<commit_message>
Deck: add plain-English 'how to read the results' cheat-sheet slide
Co-Authored-By: Claude Opus 4.8 <noreply@anthropic.com>
</commit_message>
<xml_diff>
--- a/slides/HROC_Carp_Update_Animal9.pptx
+++ b/slides/HROC_Carp_Update_Animal9.pptx
@@ -19,9 +19,10 @@
     <p:sldId id="267" r:id="rId13"/>
     <p:sldId id="268" r:id="rId14"/>
     <p:sldId id="269" r:id="rId15"/>
+    <p:sldId id="270" r:id="rId16"/>
   </p:sldIdLst>
   <p:notesMasterIdLst>
-    <p:notesMasterId r:id="rId16"/>
+    <p:notesMasterId r:id="rId17"/>
   </p:notesMasterIdLst>
   <p:sldSz cx="12192000" cy="6858000"/>
   <p:notesSz cx="6858000" cy="12192000"/>
@@ -603,7 +604,7 @@
           <a:p>
             <a:r>
               <a:rPr lang="en-US" dirty="0"/>
-              <a:t>This is the research question in one picture. Each phase's average cortical fingerprint, distance from baseline. It climbs sharply during down-conditioning and returns toward baseline afterward. The brain representation shifts as the cord learns and partly recovers when training stops. On a clean dataset, this figure is the paper. But — next slide — there's a confound to resolve first.</a:t>
+              <a:t>Here's the test that makes the fingerprint trustworthy. Freeze the model, ask a tiny predictor to read the H-reflex off the fingerprint. R-squared 0.17 on real cortex. The green line climbing is it getting better at reading the reflex. It's far below the synthetic 0.90 — but that's expected and honest: the synthetic ECoG was built to encode the reflex; real cortex is far noisier. 0.17 with zero labels during learning is a genuine signal.</a:t>
             </a:r>
             <a:endParaRPr lang="en-US" dirty="0"/>
           </a:p>
@@ -691,7 +692,7 @@
           <a:p>
             <a:r>
               <a:rPr lang="en-US" dirty="0"/>
-              <a:t>I want to be upfront. The H-reflex is HIGHER during down-conditioning, which is backwards — down-conditioning should shrink it. The likely reason: the 'Baseline' block is really the setup/characterization period, where the stimulus intensity is still being tuned (the log is full of TARG adjustments). So the cortical drift might partly reflect overall session state rather than the learning. This is the single most important thing to nail down before we call it a cortical correlate of conditioning — and it's exactly where I need your input.</a:t>
+              <a:t>This is the research question in one picture. Each phase's average cortical fingerprint, distance from baseline. It climbs sharply during down-conditioning and returns toward baseline afterward. The brain representation shifts as the cord learns and partly recovers when training stops. On a clean dataset, this figure is the paper. But — next slide — there's a confound to resolve first.</a:t>
             </a:r>
             <a:endParaRPr lang="en-US" dirty="0"/>
           </a:p>
@@ -779,7 +780,7 @@
           <a:p>
             <a:r>
               <a:rPr lang="en-US" dirty="0"/>
-              <a:t>My honest read: the infrastructure is the big win — real data end to end, reproducible, and it was genuinely the hard part. The first signal is promising, above chance, with a visible drift. But it's not yet a claim: the confound, statistics, and more animals stand between us and a result. Strong foundation, honest about where it sits.</a:t>
+              <a:t>I want to be upfront. The H-reflex is HIGHER during down-conditioning, which is backwards — down-conditioning should shrink it. The likely reason: the 'Baseline' block is really the setup/characterization period, where the stimulus intensity is still being tuned (the log is full of TARG adjustments). So the cortical drift might partly reflect overall session state rather than the learning. This is the single most important thing to nail down before we call it a cortical correlate of conditioning — and it's exactly where I need your input.</a:t>
             </a:r>
             <a:endParaRPr lang="en-US" dirty="0"/>
           </a:p>
@@ -867,7 +868,7 @@
           <a:p>
             <a:r>
               <a:rPr lang="en-US" dirty="0"/>
-              <a:t>The plan, and why it scales. Near term: resolve the baseline confound and add real statistics to the drift. Then the leverage — there are ~14 conditioned animals in the Drive. The pipeline pools them, so each one sharpens the result. And up-conditioning and freely-running animals are natural controls: they should drift in the opposite direction, or barely at all. That's how we turn today's foundation into a claim.</a:t>
+              <a:t>My honest read: the infrastructure is the big win — real data end to end, reproducible, and it was genuinely the hard part. The first signal is promising, above chance, with a visible drift. But it's not yet a claim: the confound, statistics, and more animals stand between us and a result. Strong foundation, honest about where it sits.</a:t>
             </a:r>
             <a:endParaRPr lang="en-US" dirty="0"/>
           </a:p>
@@ -955,7 +956,7 @@
           <a:p>
             <a:r>
               <a:rPr lang="en-US" dirty="0"/>
-              <a:t>Hand the conversation over. The two that actually block me are the first two: how to define a clean baseline given the setup confound, and confirming the H-reflex label. Then the bigger-picture ones: what controls would convince you it's real, and which animals to prioritize. Everything's on GitHub for you and Tarun.</a:t>
+              <a:t>The plan, and why it scales. Near term: resolve the baseline confound and add real statistics to the drift. Then the leverage — there are ~14 conditioned animals in the Drive. The pipeline pools them, so each one sharpens the result. And up-conditioning and freely-running animals are natural controls: they should drift in the opposite direction, or barely at all. That's how we turn today's foundation into a claim.</a:t>
             </a:r>
             <a:endParaRPr lang="en-US" dirty="0"/>
           </a:p>
@@ -979,6 +980,94 @@
             <a:fld id="{F7021451-1387-4CA6-816F-3879F97B5CBC}" type="slidenum">
               <a:rPr lang="en-US"/>
               <a:t>14</a:t>
+            </a:fld>
+            <a:endParaRPr lang="en-US"/>
+          </a:p>
+        </p:txBody>
+      </p:sp>
+    </p:spTree>
+    <p:extLst>
+      <p:ext uri="{BB962C8B-B14F-4D97-AF65-F5344CB8AC3E}">
+        <p14:creationId xmlns:p14="http://schemas.microsoft.com/office/powerpoint/2010/main" val="1024086991"/>
+      </p:ext>
+    </p:extLst>
+  </p:cSld>
+  <p:clrMapOvr>
+    <a:masterClrMapping/>
+  </p:clrMapOvr>
+</p:notes>
+</file>
+
+<file path=ppt/notesSlides/notesSlide15.xml><?xml version="1.0" encoding="utf-8"?>
+<p:notes xmlns:a="http://schemas.openxmlformats.org/drawingml/2006/main" xmlns:r="http://schemas.openxmlformats.org/officeDocument/2006/relationships" xmlns:p="http://schemas.openxmlformats.org/presentationml/2006/main">
+  <p:cSld>
+    <p:spTree>
+      <p:nvGrpSpPr>
+        <p:cNvPr id="1" name=""/>
+        <p:cNvGrpSpPr/>
+        <p:nvPr/>
+      </p:nvGrpSpPr>
+      <p:grpSpPr>
+        <a:xfrm>
+          <a:off x="0" y="0"/>
+          <a:ext cx="0" cy="0"/>
+          <a:chOff x="0" y="0"/>
+          <a:chExt cx="0" cy="0"/>
+        </a:xfrm>
+      </p:grpSpPr>
+      <p:sp>
+        <p:nvSpPr>
+          <p:cNvPr id="2" name="Slide Image Placeholder 1"/>
+          <p:cNvSpPr>
+            <a:spLocks noGrp="1" noRot="1" noChangeAspect="1"/>
+          </p:cNvSpPr>
+          <p:nvPr>
+            <p:ph type="sldImg"/>
+          </p:nvPr>
+        </p:nvSpPr>
+        <p:spPr/>
+      </p:sp>
+      <p:sp>
+        <p:nvSpPr>
+          <p:cNvPr id="3" name="Notes Placeholder 2"/>
+          <p:cNvSpPr>
+            <a:spLocks noGrp="1"/>
+          </p:cNvSpPr>
+          <p:nvPr>
+            <p:ph type="body" idx="1"/>
+          </p:nvPr>
+        </p:nvSpPr>
+        <p:spPr/>
+        <p:txBody>
+          <a:bodyPr/>
+          <a:lstStyle/>
+          <a:p>
+            <a:r>
+              <a:rPr lang="en-US" dirty="0"/>
+              <a:t>Hand the conversation over. The two that actually block me are the first two: how to define a clean baseline given the setup confound, and confirming the H-reflex label. Then the bigger-picture ones: what controls would convince you it's real, and which animals to prioritize. Everything's on GitHub for you and Tarun.</a:t>
+            </a:r>
+            <a:endParaRPr lang="en-US" dirty="0"/>
+          </a:p>
+        </p:txBody>
+      </p:sp>
+      <p:sp>
+        <p:nvSpPr>
+          <p:cNvPr id="4" name="Slide Number Placeholder 3"/>
+          <p:cNvSpPr>
+            <a:spLocks noGrp="1"/>
+          </p:cNvSpPr>
+          <p:nvPr>
+            <p:ph type="sldNum" sz="quarter" idx="10"/>
+          </p:nvPr>
+        </p:nvSpPr>
+        <p:spPr/>
+        <p:txBody>
+          <a:bodyPr/>
+          <a:lstStyle/>
+          <a:p>
+            <a:fld id="{F7021451-1387-4CA6-816F-3879F97B5CBC}" type="slidenum">
+              <a:rPr lang="en-US"/>
+              <a:t>15</a:t>
             </a:fld>
             <a:endParaRPr lang="en-US"/>
           </a:p>
@@ -1659,7 +1748,7 @@
           <a:p>
             <a:r>
               <a:rPr lang="en-US" dirty="0"/>
-              <a:t>Here's the test that makes the fingerprint trustworthy. Freeze the model, ask a tiny predictor to read the H-reflex off the fingerprint. R-squared 0.17 on real cortex. The green line climbing is it getting better at reading the reflex. It's far below the synthetic 0.90 — but that's expected and honest: the synthetic ECoG was built to encode the reflex; real cortex is far noisier. 0.17 with zero labels during learning is a genuine signal.</a:t>
+              <a:t>Quick cheat sheet before the results. Fingerprint = the model's self-invented 48-number summary of the brain signal. R-squared = how much of the reflex it can explain, 0 to 1, we get 0.17. Drift = how far the average brain state moved from baseline. And the catch: some of that drift might be recording-setup, not learning. Keep these four in mind for the next three slides.</a:t>
             </a:r>
             <a:endParaRPr lang="en-US" dirty="0"/>
           </a:p>
@@ -2328,13 +2417,13 @@
             <a:r>
               <a:rPr lang="en-US" sz="1250" b="1" spc="300" kern="0" dirty="0">
                 <a:solidFill>
-                  <a:srgbClr val="6D28D9"/>
-                </a:solidFill>
-                <a:latin typeface="Calibri" pitchFamily="34" charset="0"/>
-                <a:ea typeface="Calibri" pitchFamily="34" charset="-122"/>
-                <a:cs typeface="Calibri" pitchFamily="34" charset="-120"/>
-              </a:rPr>
-              <a:t>RESULT 2 · THE HEADLINE</a:t>
+                  <a:srgbClr val="0D9488"/>
+                </a:solidFill>
+                <a:latin typeface="Calibri" pitchFamily="34" charset="0"/>
+                <a:ea typeface="Calibri" pitchFamily="34" charset="-122"/>
+                <a:cs typeface="Calibri" pitchFamily="34" charset="-120"/>
+              </a:rPr>
+              <a:t>RESULT 1</a:t>
             </a:r>
             <a:endParaRPr lang="en-US" sz="1250" dirty="0"/>
           </a:p>
@@ -2373,7 +2462,7 @@
                 <a:ea typeface="Cambria" pitchFamily="34" charset="-122"/>
                 <a:cs typeface="Cambria" pitchFamily="34" charset="-120"/>
               </a:rPr>
-              <a:t>The cortical fingerprint drifts as the cord learns</a:t>
+              <a:t>The fingerprint really does carry the reflex</a:t>
             </a:r>
             <a:endParaRPr lang="en-US" sz="3000" dirty="0"/>
           </a:p>
@@ -2381,7 +2470,7 @@
       </p:sp>
       <p:pic>
         <p:nvPicPr>
-          <p:cNvPr id="4" name="Image 0" descr="outputs/centroid_drift.png">    </p:cNvPr>
+          <p:cNvPr id="4" name="Image 0" descr="outputs/phase2_loss.png">    </p:cNvPr>
           <p:cNvPicPr>
             <a:picLocks noChangeAspect="1"/>
           </p:cNvPicPr>
@@ -2394,8 +2483,8 @@
         </p:blipFill>
         <p:spPr>
           <a:xfrm>
-            <a:off x="640080" y="1783080"/>
-            <a:ext cx="5998464" cy="3749040"/>
+            <a:off x="640080" y="1828800"/>
+            <a:ext cx="5563210" cy="3566160"/>
           </a:xfrm>
           <a:prstGeom prst="rect">
             <a:avLst/>
@@ -2410,16 +2499,16 @@
         </p:nvSpPr>
         <p:spPr>
           <a:xfrm>
-            <a:off x="7680960" y="1920240"/>
-            <a:ext cx="3840480" cy="3931920"/>
+            <a:off x="7040880" y="1920240"/>
+            <a:ext cx="4480560" cy="1874520"/>
           </a:xfrm>
           <a:prstGeom prst="roundRect">
             <a:avLst>
-              <a:gd name="adj" fmla="val 2143"/>
+              <a:gd name="adj" fmla="val 4390"/>
             </a:avLst>
           </a:prstGeom>
           <a:solidFill>
-            <a:srgbClr val="F5F3FF"/>
+            <a:srgbClr val="F1F5F9"/>
           </a:solidFill>
           <a:ln w="12700">
             <a:solidFill>
@@ -2444,34 +2533,34 @@
         </p:nvSpPr>
         <p:spPr>
           <a:xfrm>
-            <a:off x="7909560" y="2148840"/>
-            <a:ext cx="3383280" cy="320040"/>
-          </a:xfrm>
-          <a:prstGeom prst="rect">
-            <a:avLst/>
-          </a:prstGeom>
-          <a:noFill/>
-          <a:ln/>
-        </p:spPr>
-        <p:txBody>
-          <a:bodyPr wrap="square" lIns="0" tIns="0" rIns="0" bIns="0" rtlCol="0" anchor="ctr"/>
-          <a:lstStyle/>
-          <a:p>
-            <a:pPr indent="0" marL="0">
-              <a:buNone/>
-            </a:pPr>
-            <a:r>
-              <a:rPr lang="en-US" sz="1400" b="1" dirty="0">
-                <a:solidFill>
-                  <a:srgbClr val="6D28D9"/>
-                </a:solidFill>
-                <a:latin typeface="Calibri" pitchFamily="34" charset="0"/>
-                <a:ea typeface="Calibri" pitchFamily="34" charset="-122"/>
-                <a:cs typeface="Calibri" pitchFamily="34" charset="-120"/>
-              </a:rPr>
-              <a:t>What you're seeing</a:t>
-            </a:r>
-            <a:endParaRPr lang="en-US" sz="1400" dirty="0"/>
+            <a:off x="7040880" y="2084832"/>
+            <a:ext cx="4480560" cy="868680"/>
+          </a:xfrm>
+          <a:prstGeom prst="rect">
+            <a:avLst/>
+          </a:prstGeom>
+          <a:noFill/>
+          <a:ln/>
+        </p:spPr>
+        <p:txBody>
+          <a:bodyPr wrap="square" lIns="0" tIns="0" rIns="0" bIns="0" rtlCol="0" anchor="ctr"/>
+          <a:lstStyle/>
+          <a:p>
+            <a:pPr algn="ctr" indent="0" marL="0">
+              <a:buNone/>
+            </a:pPr>
+            <a:r>
+              <a:rPr lang="en-US" sz="4600" b="1" dirty="0">
+                <a:solidFill>
+                  <a:srgbClr val="0D9488"/>
+                </a:solidFill>
+                <a:latin typeface="Cambria" pitchFamily="34" charset="0"/>
+                <a:ea typeface="Cambria" pitchFamily="34" charset="-122"/>
+                <a:cs typeface="Cambria" pitchFamily="34" charset="-120"/>
+              </a:rPr>
+              <a:t>R² = 0.17</a:t>
+            </a:r>
+            <a:endParaRPr lang="en-US" sz="4600" dirty="0"/>
           </a:p>
         </p:txBody>
       </p:sp>
@@ -2483,8 +2572,47 @@
         </p:nvSpPr>
         <p:spPr>
           <a:xfrm>
-            <a:off x="7909560" y="2560320"/>
-            <a:ext cx="3429000" cy="914400"/>
+            <a:off x="7040880" y="2971800"/>
+            <a:ext cx="4480560" cy="640080"/>
+          </a:xfrm>
+          <a:prstGeom prst="rect">
+            <a:avLst/>
+          </a:prstGeom>
+          <a:noFill/>
+          <a:ln/>
+        </p:spPr>
+        <p:txBody>
+          <a:bodyPr wrap="square" lIns="0" tIns="0" rIns="0" bIns="0" rtlCol="0" anchor="ctr"/>
+          <a:lstStyle/>
+          <a:p>
+            <a:pPr algn="ctr" indent="0" marL="0">
+              <a:buNone/>
+            </a:pPr>
+            <a:r>
+              <a:rPr lang="en-US" sz="1350" dirty="0">
+                <a:solidFill>
+                  <a:srgbClr val="64748B"/>
+                </a:solidFill>
+                <a:latin typeface="Calibri" pitchFamily="34" charset="0"/>
+                <a:ea typeface="Calibri" pitchFamily="34" charset="-122"/>
+                <a:cs typeface="Calibri" pitchFamily="34" charset="-120"/>
+              </a:rPr>
+              <a:t>brain fingerprint → H-reflex, frozen encoder</a:t>
+            </a:r>
+            <a:endParaRPr lang="en-US" sz="1350" dirty="0"/>
+          </a:p>
+        </p:txBody>
+      </p:sp>
+      <p:sp>
+        <p:nvSpPr>
+          <p:cNvPr id="8" name="Text 5"/>
+          <p:cNvSpPr/>
+          <p:nvPr/>
+        </p:nvSpPr>
+        <p:spPr>
+          <a:xfrm>
+            <a:off x="7040880" y="3977640"/>
+            <a:ext cx="4480560" cy="1371600"/>
           </a:xfrm>
           <a:prstGeom prst="rect">
             <a:avLst/>
@@ -2503,7 +2631,7 @@
               <a:buNone/>
             </a:pPr>
             <a:r>
-              <a:rPr lang="en-US" sz="1450" dirty="0">
+              <a:rPr lang="en-US" sz="1450" b="1" dirty="0">
                 <a:solidFill>
                   <a:srgbClr val="1E293B"/>
                 </a:solidFill>
@@ -2511,75 +2639,8 @@
                 <a:ea typeface="Calibri" pitchFamily="34" charset="-122"/>
                 <a:cs typeface="Calibri" pitchFamily="34" charset="-120"/>
               </a:rPr>
-              <a:t>Each point = how far that phase's average brain fingerprint sits from Baseline.</a:t>
-            </a:r>
-            <a:endParaRPr lang="en-US" sz="1450" dirty="0"/>
-          </a:p>
-        </p:txBody>
-      </p:sp>
-      <p:sp>
-        <p:nvSpPr>
-          <p:cNvPr id="8" name="Text 5"/>
-          <p:cNvSpPr/>
-          <p:nvPr/>
-        </p:nvSpPr>
-        <p:spPr>
-          <a:xfrm>
-            <a:off x="7909560" y="3611880"/>
-            <a:ext cx="3429000" cy="1280160"/>
-          </a:xfrm>
-          <a:prstGeom prst="rect">
-            <a:avLst/>
-          </a:prstGeom>
-          <a:noFill/>
-          <a:ln/>
-        </p:spPr>
-        <p:txBody>
-          <a:bodyPr wrap="square" lIns="0" tIns="0" rIns="0" bIns="0" rtlCol="0" anchor="ctr"/>
-          <a:lstStyle/>
-          <a:p>
-            <a:pPr indent="0" marL="0">
-              <a:lnSpc>
-                <a:spcPct val="108000"/>
-              </a:lnSpc>
-              <a:buNone/>
-            </a:pPr>
-            <a:r>
-              <a:rPr lang="en-US" sz="1500" b="1" dirty="0">
-                <a:solidFill>
-                  <a:srgbClr val="1E293B"/>
-                </a:solidFill>
-                <a:latin typeface="Calibri" pitchFamily="34" charset="0"/>
-                <a:ea typeface="Calibri" pitchFamily="34" charset="-122"/>
-                <a:cs typeface="Calibri" pitchFamily="34" charset="-120"/>
-              </a:rPr>
-              <a:t>It jumps to 28.5 during down-conditioning, then falls back to 5.0 once conditioning stops.</a:t>
-            </a:r>
-            <a:endParaRPr lang="en-US" sz="1500" dirty="0"/>
-          </a:p>
-        </p:txBody>
-      </p:sp>
-      <p:sp>
-        <p:nvSpPr>
-          <p:cNvPr id="9" name="Text 6"/>
-          <p:cNvSpPr/>
-          <p:nvPr/>
-        </p:nvSpPr>
-        <p:spPr>
-          <a:xfrm>
-            <a:off x="7909560" y="4892040"/>
-            <a:ext cx="3429000" cy="914400"/>
-          </a:xfrm>
-          <a:prstGeom prst="rect">
-            <a:avLst/>
-          </a:prstGeom>
-          <a:noFill/>
-          <a:ln/>
-        </p:spPr>
-        <p:txBody>
-          <a:bodyPr wrap="square" lIns="0" tIns="0" rIns="0" bIns="0" rtlCol="0" anchor="ctr"/>
-          <a:lstStyle/>
-          <a:p>
+              <a:t>Read it honestly. </a:t>
+            </a:r>
             <a:pPr indent="0" marL="0">
               <a:lnSpc>
                 <a:spcPct val="105000"/>
@@ -2587,17 +2648,59 @@
               <a:buNone/>
             </a:pPr>
             <a:r>
-              <a:rPr lang="en-US" sz="1300" i="1" dirty="0">
-                <a:solidFill>
-                  <a:srgbClr val="6D28D9"/>
-                </a:solidFill>
-                <a:latin typeface="Calibri" pitchFamily="34" charset="0"/>
-                <a:ea typeface="Calibri" pitchFamily="34" charset="-122"/>
-                <a:cs typeface="Calibri" pitchFamily="34" charset="-120"/>
-              </a:rPr>
-              <a:t>The representation moves while the cord is learning — and partly recovers after. That's the effect we came to find.</a:t>
-            </a:r>
-            <a:endParaRPr lang="en-US" sz="1300" dirty="0"/>
+              <a:rPr lang="en-US" sz="1450" dirty="0">
+                <a:solidFill>
+                  <a:srgbClr val="1E293B"/>
+                </a:solidFill>
+                <a:latin typeface="Calibri" pitchFamily="34" charset="0"/>
+                <a:ea typeface="Calibri" pitchFamily="34" charset="-122"/>
+                <a:cs typeface="Calibri" pitchFamily="34" charset="-120"/>
+              </a:rPr>
+              <a:t>The cortical fingerprint predicts ~17% of the reflex's variation — with no labels during learning. Modest, but real and well above chance.</a:t>
+            </a:r>
+            <a:endParaRPr lang="en-US" sz="1450" dirty="0"/>
+          </a:p>
+        </p:txBody>
+      </p:sp>
+      <p:sp>
+        <p:nvSpPr>
+          <p:cNvPr id="9" name="Text 6"/>
+          <p:cNvSpPr/>
+          <p:nvPr/>
+        </p:nvSpPr>
+        <p:spPr>
+          <a:xfrm>
+            <a:off x="7040880" y="5440680"/>
+            <a:ext cx="4480560" cy="822960"/>
+          </a:xfrm>
+          <a:prstGeom prst="rect">
+            <a:avLst/>
+          </a:prstGeom>
+          <a:noFill/>
+          <a:ln/>
+        </p:spPr>
+        <p:txBody>
+          <a:bodyPr wrap="square" lIns="0" tIns="0" rIns="0" bIns="0" rtlCol="0" anchor="ctr"/>
+          <a:lstStyle/>
+          <a:p>
+            <a:pPr indent="0" marL="0">
+              <a:lnSpc>
+                <a:spcPct val="103000"/>
+              </a:lnSpc>
+              <a:buNone/>
+            </a:pPr>
+            <a:r>
+              <a:rPr lang="en-US" sz="1250" i="1" dirty="0">
+                <a:solidFill>
+                  <a:srgbClr val="D97706"/>
+                </a:solidFill>
+                <a:latin typeface="Calibri" pitchFamily="34" charset="0"/>
+                <a:ea typeface="Calibri" pitchFamily="34" charset="-122"/>
+                <a:cs typeface="Calibri" pitchFamily="34" charset="-120"/>
+              </a:rPr>
+              <a:t>On synthetic data this was 0.90 — only because that data was built to encode the reflex. 0.17 is the real cortex.</a:t>
+            </a:r>
+            <a:endParaRPr lang="en-US" sz="1250" dirty="0"/>
           </a:p>
         </p:txBody>
       </p:sp>
@@ -2660,13 +2763,13 @@
             <a:r>
               <a:rPr lang="en-US" sz="1250" b="1" spc="300" kern="0" dirty="0">
                 <a:solidFill>
-                  <a:srgbClr val="D97706"/>
-                </a:solidFill>
-                <a:latin typeface="Calibri" pitchFamily="34" charset="0"/>
-                <a:ea typeface="Calibri" pitchFamily="34" charset="-122"/>
-                <a:cs typeface="Calibri" pitchFamily="34" charset="-120"/>
-              </a:rPr>
-              <a:t>THE HONEST CAVEAT — READ THIS</a:t>
+                  <a:srgbClr val="6D28D9"/>
+                </a:solidFill>
+                <a:latin typeface="Calibri" pitchFamily="34" charset="0"/>
+                <a:ea typeface="Calibri" pitchFamily="34" charset="-122"/>
+                <a:cs typeface="Calibri" pitchFamily="34" charset="-120"/>
+              </a:rPr>
+              <a:t>RESULT 2 · THE HEADLINE</a:t>
             </a:r>
             <a:endParaRPr lang="en-US" sz="1250" dirty="0"/>
           </a:p>
@@ -2705,7 +2808,7 @@
                 <a:ea typeface="Cambria" pitchFamily="34" charset="-122"/>
                 <a:cs typeface="Cambria" pitchFamily="34" charset="-120"/>
               </a:rPr>
-              <a:t>Is the drift learning, or just session state?</a:t>
+              <a:t>The cortical fingerprint drifts as the cord learns</a:t>
             </a:r>
             <a:endParaRPr lang="en-US" sz="3000" dirty="0"/>
           </a:p>
@@ -2713,7 +2816,7 @@
       </p:sp>
       <p:pic>
         <p:nvPicPr>
-          <p:cNvPr id="4" name="Image 0" descr="outputs/hreflex_by_phase.png">    </p:cNvPr>
+          <p:cNvPr id="4" name="Image 0" descr="outputs/centroid_drift.png">    </p:cNvPr>
           <p:cNvPicPr>
             <a:picLocks noChangeAspect="1"/>
           </p:cNvPicPr>
@@ -2726,8 +2829,8 @@
         </p:blipFill>
         <p:spPr>
           <a:xfrm>
-            <a:off x="640080" y="1828800"/>
-            <a:ext cx="5705856" cy="3566160"/>
+            <a:off x="640080" y="1783080"/>
+            <a:ext cx="5998464" cy="3749040"/>
           </a:xfrm>
           <a:prstGeom prst="rect">
             <a:avLst/>
@@ -2742,16 +2845,16 @@
         </p:nvSpPr>
         <p:spPr>
           <a:xfrm>
-            <a:off x="6858000" y="1920240"/>
-            <a:ext cx="4663440" cy="3977640"/>
+            <a:off x="7680960" y="1920240"/>
+            <a:ext cx="3840480" cy="3931920"/>
           </a:xfrm>
           <a:prstGeom prst="roundRect">
             <a:avLst>
-              <a:gd name="adj" fmla="val 2069"/>
+              <a:gd name="adj" fmla="val 2143"/>
             </a:avLst>
           </a:prstGeom>
           <a:solidFill>
-            <a:srgbClr val="FEF3E2"/>
+            <a:srgbClr val="F5F3FF"/>
           </a:solidFill>
           <a:ln w="12700">
             <a:solidFill>
@@ -2776,8 +2879,8 @@
         </p:nvSpPr>
         <p:spPr>
           <a:xfrm>
-            <a:off x="7086600" y="2148840"/>
-            <a:ext cx="4206240" cy="320040"/>
+            <a:off x="7909560" y="2148840"/>
+            <a:ext cx="3383280" cy="320040"/>
           </a:xfrm>
           <a:prstGeom prst="rect">
             <a:avLst/>
@@ -2795,13 +2898,13 @@
             <a:r>
               <a:rPr lang="en-US" sz="1400" b="1" dirty="0">
                 <a:solidFill>
-                  <a:srgbClr val="D97706"/>
-                </a:solidFill>
-                <a:latin typeface="Calibri" pitchFamily="34" charset="0"/>
-                <a:ea typeface="Calibri" pitchFamily="34" charset="-122"/>
-                <a:cs typeface="Calibri" pitchFamily="34" charset="-120"/>
-              </a:rPr>
-              <a:t>The problem</a:t>
+                  <a:srgbClr val="6D28D9"/>
+                </a:solidFill>
+                <a:latin typeface="Calibri" pitchFamily="34" charset="0"/>
+                <a:ea typeface="Calibri" pitchFamily="34" charset="-122"/>
+                <a:cs typeface="Calibri" pitchFamily="34" charset="-120"/>
+              </a:rPr>
+              <a:t>What you're seeing</a:t>
             </a:r>
             <a:endParaRPr lang="en-US" sz="1400" dirty="0"/>
           </a:p>
@@ -2815,8 +2918,8 @@
         </p:nvSpPr>
         <p:spPr>
           <a:xfrm>
-            <a:off x="7086600" y="2542032"/>
-            <a:ext cx="4251960" cy="1051560"/>
+            <a:off x="7909560" y="2560320"/>
+            <a:ext cx="3429000" cy="914400"/>
           </a:xfrm>
           <a:prstGeom prst="rect">
             <a:avLst/>
@@ -2843,7 +2946,7 @@
                 <a:ea typeface="Calibri" pitchFamily="34" charset="-122"/>
                 <a:cs typeface="Calibri" pitchFamily="34" charset="-120"/>
               </a:rPr>
-              <a:t>Down-conditioning should make the H-reflex SMALLER. But in the data it's larger during down-conditioning than at Baseline.</a:t>
+              <a:t>Each point = how far that phase's average brain fingerprint sits from Baseline.</a:t>
             </a:r>
             <a:endParaRPr lang="en-US" sz="1450" dirty="0"/>
           </a:p>
@@ -2857,24 +2960,27 @@
         </p:nvSpPr>
         <p:spPr>
           <a:xfrm>
-            <a:off x="7086600" y="3611880"/>
-            <a:ext cx="4206240" cy="320040"/>
-          </a:xfrm>
-          <a:prstGeom prst="rect">
-            <a:avLst/>
-          </a:prstGeom>
-          <a:noFill/>
-          <a:ln/>
-        </p:spPr>
-        <p:txBody>
-          <a:bodyPr wrap="square" lIns="0" tIns="0" rIns="0" bIns="0" rtlCol="0" anchor="ctr"/>
-          <a:lstStyle/>
-          <a:p>
-            <a:pPr indent="0" marL="0">
-              <a:buNone/>
-            </a:pPr>
-            <a:r>
-              <a:rPr lang="en-US" sz="1400" b="1" dirty="0">
+            <a:off x="7909560" y="3611880"/>
+            <a:ext cx="3429000" cy="1280160"/>
+          </a:xfrm>
+          <a:prstGeom prst="rect">
+            <a:avLst/>
+          </a:prstGeom>
+          <a:noFill/>
+          <a:ln/>
+        </p:spPr>
+        <p:txBody>
+          <a:bodyPr wrap="square" lIns="0" tIns="0" rIns="0" bIns="0" rtlCol="0" anchor="ctr"/>
+          <a:lstStyle/>
+          <a:p>
+            <a:pPr indent="0" marL="0">
+              <a:lnSpc>
+                <a:spcPct val="108000"/>
+              </a:lnSpc>
+              <a:buNone/>
+            </a:pPr>
+            <a:r>
+              <a:rPr lang="en-US" sz="1500" b="1" dirty="0">
                 <a:solidFill>
                   <a:srgbClr val="1E293B"/>
                 </a:solidFill>
@@ -2882,9 +2988,9 @@
                 <a:ea typeface="Calibri" pitchFamily="34" charset="-122"/>
                 <a:cs typeface="Calibri" pitchFamily="34" charset="-120"/>
               </a:rPr>
-              <a:t>Most likely why:</a:t>
-            </a:r>
-            <a:endParaRPr lang="en-US" sz="1400" dirty="0"/>
+              <a:t>It jumps to 28.5 during down-conditioning, then falls back to 5.0 once conditioning stops.</a:t>
+            </a:r>
+            <a:endParaRPr lang="en-US" sz="1500" dirty="0"/>
           </a:p>
         </p:txBody>
       </p:sp>
@@ -2896,8 +3002,8 @@
         </p:nvSpPr>
         <p:spPr>
           <a:xfrm>
-            <a:off x="7086600" y="3977640"/>
-            <a:ext cx="4251960" cy="1051560"/>
+            <a:off x="7909560" y="4892040"/>
+            <a:ext cx="3429000" cy="914400"/>
           </a:xfrm>
           <a:prstGeom prst="rect">
             <a:avLst/>
@@ -2916,59 +3022,17 @@
               <a:buNone/>
             </a:pPr>
             <a:r>
-              <a:rPr lang="en-US" sz="1400" dirty="0">
-                <a:solidFill>
-                  <a:srgbClr val="1E293B"/>
-                </a:solidFill>
-                <a:latin typeface="Calibri" pitchFamily="34" charset="0"/>
-                <a:ea typeface="Calibri" pitchFamily="34" charset="-122"/>
-                <a:cs typeface="Calibri" pitchFamily="34" charset="-120"/>
-              </a:rPr>
-              <a:t>our 'Baseline' is really the setup period — the log shows the stimulus being constantly re-tuned, so responses there are smaller and inconsistent.</a:t>
-            </a:r>
-            <a:endParaRPr lang="en-US" sz="1400" dirty="0"/>
-          </a:p>
-        </p:txBody>
-      </p:sp>
-      <p:sp>
-        <p:nvSpPr>
-          <p:cNvPr id="10" name="Text 7"/>
-          <p:cNvSpPr/>
-          <p:nvPr/>
-        </p:nvSpPr>
-        <p:spPr>
-          <a:xfrm>
-            <a:off x="7086600" y="5029200"/>
-            <a:ext cx="4251960" cy="822960"/>
-          </a:xfrm>
-          <a:prstGeom prst="rect">
-            <a:avLst/>
-          </a:prstGeom>
-          <a:noFill/>
-          <a:ln/>
-        </p:spPr>
-        <p:txBody>
-          <a:bodyPr wrap="square" lIns="0" tIns="0" rIns="0" bIns="0" rtlCol="0" anchor="ctr"/>
-          <a:lstStyle/>
-          <a:p>
-            <a:pPr indent="0" marL="0">
-              <a:lnSpc>
-                <a:spcPct val="103000"/>
-              </a:lnSpc>
-              <a:buNone/>
-            </a:pPr>
-            <a:r>
-              <a:rPr lang="en-US" sz="1250" b="1" i="1" dirty="0">
-                <a:solidFill>
-                  <a:srgbClr val="D97706"/>
-                </a:solidFill>
-                <a:latin typeface="Calibri" pitchFamily="34" charset="0"/>
-                <a:ea typeface="Calibri" pitchFamily="34" charset="-122"/>
-                <a:cs typeface="Calibri" pitchFamily="34" charset="-120"/>
-              </a:rPr>
-              <a:t>So part of the cortical drift may track session state (fixed-stimulus, active recording) rather than learning itself. #1 thing to resolve.</a:t>
-            </a:r>
-            <a:endParaRPr lang="en-US" sz="1250" dirty="0"/>
+              <a:rPr lang="en-US" sz="1300" i="1" dirty="0">
+                <a:solidFill>
+                  <a:srgbClr val="6D28D9"/>
+                </a:solidFill>
+                <a:latin typeface="Calibri" pitchFamily="34" charset="0"/>
+                <a:ea typeface="Calibri" pitchFamily="34" charset="-122"/>
+                <a:cs typeface="Calibri" pitchFamily="34" charset="-120"/>
+              </a:rPr>
+              <a:t>The representation moves while the cord is learning — and partly recovers after. That's the effect we came to find.</a:t>
+            </a:r>
+            <a:endParaRPr lang="en-US" sz="1300" dirty="0"/>
           </a:p>
         </p:txBody>
       </p:sp>
@@ -3031,13 +3095,13 @@
             <a:r>
               <a:rPr lang="en-US" sz="1250" b="1" spc="300" kern="0" dirty="0">
                 <a:solidFill>
-                  <a:srgbClr val="0D9488"/>
-                </a:solidFill>
-                <a:latin typeface="Calibri" pitchFamily="34" charset="0"/>
-                <a:ea typeface="Calibri" pitchFamily="34" charset="-122"/>
-                <a:cs typeface="Calibri" pitchFamily="34" charset="-120"/>
-              </a:rPr>
-              <a:t>WHERE WE STAND</a:t>
+                  <a:srgbClr val="D97706"/>
+                </a:solidFill>
+                <a:latin typeface="Calibri" pitchFamily="34" charset="0"/>
+                <a:ea typeface="Calibri" pitchFamily="34" charset="-122"/>
+                <a:cs typeface="Calibri" pitchFamily="34" charset="-120"/>
+              </a:rPr>
+              <a:t>THE HONEST CAVEAT — READ THIS</a:t>
             </a:r>
             <a:endParaRPr lang="en-US" sz="1250" dirty="0"/>
           </a:p>
@@ -3076,30 +3140,53 @@
                 <a:ea typeface="Cambria" pitchFamily="34" charset="-122"/>
                 <a:cs typeface="Cambria" pitchFamily="34" charset="-120"/>
               </a:rPr>
-              <a:t>Is this good progress? My honest scorecard</a:t>
+              <a:t>Is the drift learning, or just session state?</a:t>
             </a:r>
             <a:endParaRPr lang="en-US" sz="3000" dirty="0"/>
           </a:p>
         </p:txBody>
       </p:sp>
-      <p:sp>
-        <p:nvSpPr>
-          <p:cNvPr id="4" name="Shape 2"/>
-          <p:cNvSpPr/>
-          <p:nvPr/>
-        </p:nvSpPr>
+      <p:pic>
+        <p:nvPicPr>
+          <p:cNvPr id="4" name="Image 0" descr="outputs/hreflex_by_phase.png">    </p:cNvPr>
+          <p:cNvPicPr>
+            <a:picLocks noChangeAspect="1"/>
+          </p:cNvPicPr>
+          <p:nvPr/>
+        </p:nvPicPr>
+        <p:blipFill>
+          <a:blip r:embed="rId1"/>
+          <a:srcRect l="0" r="0" t="0" b="0"/>
+          <a:stretch/>
+        </p:blipFill>
         <p:spPr>
           <a:xfrm>
             <a:off x="640080" y="1828800"/>
-            <a:ext cx="3538728" cy="4114800"/>
+            <a:ext cx="5705856" cy="3566160"/>
+          </a:xfrm>
+          <a:prstGeom prst="rect">
+            <a:avLst/>
+          </a:prstGeom>
+        </p:spPr>
+      </p:pic>
+      <p:sp>
+        <p:nvSpPr>
+          <p:cNvPr id="5" name="Shape 2"/>
+          <p:cNvSpPr/>
+          <p:nvPr/>
+        </p:nvSpPr>
+        <p:spPr>
+          <a:xfrm>
+            <a:off x="6858000" y="1920240"/>
+            <a:ext cx="4663440" cy="3977640"/>
           </a:xfrm>
           <a:prstGeom prst="roundRect">
             <a:avLst>
-              <a:gd name="adj" fmla="val 2326"/>
+              <a:gd name="adj" fmla="val 2069"/>
             </a:avLst>
           </a:prstGeom>
           <a:solidFill>
-            <a:srgbClr val="FFFFFF"/>
+            <a:srgbClr val="FEF3E2"/>
           </a:solidFill>
           <a:ln w="12700">
             <a:solidFill>
@@ -3118,91 +3205,72 @@
       </p:sp>
       <p:sp>
         <p:nvSpPr>
-          <p:cNvPr id="5" name="Shape 3"/>
-          <p:cNvSpPr/>
-          <p:nvPr/>
-        </p:nvSpPr>
-        <p:spPr>
-          <a:xfrm>
-            <a:off x="914400" y="2103120"/>
-            <a:ext cx="1737360" cy="457200"/>
-          </a:xfrm>
-          <a:prstGeom prst="roundRect">
-            <a:avLst>
-              <a:gd name="adj" fmla="val 20000"/>
-            </a:avLst>
-          </a:prstGeom>
-          <a:solidFill>
-            <a:srgbClr val="16A34A"/>
-          </a:solidFill>
-          <a:ln/>
-        </p:spPr>
-      </p:sp>
-      <p:sp>
-        <p:nvSpPr>
-          <p:cNvPr id="6" name="Text 4"/>
-          <p:cNvSpPr/>
-          <p:nvPr/>
-        </p:nvSpPr>
-        <p:spPr>
-          <a:xfrm>
-            <a:off x="914400" y="2103120"/>
-            <a:ext cx="1737360" cy="457200"/>
-          </a:xfrm>
-          <a:prstGeom prst="rect">
-            <a:avLst/>
-          </a:prstGeom>
-          <a:noFill/>
-          <a:ln/>
-        </p:spPr>
-        <p:txBody>
-          <a:bodyPr wrap="square" lIns="0" tIns="0" rIns="0" bIns="0" rtlCol="0" anchor="ctr"/>
-          <a:lstStyle/>
-          <a:p>
-            <a:pPr algn="ctr" indent="0" marL="0">
-              <a:buNone/>
-            </a:pPr>
-            <a:r>
-              <a:rPr lang="en-US" sz="1300" b="1" spc="100" kern="0" dirty="0">
-                <a:solidFill>
-                  <a:srgbClr val="FFFFFF"/>
-                </a:solidFill>
-                <a:latin typeface="Calibri" pitchFamily="34" charset="0"/>
-                <a:ea typeface="Calibri" pitchFamily="34" charset="-122"/>
-                <a:cs typeface="Calibri" pitchFamily="34" charset="-120"/>
-              </a:rPr>
-              <a:t>STRONG</a:t>
-            </a:r>
-            <a:endParaRPr lang="en-US" sz="1300" dirty="0"/>
-          </a:p>
-        </p:txBody>
-      </p:sp>
-      <p:sp>
-        <p:nvSpPr>
-          <p:cNvPr id="7" name="Text 5"/>
-          <p:cNvSpPr/>
-          <p:nvPr/>
-        </p:nvSpPr>
-        <p:spPr>
-          <a:xfrm>
-            <a:off x="914400" y="2743200"/>
-            <a:ext cx="3017520" cy="548640"/>
-          </a:xfrm>
-          <a:prstGeom prst="rect">
-            <a:avLst/>
-          </a:prstGeom>
-          <a:noFill/>
-          <a:ln/>
-        </p:spPr>
-        <p:txBody>
-          <a:bodyPr wrap="square" lIns="0" tIns="0" rIns="0" bIns="0" rtlCol="0" anchor="ctr"/>
-          <a:lstStyle/>
-          <a:p>
-            <a:pPr indent="0" marL="0">
-              <a:buNone/>
-            </a:pPr>
-            <a:r>
-              <a:rPr lang="en-US" sz="1800" b="1" dirty="0">
+          <p:cNvPr id="6" name="Text 3"/>
+          <p:cNvSpPr/>
+          <p:nvPr/>
+        </p:nvSpPr>
+        <p:spPr>
+          <a:xfrm>
+            <a:off x="7086600" y="2148840"/>
+            <a:ext cx="4206240" cy="320040"/>
+          </a:xfrm>
+          <a:prstGeom prst="rect">
+            <a:avLst/>
+          </a:prstGeom>
+          <a:noFill/>
+          <a:ln/>
+        </p:spPr>
+        <p:txBody>
+          <a:bodyPr wrap="square" lIns="0" tIns="0" rIns="0" bIns="0" rtlCol="0" anchor="ctr"/>
+          <a:lstStyle/>
+          <a:p>
+            <a:pPr indent="0" marL="0">
+              <a:buNone/>
+            </a:pPr>
+            <a:r>
+              <a:rPr lang="en-US" sz="1400" b="1" dirty="0">
+                <a:solidFill>
+                  <a:srgbClr val="D97706"/>
+                </a:solidFill>
+                <a:latin typeface="Calibri" pitchFamily="34" charset="0"/>
+                <a:ea typeface="Calibri" pitchFamily="34" charset="-122"/>
+                <a:cs typeface="Calibri" pitchFamily="34" charset="-120"/>
+              </a:rPr>
+              <a:t>The problem</a:t>
+            </a:r>
+            <a:endParaRPr lang="en-US" sz="1400" dirty="0"/>
+          </a:p>
+        </p:txBody>
+      </p:sp>
+      <p:sp>
+        <p:nvSpPr>
+          <p:cNvPr id="7" name="Text 4"/>
+          <p:cNvSpPr/>
+          <p:nvPr/>
+        </p:nvSpPr>
+        <p:spPr>
+          <a:xfrm>
+            <a:off x="7086600" y="2542032"/>
+            <a:ext cx="4251960" cy="1051560"/>
+          </a:xfrm>
+          <a:prstGeom prst="rect">
+            <a:avLst/>
+          </a:prstGeom>
+          <a:noFill/>
+          <a:ln/>
+        </p:spPr>
+        <p:txBody>
+          <a:bodyPr wrap="square" lIns="0" tIns="0" rIns="0" bIns="0" rtlCol="0" anchor="ctr"/>
+          <a:lstStyle/>
+          <a:p>
+            <a:pPr indent="0" marL="0">
+              <a:lnSpc>
+                <a:spcPct val="105000"/>
+              </a:lnSpc>
+              <a:buNone/>
+            </a:pPr>
+            <a:r>
+              <a:rPr lang="en-US" sz="1450" dirty="0">
                 <a:solidFill>
                   <a:srgbClr val="1E293B"/>
                 </a:solidFill>
@@ -3210,22 +3278,61 @@
                 <a:ea typeface="Calibri" pitchFamily="34" charset="-122"/>
                 <a:cs typeface="Calibri" pitchFamily="34" charset="-120"/>
               </a:rPr>
-              <a:t>Infrastructure</a:t>
-            </a:r>
-            <a:endParaRPr lang="en-US" sz="1800" dirty="0"/>
-          </a:p>
-        </p:txBody>
-      </p:sp>
-      <p:sp>
-        <p:nvSpPr>
-          <p:cNvPr id="8" name="Text 6"/>
-          <p:cNvSpPr/>
-          <p:nvPr/>
-        </p:nvSpPr>
-        <p:spPr>
-          <a:xfrm>
-            <a:off x="914400" y="3383280"/>
-            <a:ext cx="3063240" cy="2286000"/>
+              <a:t>Down-conditioning should make the H-reflex SMALLER. But in the data it's larger during down-conditioning than at Baseline.</a:t>
+            </a:r>
+            <a:endParaRPr lang="en-US" sz="1450" dirty="0"/>
+          </a:p>
+        </p:txBody>
+      </p:sp>
+      <p:sp>
+        <p:nvSpPr>
+          <p:cNvPr id="8" name="Text 5"/>
+          <p:cNvSpPr/>
+          <p:nvPr/>
+        </p:nvSpPr>
+        <p:spPr>
+          <a:xfrm>
+            <a:off x="7086600" y="3611880"/>
+            <a:ext cx="4206240" cy="320040"/>
+          </a:xfrm>
+          <a:prstGeom prst="rect">
+            <a:avLst/>
+          </a:prstGeom>
+          <a:noFill/>
+          <a:ln/>
+        </p:spPr>
+        <p:txBody>
+          <a:bodyPr wrap="square" lIns="0" tIns="0" rIns="0" bIns="0" rtlCol="0" anchor="ctr"/>
+          <a:lstStyle/>
+          <a:p>
+            <a:pPr indent="0" marL="0">
+              <a:buNone/>
+            </a:pPr>
+            <a:r>
+              <a:rPr lang="en-US" sz="1400" b="1" dirty="0">
+                <a:solidFill>
+                  <a:srgbClr val="1E293B"/>
+                </a:solidFill>
+                <a:latin typeface="Calibri" pitchFamily="34" charset="0"/>
+                <a:ea typeface="Calibri" pitchFamily="34" charset="-122"/>
+                <a:cs typeface="Calibri" pitchFamily="34" charset="-120"/>
+              </a:rPr>
+              <a:t>Most likely why:</a:t>
+            </a:r>
+            <a:endParaRPr lang="en-US" sz="1400" dirty="0"/>
+          </a:p>
+        </p:txBody>
+      </p:sp>
+      <p:sp>
+        <p:nvSpPr>
+          <p:cNvPr id="9" name="Text 6"/>
+          <p:cNvSpPr/>
+          <p:nvPr/>
+        </p:nvSpPr>
+        <p:spPr>
+          <a:xfrm>
+            <a:off x="7086600" y="3977640"/>
+            <a:ext cx="4251960" cy="1051560"/>
           </a:xfrm>
           <a:prstGeom prst="rect">
             <a:avLst/>
@@ -3239,20 +3346,20 @@
           <a:p>
             <a:pPr indent="0" marL="0">
               <a:lnSpc>
-                <a:spcPct val="108000"/>
+                <a:spcPct val="105000"/>
               </a:lnSpc>
               <a:buNone/>
             </a:pPr>
             <a:r>
               <a:rPr lang="en-US" sz="1400" dirty="0">
                 <a:solidFill>
-                  <a:srgbClr val="64748B"/>
-                </a:solidFill>
-                <a:latin typeface="Calibri" pitchFamily="34" charset="0"/>
-                <a:ea typeface="Calibri" pitchFamily="34" charset="-122"/>
-                <a:cs typeface="Calibri" pitchFamily="34" charset="-120"/>
-              </a:rPr>
-              <a:t>Real data flows end to end — decode, phase labels, training, analysis. Reproducible, on a laptop. This was the hard part and it's done.</a:t>
+                  <a:srgbClr val="1E293B"/>
+                </a:solidFill>
+                <a:latin typeface="Calibri" pitchFamily="34" charset="0"/>
+                <a:ea typeface="Calibri" pitchFamily="34" charset="-122"/>
+                <a:cs typeface="Calibri" pitchFamily="34" charset="-120"/>
+              </a:rPr>
+              <a:t>our 'Baseline' is really the setup period — the log shows the stimulus being constantly re-tuned, so responses there are smaller and inconsistent.</a:t>
             </a:r>
             <a:endParaRPr lang="en-US" sz="1400" dirty="0"/>
           </a:p>
@@ -3260,148 +3367,14 @@
       </p:sp>
       <p:sp>
         <p:nvSpPr>
-          <p:cNvPr id="9" name="Shape 7"/>
-          <p:cNvSpPr/>
-          <p:nvPr/>
-        </p:nvSpPr>
-        <p:spPr>
-          <a:xfrm>
-            <a:off x="4370832" y="1828800"/>
-            <a:ext cx="3538728" cy="4114800"/>
-          </a:xfrm>
-          <a:prstGeom prst="roundRect">
-            <a:avLst>
-              <a:gd name="adj" fmla="val 2326"/>
-            </a:avLst>
-          </a:prstGeom>
-          <a:solidFill>
-            <a:srgbClr val="FFFFFF"/>
-          </a:solidFill>
-          <a:ln w="12700">
-            <a:solidFill>
-              <a:srgbClr val="E2E8F0"/>
-            </a:solidFill>
-            <a:prstDash val="solid"/>
-          </a:ln>
-          <a:effectLst>
-            <a:outerShdw sx="100000" sy="100000" kx="0" ky="0" algn="bl" rotWithShape="0" blurRad="114300" dist="38100" dir="5400000">
-              <a:srgbClr val="0F172A">
-                <a:alpha val="14000"/>
-              </a:srgbClr>
-            </a:outerShdw>
-          </a:effectLst>
-        </p:spPr>
-      </p:sp>
-      <p:sp>
-        <p:nvSpPr>
-          <p:cNvPr id="10" name="Shape 8"/>
-          <p:cNvSpPr/>
-          <p:nvPr/>
-        </p:nvSpPr>
-        <p:spPr>
-          <a:xfrm>
-            <a:off x="4645152" y="2103120"/>
-            <a:ext cx="1737360" cy="457200"/>
-          </a:xfrm>
-          <a:prstGeom prst="roundRect">
-            <a:avLst>
-              <a:gd name="adj" fmla="val 20000"/>
-            </a:avLst>
-          </a:prstGeom>
-          <a:solidFill>
-            <a:srgbClr val="0D9488"/>
-          </a:solidFill>
-          <a:ln/>
-        </p:spPr>
-      </p:sp>
-      <p:sp>
-        <p:nvSpPr>
-          <p:cNvPr id="11" name="Text 9"/>
-          <p:cNvSpPr/>
-          <p:nvPr/>
-        </p:nvSpPr>
-        <p:spPr>
-          <a:xfrm>
-            <a:off x="4645152" y="2103120"/>
-            <a:ext cx="1737360" cy="457200"/>
-          </a:xfrm>
-          <a:prstGeom prst="rect">
-            <a:avLst/>
-          </a:prstGeom>
-          <a:noFill/>
-          <a:ln/>
-        </p:spPr>
-        <p:txBody>
-          <a:bodyPr wrap="square" lIns="0" tIns="0" rIns="0" bIns="0" rtlCol="0" anchor="ctr"/>
-          <a:lstStyle/>
-          <a:p>
-            <a:pPr algn="ctr" indent="0" marL="0">
-              <a:buNone/>
-            </a:pPr>
-            <a:r>
-              <a:rPr lang="en-US" sz="1300" b="1" spc="100" kern="0" dirty="0">
-                <a:solidFill>
-                  <a:srgbClr val="FFFFFF"/>
-                </a:solidFill>
-                <a:latin typeface="Calibri" pitchFamily="34" charset="0"/>
-                <a:ea typeface="Calibri" pitchFamily="34" charset="-122"/>
-                <a:cs typeface="Calibri" pitchFamily="34" charset="-120"/>
-              </a:rPr>
-              <a:t>PROMISING</a:t>
-            </a:r>
-            <a:endParaRPr lang="en-US" sz="1300" dirty="0"/>
-          </a:p>
-        </p:txBody>
-      </p:sp>
-      <p:sp>
-        <p:nvSpPr>
-          <p:cNvPr id="12" name="Text 10"/>
-          <p:cNvSpPr/>
-          <p:nvPr/>
-        </p:nvSpPr>
-        <p:spPr>
-          <a:xfrm>
-            <a:off x="4645152" y="2743200"/>
-            <a:ext cx="3017520" cy="548640"/>
-          </a:xfrm>
-          <a:prstGeom prst="rect">
-            <a:avLst/>
-          </a:prstGeom>
-          <a:noFill/>
-          <a:ln/>
-        </p:spPr>
-        <p:txBody>
-          <a:bodyPr wrap="square" lIns="0" tIns="0" rIns="0" bIns="0" rtlCol="0" anchor="ctr"/>
-          <a:lstStyle/>
-          <a:p>
-            <a:pPr indent="0" marL="0">
-              <a:buNone/>
-            </a:pPr>
-            <a:r>
-              <a:rPr lang="en-US" sz="1800" b="1" dirty="0">
-                <a:solidFill>
-                  <a:srgbClr val="1E293B"/>
-                </a:solidFill>
-                <a:latin typeface="Calibri" pitchFamily="34" charset="0"/>
-                <a:ea typeface="Calibri" pitchFamily="34" charset="-122"/>
-                <a:cs typeface="Calibri" pitchFamily="34" charset="-120"/>
-              </a:rPr>
-              <a:t>First real signal</a:t>
-            </a:r>
-            <a:endParaRPr lang="en-US" sz="1800" dirty="0"/>
-          </a:p>
-        </p:txBody>
-      </p:sp>
-      <p:sp>
-        <p:nvSpPr>
-          <p:cNvPr id="13" name="Text 11"/>
-          <p:cNvSpPr/>
-          <p:nvPr/>
-        </p:nvSpPr>
-        <p:spPr>
-          <a:xfrm>
-            <a:off x="4645152" y="3383280"/>
-            <a:ext cx="3063240" cy="2286000"/>
+          <p:cNvPr id="10" name="Text 7"/>
+          <p:cNvSpPr/>
+          <p:nvPr/>
+        </p:nvSpPr>
+        <p:spPr>
+          <a:xfrm>
+            <a:off x="7086600" y="5029200"/>
+            <a:ext cx="4251960" cy="822960"/>
           </a:xfrm>
           <a:prstGeom prst="rect">
             <a:avLst/>
@@ -3415,198 +3388,22 @@
           <a:p>
             <a:pPr indent="0" marL="0">
               <a:lnSpc>
-                <a:spcPct val="108000"/>
+                <a:spcPct val="103000"/>
               </a:lnSpc>
               <a:buNone/>
             </a:pPr>
             <a:r>
-              <a:rPr lang="en-US" sz="1400" dirty="0">
-                <a:solidFill>
-                  <a:srgbClr val="64748B"/>
-                </a:solidFill>
-                <a:latin typeface="Calibri" pitchFamily="34" charset="0"/>
-                <a:ea typeface="Calibri" pitchFamily="34" charset="-122"/>
-                <a:cs typeface="Calibri" pitchFamily="34" charset="-120"/>
-              </a:rPr>
-              <a:t>The fingerprint predicts the reflex above chance (R²=0.17) and the representation clearly moves during conditioning.</a:t>
-            </a:r>
-            <a:endParaRPr lang="en-US" sz="1400" dirty="0"/>
-          </a:p>
-        </p:txBody>
-      </p:sp>
-      <p:sp>
-        <p:nvSpPr>
-          <p:cNvPr id="14" name="Shape 12"/>
-          <p:cNvSpPr/>
-          <p:nvPr/>
-        </p:nvSpPr>
-        <p:spPr>
-          <a:xfrm>
-            <a:off x="8101584" y="1828800"/>
-            <a:ext cx="3538728" cy="4114800"/>
-          </a:xfrm>
-          <a:prstGeom prst="roundRect">
-            <a:avLst>
-              <a:gd name="adj" fmla="val 2326"/>
-            </a:avLst>
-          </a:prstGeom>
-          <a:solidFill>
-            <a:srgbClr val="FFFFFF"/>
-          </a:solidFill>
-          <a:ln w="12700">
-            <a:solidFill>
-              <a:srgbClr val="E2E8F0"/>
-            </a:solidFill>
-            <a:prstDash val="solid"/>
-          </a:ln>
-          <a:effectLst>
-            <a:outerShdw sx="100000" sy="100000" kx="0" ky="0" algn="bl" rotWithShape="0" blurRad="114300" dist="38100" dir="5400000">
-              <a:srgbClr val="0F172A">
-                <a:alpha val="14000"/>
-              </a:srgbClr>
-            </a:outerShdw>
-          </a:effectLst>
-        </p:spPr>
-      </p:sp>
-      <p:sp>
-        <p:nvSpPr>
-          <p:cNvPr id="15" name="Shape 13"/>
-          <p:cNvSpPr/>
-          <p:nvPr/>
-        </p:nvSpPr>
-        <p:spPr>
-          <a:xfrm>
-            <a:off x="8375904" y="2103120"/>
-            <a:ext cx="1737360" cy="457200"/>
-          </a:xfrm>
-          <a:prstGeom prst="roundRect">
-            <a:avLst>
-              <a:gd name="adj" fmla="val 20000"/>
-            </a:avLst>
-          </a:prstGeom>
-          <a:solidFill>
-            <a:srgbClr val="D97706"/>
-          </a:solidFill>
-          <a:ln/>
-        </p:spPr>
-      </p:sp>
-      <p:sp>
-        <p:nvSpPr>
-          <p:cNvPr id="16" name="Text 14"/>
-          <p:cNvSpPr/>
-          <p:nvPr/>
-        </p:nvSpPr>
-        <p:spPr>
-          <a:xfrm>
-            <a:off x="8375904" y="2103120"/>
-            <a:ext cx="1737360" cy="457200"/>
-          </a:xfrm>
-          <a:prstGeom prst="rect">
-            <a:avLst/>
-          </a:prstGeom>
-          <a:noFill/>
-          <a:ln/>
-        </p:spPr>
-        <p:txBody>
-          <a:bodyPr wrap="square" lIns="0" tIns="0" rIns="0" bIns="0" rtlCol="0" anchor="ctr"/>
-          <a:lstStyle/>
-          <a:p>
-            <a:pPr algn="ctr" indent="0" marL="0">
-              <a:buNone/>
-            </a:pPr>
-            <a:r>
-              <a:rPr lang="en-US" sz="1300" b="1" spc="100" kern="0" dirty="0">
-                <a:solidFill>
-                  <a:srgbClr val="FFFFFF"/>
-                </a:solidFill>
-                <a:latin typeface="Calibri" pitchFamily="34" charset="0"/>
-                <a:ea typeface="Calibri" pitchFamily="34" charset="-122"/>
-                <a:cs typeface="Calibri" pitchFamily="34" charset="-120"/>
-              </a:rPr>
-              <a:t>NOT YET</a:t>
-            </a:r>
-            <a:endParaRPr lang="en-US" sz="1300" dirty="0"/>
-          </a:p>
-        </p:txBody>
-      </p:sp>
-      <p:sp>
-        <p:nvSpPr>
-          <p:cNvPr id="17" name="Text 15"/>
-          <p:cNvSpPr/>
-          <p:nvPr/>
-        </p:nvSpPr>
-        <p:spPr>
-          <a:xfrm>
-            <a:off x="8375904" y="2743200"/>
-            <a:ext cx="3017520" cy="548640"/>
-          </a:xfrm>
-          <a:prstGeom prst="rect">
-            <a:avLst/>
-          </a:prstGeom>
-          <a:noFill/>
-          <a:ln/>
-        </p:spPr>
-        <p:txBody>
-          <a:bodyPr wrap="square" lIns="0" tIns="0" rIns="0" bIns="0" rtlCol="0" anchor="ctr"/>
-          <a:lstStyle/>
-          <a:p>
-            <a:pPr indent="0" marL="0">
-              <a:buNone/>
-            </a:pPr>
-            <a:r>
-              <a:rPr lang="en-US" sz="1800" b="1" dirty="0">
-                <a:solidFill>
-                  <a:srgbClr val="1E293B"/>
-                </a:solidFill>
-                <a:latin typeface="Calibri" pitchFamily="34" charset="0"/>
-                <a:ea typeface="Calibri" pitchFamily="34" charset="-122"/>
-                <a:cs typeface="Calibri" pitchFamily="34" charset="-120"/>
-              </a:rPr>
-              <a:t>A publishable claim</a:t>
-            </a:r>
-            <a:endParaRPr lang="en-US" sz="1800" dirty="0"/>
-          </a:p>
-        </p:txBody>
-      </p:sp>
-      <p:sp>
-        <p:nvSpPr>
-          <p:cNvPr id="18" name="Text 16"/>
-          <p:cNvSpPr/>
-          <p:nvPr/>
-        </p:nvSpPr>
-        <p:spPr>
-          <a:xfrm>
-            <a:off x="8375904" y="3383280"/>
-            <a:ext cx="3063240" cy="2286000"/>
-          </a:xfrm>
-          <a:prstGeom prst="rect">
-            <a:avLst/>
-          </a:prstGeom>
-          <a:noFill/>
-          <a:ln/>
-        </p:spPr>
-        <p:txBody>
-          <a:bodyPr wrap="square" lIns="0" tIns="0" rIns="0" bIns="0" rtlCol="0" anchor="ctr"/>
-          <a:lstStyle/>
-          <a:p>
-            <a:pPr indent="0" marL="0">
-              <a:lnSpc>
-                <a:spcPct val="108000"/>
-              </a:lnSpc>
-              <a:buNone/>
-            </a:pPr>
-            <a:r>
-              <a:rPr lang="en-US" sz="1400" dirty="0">
-                <a:solidFill>
-                  <a:srgbClr val="64748B"/>
-                </a:solidFill>
-                <a:latin typeface="Calibri" pitchFamily="34" charset="0"/>
-                <a:ea typeface="Calibri" pitchFamily="34" charset="-122"/>
-                <a:cs typeface="Calibri" pitchFamily="34" charset="-120"/>
-              </a:rPr>
-              <a:t>Needs the baseline confound resolved, proper statistics, and more animals. Today is a strong foundation, not a result.</a:t>
-            </a:r>
-            <a:endParaRPr lang="en-US" sz="1400" dirty="0"/>
+              <a:rPr lang="en-US" sz="1250" b="1" i="1" dirty="0">
+                <a:solidFill>
+                  <a:srgbClr val="D97706"/>
+                </a:solidFill>
+                <a:latin typeface="Calibri" pitchFamily="34" charset="0"/>
+                <a:ea typeface="Calibri" pitchFamily="34" charset="-122"/>
+                <a:cs typeface="Calibri" pitchFamily="34" charset="-120"/>
+              </a:rPr>
+              <a:t>So part of the cortical drift may track session state (fixed-stimulus, active recording) rather than learning itself. #1 thing to resolve.</a:t>
+            </a:r>
+            <a:endParaRPr lang="en-US" sz="1250" dirty="0"/>
           </a:p>
         </p:txBody>
       </p:sp>
@@ -3675,7 +3472,7 @@
                 <a:ea typeface="Calibri" pitchFamily="34" charset="-122"/>
                 <a:cs typeface="Calibri" pitchFamily="34" charset="-120"/>
               </a:rPr>
-              <a:t>NEXT</a:t>
+              <a:t>WHERE WE STAND</a:t>
             </a:r>
             <a:endParaRPr lang="en-US" sz="1250" dirty="0"/>
           </a:p>
@@ -3714,7 +3511,7 @@
                 <a:ea typeface="Cambria" pitchFamily="34" charset="-122"/>
                 <a:cs typeface="Cambria" pitchFamily="34" charset="-120"/>
               </a:rPr>
-              <a:t>The plan — and it scales</a:t>
+              <a:t>Is this good progress? My honest scorecard</a:t>
             </a:r>
             <a:endParaRPr lang="en-US" sz="3000" dirty="0"/>
           </a:p>
@@ -3722,60 +3519,18 @@
       </p:sp>
       <p:sp>
         <p:nvSpPr>
-          <p:cNvPr id="4" name="Text 2"/>
-          <p:cNvSpPr/>
-          <p:nvPr/>
-        </p:nvSpPr>
-        <p:spPr>
-          <a:xfrm>
-            <a:off x="640080" y="1600200"/>
-            <a:ext cx="10881360" cy="731520"/>
-          </a:xfrm>
-          <a:prstGeom prst="rect">
-            <a:avLst/>
-          </a:prstGeom>
-          <a:noFill/>
-          <a:ln/>
-        </p:spPr>
-        <p:txBody>
-          <a:bodyPr wrap="square" lIns="0" tIns="0" rIns="0" bIns="0" rtlCol="0" anchor="ctr"/>
-          <a:lstStyle/>
-          <a:p>
-            <a:pPr indent="0" marL="0">
-              <a:lnSpc>
-                <a:spcPct val="105000"/>
-              </a:lnSpc>
-              <a:buNone/>
-            </a:pPr>
-            <a:r>
-              <a:rPr lang="en-US" sz="1600" dirty="0">
-                <a:solidFill>
-                  <a:srgbClr val="1E293B"/>
-                </a:solidFill>
-                <a:latin typeface="Calibri" pitchFamily="34" charset="0"/>
-                <a:ea typeface="Calibri" pitchFamily="34" charset="-122"/>
-                <a:cs typeface="Calibri" pitchFamily="34" charset="-120"/>
-              </a:rPr>
-              <a:t>Animal 9 is 1 of ~14 conditioned animals sitting in the Drive. The pipeline is built to pool them — every new animal makes the drift result stronger.</a:t>
-            </a:r>
-            <a:endParaRPr lang="en-US" sz="1600" dirty="0"/>
-          </a:p>
-        </p:txBody>
-      </p:sp>
-      <p:sp>
-        <p:nvSpPr>
-          <p:cNvPr id="5" name="Shape 3"/>
-          <p:cNvSpPr/>
-          <p:nvPr/>
-        </p:nvSpPr>
-        <p:spPr>
-          <a:xfrm>
-            <a:off x="640080" y="2514600"/>
-            <a:ext cx="10881360" cy="841248"/>
+          <p:cNvPr id="4" name="Shape 2"/>
+          <p:cNvSpPr/>
+          <p:nvPr/>
+        </p:nvSpPr>
+        <p:spPr>
+          <a:xfrm>
+            <a:off x="640080" y="1828800"/>
+            <a:ext cx="3538728" cy="4114800"/>
           </a:xfrm>
           <a:prstGeom prst="roundRect">
             <a:avLst>
-              <a:gd name="adj" fmla="val 9783"/>
+              <a:gd name="adj" fmla="val 2326"/>
             </a:avLst>
           </a:prstGeom>
           <a:solidFill>
@@ -3798,158 +3553,160 @@
       </p:sp>
       <p:sp>
         <p:nvSpPr>
-          <p:cNvPr id="6" name="Shape 4"/>
-          <p:cNvSpPr/>
-          <p:nvPr/>
-        </p:nvSpPr>
-        <p:spPr>
-          <a:xfrm>
-            <a:off x="868680" y="2706624"/>
-            <a:ext cx="457200" cy="457200"/>
-          </a:xfrm>
-          <a:prstGeom prst="ellipse">
-            <a:avLst/>
-          </a:prstGeom>
-          <a:solidFill>
-            <a:srgbClr val="6D28D9"/>
-          </a:solidFill>
-          <a:ln/>
-        </p:spPr>
-      </p:sp>
-      <p:sp>
-        <p:nvSpPr>
-          <p:cNvPr id="7" name="Text 5"/>
-          <p:cNvSpPr/>
-          <p:nvPr/>
-        </p:nvSpPr>
-        <p:spPr>
-          <a:xfrm>
-            <a:off x="868680" y="2706624"/>
-            <a:ext cx="457200" cy="457200"/>
-          </a:xfrm>
-          <a:prstGeom prst="rect">
-            <a:avLst/>
-          </a:prstGeom>
-          <a:noFill/>
-          <a:ln/>
-        </p:spPr>
-        <p:txBody>
-          <a:bodyPr wrap="square" lIns="0" tIns="0" rIns="0" bIns="0" rtlCol="0" anchor="ctr"/>
-          <a:lstStyle/>
-          <a:p>
-            <a:pPr algn="ctr" indent="0" marL="0">
-              <a:buNone/>
-            </a:pPr>
-            <a:r>
-              <a:rPr lang="en-US" sz="1800" b="1" dirty="0">
-                <a:solidFill>
-                  <a:srgbClr val="FFFFFF"/>
-                </a:solidFill>
-                <a:latin typeface="Calibri" pitchFamily="34" charset="0"/>
-                <a:ea typeface="Calibri" pitchFamily="34" charset="-122"/>
-                <a:cs typeface="Calibri" pitchFamily="34" charset="-120"/>
-              </a:rPr>
-              <a:t>1</a:t>
-            </a:r>
-            <a:endParaRPr lang="en-US" sz="1800" dirty="0"/>
-          </a:p>
-        </p:txBody>
-      </p:sp>
-      <p:sp>
-        <p:nvSpPr>
-          <p:cNvPr id="8" name="Text 6"/>
-          <p:cNvSpPr/>
-          <p:nvPr/>
-        </p:nvSpPr>
-        <p:spPr>
-          <a:xfrm>
-            <a:off x="1554480" y="2633472"/>
-            <a:ext cx="3840480" cy="594360"/>
-          </a:xfrm>
-          <a:prstGeom prst="rect">
-            <a:avLst/>
-          </a:prstGeom>
-          <a:noFill/>
-          <a:ln/>
-        </p:spPr>
-        <p:txBody>
-          <a:bodyPr wrap="square" lIns="0" tIns="0" rIns="0" bIns="0" rtlCol="0" anchor="ctr"/>
-          <a:lstStyle/>
-          <a:p>
-            <a:pPr indent="0" marL="0">
-              <a:buNone/>
-            </a:pPr>
-            <a:r>
-              <a:rPr lang="en-US" sz="1550" b="1" dirty="0">
-                <a:solidFill>
-                  <a:srgbClr val="1E293B"/>
-                </a:solidFill>
-                <a:latin typeface="Calibri" pitchFamily="34" charset="0"/>
-                <a:ea typeface="Calibri" pitchFamily="34" charset="-122"/>
-                <a:cs typeface="Calibri" pitchFamily="34" charset="-120"/>
-              </a:rPr>
-              <a:t>Resolve the baseline confound</a:t>
-            </a:r>
-            <a:endParaRPr lang="en-US" sz="1550" dirty="0"/>
-          </a:p>
-        </p:txBody>
-      </p:sp>
-      <p:sp>
-        <p:nvSpPr>
-          <p:cNvPr id="9" name="Text 7"/>
-          <p:cNvSpPr/>
-          <p:nvPr/>
-        </p:nvSpPr>
-        <p:spPr>
-          <a:xfrm>
-            <a:off x="5486400" y="2633472"/>
-            <a:ext cx="5852160" cy="594360"/>
-          </a:xfrm>
-          <a:prstGeom prst="rect">
-            <a:avLst/>
-          </a:prstGeom>
-          <a:noFill/>
-          <a:ln/>
-        </p:spPr>
-        <p:txBody>
-          <a:bodyPr wrap="square" lIns="0" tIns="0" rIns="0" bIns="0" rtlCol="0" anchor="ctr"/>
-          <a:lstStyle/>
-          <a:p>
-            <a:pPr indent="0" marL="0">
-              <a:lnSpc>
-                <a:spcPct val="100000"/>
-              </a:lnSpc>
-              <a:buNone/>
-            </a:pPr>
-            <a:r>
-              <a:rPr lang="en-US" sz="1350" dirty="0">
-                <a:solidFill>
-                  <a:srgbClr val="64748B"/>
-                </a:solidFill>
-                <a:latin typeface="Calibri" pitchFamily="34" charset="0"/>
-                <a:ea typeface="Calibri" pitchFamily="34" charset="-122"/>
-                <a:cs typeface="Calibri" pitchFamily="34" charset="-120"/>
-              </a:rPr>
-              <a:t>Restrict 'Baseline' to post-setup trials; regress out raw reflex size. Does the drift survive?</a:t>
-            </a:r>
-            <a:endParaRPr lang="en-US" sz="1350" dirty="0"/>
-          </a:p>
-        </p:txBody>
-      </p:sp>
-      <p:sp>
-        <p:nvSpPr>
-          <p:cNvPr id="10" name="Shape 8"/>
-          <p:cNvSpPr/>
-          <p:nvPr/>
-        </p:nvSpPr>
-        <p:spPr>
-          <a:xfrm>
-            <a:off x="640080" y="3456432"/>
-            <a:ext cx="10881360" cy="841248"/>
+          <p:cNvPr id="5" name="Shape 3"/>
+          <p:cNvSpPr/>
+          <p:nvPr/>
+        </p:nvSpPr>
+        <p:spPr>
+          <a:xfrm>
+            <a:off x="914400" y="2103120"/>
+            <a:ext cx="1737360" cy="457200"/>
           </a:xfrm>
           <a:prstGeom prst="roundRect">
             <a:avLst>
-              <a:gd name="adj" fmla="val 9783"/>
+              <a:gd name="adj" fmla="val 20000"/>
+            </a:avLst>
+          </a:prstGeom>
+          <a:solidFill>
+            <a:srgbClr val="16A34A"/>
+          </a:solidFill>
+          <a:ln/>
+        </p:spPr>
+      </p:sp>
+      <p:sp>
+        <p:nvSpPr>
+          <p:cNvPr id="6" name="Text 4"/>
+          <p:cNvSpPr/>
+          <p:nvPr/>
+        </p:nvSpPr>
+        <p:spPr>
+          <a:xfrm>
+            <a:off x="914400" y="2103120"/>
+            <a:ext cx="1737360" cy="457200"/>
+          </a:xfrm>
+          <a:prstGeom prst="rect">
+            <a:avLst/>
+          </a:prstGeom>
+          <a:noFill/>
+          <a:ln/>
+        </p:spPr>
+        <p:txBody>
+          <a:bodyPr wrap="square" lIns="0" tIns="0" rIns="0" bIns="0" rtlCol="0" anchor="ctr"/>
+          <a:lstStyle/>
+          <a:p>
+            <a:pPr algn="ctr" indent="0" marL="0">
+              <a:buNone/>
+            </a:pPr>
+            <a:r>
+              <a:rPr lang="en-US" sz="1300" b="1" spc="100" kern="0" dirty="0">
+                <a:solidFill>
+                  <a:srgbClr val="FFFFFF"/>
+                </a:solidFill>
+                <a:latin typeface="Calibri" pitchFamily="34" charset="0"/>
+                <a:ea typeface="Calibri" pitchFamily="34" charset="-122"/>
+                <a:cs typeface="Calibri" pitchFamily="34" charset="-120"/>
+              </a:rPr>
+              <a:t>STRONG</a:t>
+            </a:r>
+            <a:endParaRPr lang="en-US" sz="1300" dirty="0"/>
+          </a:p>
+        </p:txBody>
+      </p:sp>
+      <p:sp>
+        <p:nvSpPr>
+          <p:cNvPr id="7" name="Text 5"/>
+          <p:cNvSpPr/>
+          <p:nvPr/>
+        </p:nvSpPr>
+        <p:spPr>
+          <a:xfrm>
+            <a:off x="914400" y="2743200"/>
+            <a:ext cx="3017520" cy="548640"/>
+          </a:xfrm>
+          <a:prstGeom prst="rect">
+            <a:avLst/>
+          </a:prstGeom>
+          <a:noFill/>
+          <a:ln/>
+        </p:spPr>
+        <p:txBody>
+          <a:bodyPr wrap="square" lIns="0" tIns="0" rIns="0" bIns="0" rtlCol="0" anchor="ctr"/>
+          <a:lstStyle/>
+          <a:p>
+            <a:pPr indent="0" marL="0">
+              <a:buNone/>
+            </a:pPr>
+            <a:r>
+              <a:rPr lang="en-US" sz="1800" b="1" dirty="0">
+                <a:solidFill>
+                  <a:srgbClr val="1E293B"/>
+                </a:solidFill>
+                <a:latin typeface="Calibri" pitchFamily="34" charset="0"/>
+                <a:ea typeface="Calibri" pitchFamily="34" charset="-122"/>
+                <a:cs typeface="Calibri" pitchFamily="34" charset="-120"/>
+              </a:rPr>
+              <a:t>Infrastructure</a:t>
+            </a:r>
+            <a:endParaRPr lang="en-US" sz="1800" dirty="0"/>
+          </a:p>
+        </p:txBody>
+      </p:sp>
+      <p:sp>
+        <p:nvSpPr>
+          <p:cNvPr id="8" name="Text 6"/>
+          <p:cNvSpPr/>
+          <p:nvPr/>
+        </p:nvSpPr>
+        <p:spPr>
+          <a:xfrm>
+            <a:off x="914400" y="3383280"/>
+            <a:ext cx="3063240" cy="2286000"/>
+          </a:xfrm>
+          <a:prstGeom prst="rect">
+            <a:avLst/>
+          </a:prstGeom>
+          <a:noFill/>
+          <a:ln/>
+        </p:spPr>
+        <p:txBody>
+          <a:bodyPr wrap="square" lIns="0" tIns="0" rIns="0" bIns="0" rtlCol="0" anchor="ctr"/>
+          <a:lstStyle/>
+          <a:p>
+            <a:pPr indent="0" marL="0">
+              <a:lnSpc>
+                <a:spcPct val="108000"/>
+              </a:lnSpc>
+              <a:buNone/>
+            </a:pPr>
+            <a:r>
+              <a:rPr lang="en-US" sz="1400" dirty="0">
+                <a:solidFill>
+                  <a:srgbClr val="64748B"/>
+                </a:solidFill>
+                <a:latin typeface="Calibri" pitchFamily="34" charset="0"/>
+                <a:ea typeface="Calibri" pitchFamily="34" charset="-122"/>
+                <a:cs typeface="Calibri" pitchFamily="34" charset="-120"/>
+              </a:rPr>
+              <a:t>Real data flows end to end — decode, phase labels, training, analysis. Reproducible, on a laptop. This was the hard part and it's done.</a:t>
+            </a:r>
+            <a:endParaRPr lang="en-US" sz="1400" dirty="0"/>
+          </a:p>
+        </p:txBody>
+      </p:sp>
+      <p:sp>
+        <p:nvSpPr>
+          <p:cNvPr id="9" name="Shape 7"/>
+          <p:cNvSpPr/>
+          <p:nvPr/>
+        </p:nvSpPr>
+        <p:spPr>
+          <a:xfrm>
+            <a:off x="4370832" y="1828800"/>
+            <a:ext cx="3538728" cy="4114800"/>
+          </a:xfrm>
+          <a:prstGeom prst="roundRect">
+            <a:avLst>
+              <a:gd name="adj" fmla="val 2326"/>
             </a:avLst>
           </a:prstGeom>
           <a:solidFill>
@@ -3972,158 +3729,160 @@
       </p:sp>
       <p:sp>
         <p:nvSpPr>
-          <p:cNvPr id="11" name="Shape 9"/>
-          <p:cNvSpPr/>
-          <p:nvPr/>
-        </p:nvSpPr>
-        <p:spPr>
-          <a:xfrm>
-            <a:off x="868680" y="3648456"/>
-            <a:ext cx="457200" cy="457200"/>
-          </a:xfrm>
-          <a:prstGeom prst="ellipse">
-            <a:avLst/>
-          </a:prstGeom>
-          <a:solidFill>
-            <a:srgbClr val="6D28D9"/>
-          </a:solidFill>
-          <a:ln/>
-        </p:spPr>
-      </p:sp>
-      <p:sp>
-        <p:nvSpPr>
-          <p:cNvPr id="12" name="Text 10"/>
-          <p:cNvSpPr/>
-          <p:nvPr/>
-        </p:nvSpPr>
-        <p:spPr>
-          <a:xfrm>
-            <a:off x="868680" y="3648456"/>
-            <a:ext cx="457200" cy="457200"/>
-          </a:xfrm>
-          <a:prstGeom prst="rect">
-            <a:avLst/>
-          </a:prstGeom>
-          <a:noFill/>
-          <a:ln/>
-        </p:spPr>
-        <p:txBody>
-          <a:bodyPr wrap="square" lIns="0" tIns="0" rIns="0" bIns="0" rtlCol="0" anchor="ctr"/>
-          <a:lstStyle/>
-          <a:p>
-            <a:pPr algn="ctr" indent="0" marL="0">
-              <a:buNone/>
-            </a:pPr>
-            <a:r>
-              <a:rPr lang="en-US" sz="1800" b="1" dirty="0">
-                <a:solidFill>
-                  <a:srgbClr val="FFFFFF"/>
-                </a:solidFill>
-                <a:latin typeface="Calibri" pitchFamily="34" charset="0"/>
-                <a:ea typeface="Calibri" pitchFamily="34" charset="-122"/>
-                <a:cs typeface="Calibri" pitchFamily="34" charset="-120"/>
-              </a:rPr>
-              <a:t>2</a:t>
-            </a:r>
-            <a:endParaRPr lang="en-US" sz="1800" dirty="0"/>
-          </a:p>
-        </p:txBody>
-      </p:sp>
-      <p:sp>
-        <p:nvSpPr>
-          <p:cNvPr id="13" name="Text 11"/>
-          <p:cNvSpPr/>
-          <p:nvPr/>
-        </p:nvSpPr>
-        <p:spPr>
-          <a:xfrm>
-            <a:off x="1554480" y="3575304"/>
-            <a:ext cx="3840480" cy="594360"/>
-          </a:xfrm>
-          <a:prstGeom prst="rect">
-            <a:avLst/>
-          </a:prstGeom>
-          <a:noFill/>
-          <a:ln/>
-        </p:spPr>
-        <p:txBody>
-          <a:bodyPr wrap="square" lIns="0" tIns="0" rIns="0" bIns="0" rtlCol="0" anchor="ctr"/>
-          <a:lstStyle/>
-          <a:p>
-            <a:pPr indent="0" marL="0">
-              <a:buNone/>
-            </a:pPr>
-            <a:r>
-              <a:rPr lang="en-US" sz="1550" b="1" dirty="0">
-                <a:solidFill>
-                  <a:srgbClr val="1E293B"/>
-                </a:solidFill>
-                <a:latin typeface="Calibri" pitchFamily="34" charset="0"/>
-                <a:ea typeface="Calibri" pitchFamily="34" charset="-122"/>
-                <a:cs typeface="Calibri" pitchFamily="34" charset="-120"/>
-              </a:rPr>
-              <a:t>Add statistics</a:t>
-            </a:r>
-            <a:endParaRPr lang="en-US" sz="1550" dirty="0"/>
-          </a:p>
-        </p:txBody>
-      </p:sp>
-      <p:sp>
-        <p:nvSpPr>
-          <p:cNvPr id="14" name="Text 12"/>
-          <p:cNvSpPr/>
-          <p:nvPr/>
-        </p:nvSpPr>
-        <p:spPr>
-          <a:xfrm>
-            <a:off x="5486400" y="3575304"/>
-            <a:ext cx="5852160" cy="594360"/>
-          </a:xfrm>
-          <a:prstGeom prst="rect">
-            <a:avLst/>
-          </a:prstGeom>
-          <a:noFill/>
-          <a:ln/>
-        </p:spPr>
-        <p:txBody>
-          <a:bodyPr wrap="square" lIns="0" tIns="0" rIns="0" bIns="0" rtlCol="0" anchor="ctr"/>
-          <a:lstStyle/>
-          <a:p>
-            <a:pPr indent="0" marL="0">
-              <a:lnSpc>
-                <a:spcPct val="100000"/>
-              </a:lnSpc>
-              <a:buNone/>
-            </a:pPr>
-            <a:r>
-              <a:rPr lang="en-US" sz="1350" dirty="0">
-                <a:solidFill>
-                  <a:srgbClr val="64748B"/>
-                </a:solidFill>
-                <a:latin typeface="Calibri" pitchFamily="34" charset="0"/>
-                <a:ea typeface="Calibri" pitchFamily="34" charset="-122"/>
-                <a:cs typeface="Calibri" pitchFamily="34" charset="-120"/>
-              </a:rPr>
-              <a:t>Bootstrap the drift — a within-baseline split should drift ~0. Is 28.5 vs 5.0 real?</a:t>
-            </a:r>
-            <a:endParaRPr lang="en-US" sz="1350" dirty="0"/>
-          </a:p>
-        </p:txBody>
-      </p:sp>
-      <p:sp>
-        <p:nvSpPr>
-          <p:cNvPr id="15" name="Shape 13"/>
-          <p:cNvSpPr/>
-          <p:nvPr/>
-        </p:nvSpPr>
-        <p:spPr>
-          <a:xfrm>
-            <a:off x="640080" y="4398264"/>
-            <a:ext cx="10881360" cy="841248"/>
+          <p:cNvPr id="10" name="Shape 8"/>
+          <p:cNvSpPr/>
+          <p:nvPr/>
+        </p:nvSpPr>
+        <p:spPr>
+          <a:xfrm>
+            <a:off x="4645152" y="2103120"/>
+            <a:ext cx="1737360" cy="457200"/>
           </a:xfrm>
           <a:prstGeom prst="roundRect">
             <a:avLst>
-              <a:gd name="adj" fmla="val 9783"/>
+              <a:gd name="adj" fmla="val 20000"/>
+            </a:avLst>
+          </a:prstGeom>
+          <a:solidFill>
+            <a:srgbClr val="0D9488"/>
+          </a:solidFill>
+          <a:ln/>
+        </p:spPr>
+      </p:sp>
+      <p:sp>
+        <p:nvSpPr>
+          <p:cNvPr id="11" name="Text 9"/>
+          <p:cNvSpPr/>
+          <p:nvPr/>
+        </p:nvSpPr>
+        <p:spPr>
+          <a:xfrm>
+            <a:off x="4645152" y="2103120"/>
+            <a:ext cx="1737360" cy="457200"/>
+          </a:xfrm>
+          <a:prstGeom prst="rect">
+            <a:avLst/>
+          </a:prstGeom>
+          <a:noFill/>
+          <a:ln/>
+        </p:spPr>
+        <p:txBody>
+          <a:bodyPr wrap="square" lIns="0" tIns="0" rIns="0" bIns="0" rtlCol="0" anchor="ctr"/>
+          <a:lstStyle/>
+          <a:p>
+            <a:pPr algn="ctr" indent="0" marL="0">
+              <a:buNone/>
+            </a:pPr>
+            <a:r>
+              <a:rPr lang="en-US" sz="1300" b="1" spc="100" kern="0" dirty="0">
+                <a:solidFill>
+                  <a:srgbClr val="FFFFFF"/>
+                </a:solidFill>
+                <a:latin typeface="Calibri" pitchFamily="34" charset="0"/>
+                <a:ea typeface="Calibri" pitchFamily="34" charset="-122"/>
+                <a:cs typeface="Calibri" pitchFamily="34" charset="-120"/>
+              </a:rPr>
+              <a:t>PROMISING</a:t>
+            </a:r>
+            <a:endParaRPr lang="en-US" sz="1300" dirty="0"/>
+          </a:p>
+        </p:txBody>
+      </p:sp>
+      <p:sp>
+        <p:nvSpPr>
+          <p:cNvPr id="12" name="Text 10"/>
+          <p:cNvSpPr/>
+          <p:nvPr/>
+        </p:nvSpPr>
+        <p:spPr>
+          <a:xfrm>
+            <a:off x="4645152" y="2743200"/>
+            <a:ext cx="3017520" cy="548640"/>
+          </a:xfrm>
+          <a:prstGeom prst="rect">
+            <a:avLst/>
+          </a:prstGeom>
+          <a:noFill/>
+          <a:ln/>
+        </p:spPr>
+        <p:txBody>
+          <a:bodyPr wrap="square" lIns="0" tIns="0" rIns="0" bIns="0" rtlCol="0" anchor="ctr"/>
+          <a:lstStyle/>
+          <a:p>
+            <a:pPr indent="0" marL="0">
+              <a:buNone/>
+            </a:pPr>
+            <a:r>
+              <a:rPr lang="en-US" sz="1800" b="1" dirty="0">
+                <a:solidFill>
+                  <a:srgbClr val="1E293B"/>
+                </a:solidFill>
+                <a:latin typeface="Calibri" pitchFamily="34" charset="0"/>
+                <a:ea typeface="Calibri" pitchFamily="34" charset="-122"/>
+                <a:cs typeface="Calibri" pitchFamily="34" charset="-120"/>
+              </a:rPr>
+              <a:t>First real signal</a:t>
+            </a:r>
+            <a:endParaRPr lang="en-US" sz="1800" dirty="0"/>
+          </a:p>
+        </p:txBody>
+      </p:sp>
+      <p:sp>
+        <p:nvSpPr>
+          <p:cNvPr id="13" name="Text 11"/>
+          <p:cNvSpPr/>
+          <p:nvPr/>
+        </p:nvSpPr>
+        <p:spPr>
+          <a:xfrm>
+            <a:off x="4645152" y="3383280"/>
+            <a:ext cx="3063240" cy="2286000"/>
+          </a:xfrm>
+          <a:prstGeom prst="rect">
+            <a:avLst/>
+          </a:prstGeom>
+          <a:noFill/>
+          <a:ln/>
+        </p:spPr>
+        <p:txBody>
+          <a:bodyPr wrap="square" lIns="0" tIns="0" rIns="0" bIns="0" rtlCol="0" anchor="ctr"/>
+          <a:lstStyle/>
+          <a:p>
+            <a:pPr indent="0" marL="0">
+              <a:lnSpc>
+                <a:spcPct val="108000"/>
+              </a:lnSpc>
+              <a:buNone/>
+            </a:pPr>
+            <a:r>
+              <a:rPr lang="en-US" sz="1400" dirty="0">
+                <a:solidFill>
+                  <a:srgbClr val="64748B"/>
+                </a:solidFill>
+                <a:latin typeface="Calibri" pitchFamily="34" charset="0"/>
+                <a:ea typeface="Calibri" pitchFamily="34" charset="-122"/>
+                <a:cs typeface="Calibri" pitchFamily="34" charset="-120"/>
+              </a:rPr>
+              <a:t>The fingerprint predicts the reflex above chance (R²=0.17) and the representation clearly moves during conditioning.</a:t>
+            </a:r>
+            <a:endParaRPr lang="en-US" sz="1400" dirty="0"/>
+          </a:p>
+        </p:txBody>
+      </p:sp>
+      <p:sp>
+        <p:nvSpPr>
+          <p:cNvPr id="14" name="Shape 12"/>
+          <p:cNvSpPr/>
+          <p:nvPr/>
+        </p:nvSpPr>
+        <p:spPr>
+          <a:xfrm>
+            <a:off x="8101584" y="1828800"/>
+            <a:ext cx="3538728" cy="4114800"/>
+          </a:xfrm>
+          <a:prstGeom prst="roundRect">
+            <a:avLst>
+              <a:gd name="adj" fmla="val 2326"/>
             </a:avLst>
           </a:prstGeom>
           <a:solidFill>
@@ -4146,58 +3905,99 @@
       </p:sp>
       <p:sp>
         <p:nvSpPr>
-          <p:cNvPr id="16" name="Shape 14"/>
-          <p:cNvSpPr/>
-          <p:nvPr/>
-        </p:nvSpPr>
-        <p:spPr>
-          <a:xfrm>
-            <a:off x="868680" y="4590288"/>
-            <a:ext cx="457200" cy="457200"/>
-          </a:xfrm>
-          <a:prstGeom prst="ellipse">
-            <a:avLst/>
+          <p:cNvPr id="15" name="Shape 13"/>
+          <p:cNvSpPr/>
+          <p:nvPr/>
+        </p:nvSpPr>
+        <p:spPr>
+          <a:xfrm>
+            <a:off x="8375904" y="2103120"/>
+            <a:ext cx="1737360" cy="457200"/>
+          </a:xfrm>
+          <a:prstGeom prst="roundRect">
+            <a:avLst>
+              <a:gd name="adj" fmla="val 20000"/>
+            </a:avLst>
           </a:prstGeom>
           <a:solidFill>
-            <a:srgbClr val="0D9488"/>
+            <a:srgbClr val="D97706"/>
           </a:solidFill>
           <a:ln/>
         </p:spPr>
       </p:sp>
       <p:sp>
         <p:nvSpPr>
+          <p:cNvPr id="16" name="Text 14"/>
+          <p:cNvSpPr/>
+          <p:nvPr/>
+        </p:nvSpPr>
+        <p:spPr>
+          <a:xfrm>
+            <a:off x="8375904" y="2103120"/>
+            <a:ext cx="1737360" cy="457200"/>
+          </a:xfrm>
+          <a:prstGeom prst="rect">
+            <a:avLst/>
+          </a:prstGeom>
+          <a:noFill/>
+          <a:ln/>
+        </p:spPr>
+        <p:txBody>
+          <a:bodyPr wrap="square" lIns="0" tIns="0" rIns="0" bIns="0" rtlCol="0" anchor="ctr"/>
+          <a:lstStyle/>
+          <a:p>
+            <a:pPr algn="ctr" indent="0" marL="0">
+              <a:buNone/>
+            </a:pPr>
+            <a:r>
+              <a:rPr lang="en-US" sz="1300" b="1" spc="100" kern="0" dirty="0">
+                <a:solidFill>
+                  <a:srgbClr val="FFFFFF"/>
+                </a:solidFill>
+                <a:latin typeface="Calibri" pitchFamily="34" charset="0"/>
+                <a:ea typeface="Calibri" pitchFamily="34" charset="-122"/>
+                <a:cs typeface="Calibri" pitchFamily="34" charset="-120"/>
+              </a:rPr>
+              <a:t>NOT YET</a:t>
+            </a:r>
+            <a:endParaRPr lang="en-US" sz="1300" dirty="0"/>
+          </a:p>
+        </p:txBody>
+      </p:sp>
+      <p:sp>
+        <p:nvSpPr>
           <p:cNvPr id="17" name="Text 15"/>
           <p:cNvSpPr/>
           <p:nvPr/>
         </p:nvSpPr>
         <p:spPr>
           <a:xfrm>
-            <a:off x="868680" y="4590288"/>
-            <a:ext cx="457200" cy="457200"/>
-          </a:xfrm>
-          <a:prstGeom prst="rect">
-            <a:avLst/>
-          </a:prstGeom>
-          <a:noFill/>
-          <a:ln/>
-        </p:spPr>
-        <p:txBody>
-          <a:bodyPr wrap="square" lIns="0" tIns="0" rIns="0" bIns="0" rtlCol="0" anchor="ctr"/>
-          <a:lstStyle/>
-          <a:p>
-            <a:pPr algn="ctr" indent="0" marL="0">
+            <a:off x="8375904" y="2743200"/>
+            <a:ext cx="3017520" cy="548640"/>
+          </a:xfrm>
+          <a:prstGeom prst="rect">
+            <a:avLst/>
+          </a:prstGeom>
+          <a:noFill/>
+          <a:ln/>
+        </p:spPr>
+        <p:txBody>
+          <a:bodyPr wrap="square" lIns="0" tIns="0" rIns="0" bIns="0" rtlCol="0" anchor="ctr"/>
+          <a:lstStyle/>
+          <a:p>
+            <a:pPr indent="0" marL="0">
               <a:buNone/>
             </a:pPr>
             <a:r>
               <a:rPr lang="en-US" sz="1800" b="1" dirty="0">
                 <a:solidFill>
-                  <a:srgbClr val="FFFFFF"/>
-                </a:solidFill>
-                <a:latin typeface="Calibri" pitchFamily="34" charset="0"/>
-                <a:ea typeface="Calibri" pitchFamily="34" charset="-122"/>
-                <a:cs typeface="Calibri" pitchFamily="34" charset="-120"/>
-              </a:rPr>
-              <a:t>3</a:t>
+                  <a:srgbClr val="1E293B"/>
+                </a:solidFill>
+                <a:latin typeface="Calibri" pitchFamily="34" charset="0"/>
+                <a:ea typeface="Calibri" pitchFamily="34" charset="-122"/>
+                <a:cs typeface="Calibri" pitchFamily="34" charset="-120"/>
+              </a:rPr>
+              <a:t>A publishable claim</a:t>
             </a:r>
             <a:endParaRPr lang="en-US" sz="1800" dirty="0"/>
           </a:p>
@@ -4211,47 +4011,160 @@
         </p:nvSpPr>
         <p:spPr>
           <a:xfrm>
-            <a:off x="1554480" y="4517136"/>
-            <a:ext cx="3840480" cy="594360"/>
-          </a:xfrm>
-          <a:prstGeom prst="rect">
-            <a:avLst/>
-          </a:prstGeom>
-          <a:noFill/>
-          <a:ln/>
-        </p:spPr>
-        <p:txBody>
-          <a:bodyPr wrap="square" lIns="0" tIns="0" rIns="0" bIns="0" rtlCol="0" anchor="ctr"/>
-          <a:lstStyle/>
-          <a:p>
-            <a:pPr indent="0" marL="0">
-              <a:buNone/>
-            </a:pPr>
-            <a:r>
-              <a:rPr lang="en-US" sz="1550" b="1" dirty="0">
+            <a:off x="8375904" y="3383280"/>
+            <a:ext cx="3063240" cy="2286000"/>
+          </a:xfrm>
+          <a:prstGeom prst="rect">
+            <a:avLst/>
+          </a:prstGeom>
+          <a:noFill/>
+          <a:ln/>
+        </p:spPr>
+        <p:txBody>
+          <a:bodyPr wrap="square" lIns="0" tIns="0" rIns="0" bIns="0" rtlCol="0" anchor="ctr"/>
+          <a:lstStyle/>
+          <a:p>
+            <a:pPr indent="0" marL="0">
+              <a:lnSpc>
+                <a:spcPct val="108000"/>
+              </a:lnSpc>
+              <a:buNone/>
+            </a:pPr>
+            <a:r>
+              <a:rPr lang="en-US" sz="1400" dirty="0">
+                <a:solidFill>
+                  <a:srgbClr val="64748B"/>
+                </a:solidFill>
+                <a:latin typeface="Calibri" pitchFamily="34" charset="0"/>
+                <a:ea typeface="Calibri" pitchFamily="34" charset="-122"/>
+                <a:cs typeface="Calibri" pitchFamily="34" charset="-120"/>
+              </a:rPr>
+              <a:t>Needs the baseline confound resolved, proper statistics, and more animals. Today is a strong foundation, not a result.</a:t>
+            </a:r>
+            <a:endParaRPr lang="en-US" sz="1400" dirty="0"/>
+          </a:p>
+        </p:txBody>
+      </p:sp>
+    </p:spTree>
+  </p:cSld>
+  <p:clrMapOvr>
+    <a:masterClrMapping/>
+  </p:clrMapOvr>
+</p:sld>
+</file>
+
+<file path=ppt/slides/slide14.xml><?xml version="1.0" encoding="utf-8"?>
+<p:sld xmlns:a="http://schemas.openxmlformats.org/drawingml/2006/main" xmlns:r="http://schemas.openxmlformats.org/officeDocument/2006/relationships" xmlns:p="http://schemas.openxmlformats.org/presentationml/2006/main">
+  <p:cSld name="Slide 14">
+    <p:bg>
+      <p:bgPr>
+        <a:solidFill>
+          <a:srgbClr val="FFFFFF"/>
+        </a:solidFill>
+      </p:bgPr>
+    </p:bg>
+    <p:spTree>
+      <p:nvGrpSpPr>
+        <p:cNvPr id="1" name=""/>
+        <p:cNvGrpSpPr/>
+        <p:nvPr/>
+      </p:nvGrpSpPr>
+      <p:grpSpPr>
+        <a:xfrm>
+          <a:off x="0" y="0"/>
+          <a:ext cx="0" cy="0"/>
+          <a:chOff x="0" y="0"/>
+          <a:chExt cx="0" cy="0"/>
+        </a:xfrm>
+      </p:grpSpPr>
+      <p:sp>
+        <p:nvSpPr>
+          <p:cNvPr id="2" name="Text 0"/>
+          <p:cNvSpPr/>
+          <p:nvPr/>
+        </p:nvSpPr>
+        <p:spPr>
+          <a:xfrm>
+            <a:off x="658368" y="384048"/>
+            <a:ext cx="10972800" cy="274320"/>
+          </a:xfrm>
+          <a:prstGeom prst="rect">
+            <a:avLst/>
+          </a:prstGeom>
+          <a:noFill/>
+          <a:ln/>
+        </p:spPr>
+        <p:txBody>
+          <a:bodyPr wrap="square" lIns="0" tIns="0" rIns="0" bIns="0" rtlCol="0" anchor="ctr"/>
+          <a:lstStyle/>
+          <a:p>
+            <a:pPr indent="0" marL="0">
+              <a:buNone/>
+            </a:pPr>
+            <a:r>
+              <a:rPr lang="en-US" sz="1250" b="1" spc="300" kern="0" dirty="0">
+                <a:solidFill>
+                  <a:srgbClr val="0D9488"/>
+                </a:solidFill>
+                <a:latin typeface="Calibri" pitchFamily="34" charset="0"/>
+                <a:ea typeface="Calibri" pitchFamily="34" charset="-122"/>
+                <a:cs typeface="Calibri" pitchFamily="34" charset="-120"/>
+              </a:rPr>
+              <a:t>NEXT</a:t>
+            </a:r>
+            <a:endParaRPr lang="en-US" sz="1250" dirty="0"/>
+          </a:p>
+        </p:txBody>
+      </p:sp>
+      <p:sp>
+        <p:nvSpPr>
+          <p:cNvPr id="3" name="Text 1"/>
+          <p:cNvSpPr/>
+          <p:nvPr/>
+        </p:nvSpPr>
+        <p:spPr>
+          <a:xfrm>
+            <a:off x="640080" y="457200"/>
+            <a:ext cx="10972800" cy="640080"/>
+          </a:xfrm>
+          <a:prstGeom prst="rect">
+            <a:avLst/>
+          </a:prstGeom>
+          <a:noFill/>
+          <a:ln/>
+        </p:spPr>
+        <p:txBody>
+          <a:bodyPr wrap="square" lIns="0" tIns="0" rIns="0" bIns="0" rtlCol="0" anchor="ctr"/>
+          <a:lstStyle/>
+          <a:p>
+            <a:pPr indent="0" marL="0">
+              <a:buNone/>
+            </a:pPr>
+            <a:r>
+              <a:rPr lang="en-US" sz="3000" b="1" dirty="0">
                 <a:solidFill>
                   <a:srgbClr val="1E293B"/>
                 </a:solidFill>
-                <a:latin typeface="Calibri" pitchFamily="34" charset="0"/>
-                <a:ea typeface="Calibri" pitchFamily="34" charset="-122"/>
-                <a:cs typeface="Calibri" pitchFamily="34" charset="-120"/>
-              </a:rPr>
-              <a:t>Pool more animals</a:t>
-            </a:r>
-            <a:endParaRPr lang="en-US" sz="1550" dirty="0"/>
-          </a:p>
-        </p:txBody>
-      </p:sp>
-      <p:sp>
-        <p:nvSpPr>
-          <p:cNvPr id="19" name="Text 17"/>
-          <p:cNvSpPr/>
-          <p:nvPr/>
-        </p:nvSpPr>
-        <p:spPr>
-          <a:xfrm>
-            <a:off x="5486400" y="4517136"/>
-            <a:ext cx="5852160" cy="594360"/>
+                <a:latin typeface="Cambria" pitchFamily="34" charset="0"/>
+                <a:ea typeface="Cambria" pitchFamily="34" charset="-122"/>
+                <a:cs typeface="Cambria" pitchFamily="34" charset="-120"/>
+              </a:rPr>
+              <a:t>The plan — and it scales</a:t>
+            </a:r>
+            <a:endParaRPr lang="en-US" sz="3000" dirty="0"/>
+          </a:p>
+        </p:txBody>
+      </p:sp>
+      <p:sp>
+        <p:nvSpPr>
+          <p:cNvPr id="4" name="Text 2"/>
+          <p:cNvSpPr/>
+          <p:nvPr/>
+        </p:nvSpPr>
+        <p:spPr>
+          <a:xfrm>
+            <a:off x="640080" y="1600200"/>
+            <a:ext cx="10881360" cy="731520"/>
           </a:xfrm>
           <a:prstGeom prst="rect">
             <a:avLst/>
@@ -4265,34 +4178,34 @@
           <a:p>
             <a:pPr indent="0" marL="0">
               <a:lnSpc>
-                <a:spcPct val="100000"/>
+                <a:spcPct val="105000"/>
               </a:lnSpc>
               <a:buNone/>
             </a:pPr>
             <a:r>
-              <a:rPr lang="en-US" sz="1350" dirty="0">
-                <a:solidFill>
-                  <a:srgbClr val="64748B"/>
-                </a:solidFill>
-                <a:latin typeface="Calibri" pitchFamily="34" charset="0"/>
-                <a:ea typeface="Calibri" pitchFamily="34" charset="-122"/>
-                <a:cs typeface="Calibri" pitchFamily="34" charset="-120"/>
-              </a:rPr>
-              <a:t>Convert 6, 10, 11, 12, 13… one at a time, watching for animal-identity confounds.</a:t>
-            </a:r>
-            <a:endParaRPr lang="en-US" sz="1350" dirty="0"/>
-          </a:p>
-        </p:txBody>
-      </p:sp>
-      <p:sp>
-        <p:nvSpPr>
-          <p:cNvPr id="20" name="Shape 18"/>
-          <p:cNvSpPr/>
-          <p:nvPr/>
-        </p:nvSpPr>
-        <p:spPr>
-          <a:xfrm>
-            <a:off x="640080" y="5340096"/>
+              <a:rPr lang="en-US" sz="1600" dirty="0">
+                <a:solidFill>
+                  <a:srgbClr val="1E293B"/>
+                </a:solidFill>
+                <a:latin typeface="Calibri" pitchFamily="34" charset="0"/>
+                <a:ea typeface="Calibri" pitchFamily="34" charset="-122"/>
+                <a:cs typeface="Calibri" pitchFamily="34" charset="-120"/>
+              </a:rPr>
+              <a:t>Animal 9 is 1 of ~14 conditioned animals sitting in the Drive. The pipeline is built to pool them — every new animal makes the drift result stronger.</a:t>
+            </a:r>
+            <a:endParaRPr lang="en-US" sz="1600" dirty="0"/>
+          </a:p>
+        </p:txBody>
+      </p:sp>
+      <p:sp>
+        <p:nvSpPr>
+          <p:cNvPr id="5" name="Shape 3"/>
+          <p:cNvSpPr/>
+          <p:nvPr/>
+        </p:nvSpPr>
+        <p:spPr>
+          <a:xfrm>
+            <a:off x="640080" y="2514600"/>
             <a:ext cx="10881360" cy="841248"/>
           </a:xfrm>
           <a:prstGeom prst="roundRect">
@@ -4320,6 +4233,528 @@
       </p:sp>
       <p:sp>
         <p:nvSpPr>
+          <p:cNvPr id="6" name="Shape 4"/>
+          <p:cNvSpPr/>
+          <p:nvPr/>
+        </p:nvSpPr>
+        <p:spPr>
+          <a:xfrm>
+            <a:off x="868680" y="2706624"/>
+            <a:ext cx="457200" cy="457200"/>
+          </a:xfrm>
+          <a:prstGeom prst="ellipse">
+            <a:avLst/>
+          </a:prstGeom>
+          <a:solidFill>
+            <a:srgbClr val="6D28D9"/>
+          </a:solidFill>
+          <a:ln/>
+        </p:spPr>
+      </p:sp>
+      <p:sp>
+        <p:nvSpPr>
+          <p:cNvPr id="7" name="Text 5"/>
+          <p:cNvSpPr/>
+          <p:nvPr/>
+        </p:nvSpPr>
+        <p:spPr>
+          <a:xfrm>
+            <a:off x="868680" y="2706624"/>
+            <a:ext cx="457200" cy="457200"/>
+          </a:xfrm>
+          <a:prstGeom prst="rect">
+            <a:avLst/>
+          </a:prstGeom>
+          <a:noFill/>
+          <a:ln/>
+        </p:spPr>
+        <p:txBody>
+          <a:bodyPr wrap="square" lIns="0" tIns="0" rIns="0" bIns="0" rtlCol="0" anchor="ctr"/>
+          <a:lstStyle/>
+          <a:p>
+            <a:pPr algn="ctr" indent="0" marL="0">
+              <a:buNone/>
+            </a:pPr>
+            <a:r>
+              <a:rPr lang="en-US" sz="1800" b="1" dirty="0">
+                <a:solidFill>
+                  <a:srgbClr val="FFFFFF"/>
+                </a:solidFill>
+                <a:latin typeface="Calibri" pitchFamily="34" charset="0"/>
+                <a:ea typeface="Calibri" pitchFamily="34" charset="-122"/>
+                <a:cs typeface="Calibri" pitchFamily="34" charset="-120"/>
+              </a:rPr>
+              <a:t>1</a:t>
+            </a:r>
+            <a:endParaRPr lang="en-US" sz="1800" dirty="0"/>
+          </a:p>
+        </p:txBody>
+      </p:sp>
+      <p:sp>
+        <p:nvSpPr>
+          <p:cNvPr id="8" name="Text 6"/>
+          <p:cNvSpPr/>
+          <p:nvPr/>
+        </p:nvSpPr>
+        <p:spPr>
+          <a:xfrm>
+            <a:off x="1554480" y="2633472"/>
+            <a:ext cx="3840480" cy="594360"/>
+          </a:xfrm>
+          <a:prstGeom prst="rect">
+            <a:avLst/>
+          </a:prstGeom>
+          <a:noFill/>
+          <a:ln/>
+        </p:spPr>
+        <p:txBody>
+          <a:bodyPr wrap="square" lIns="0" tIns="0" rIns="0" bIns="0" rtlCol="0" anchor="ctr"/>
+          <a:lstStyle/>
+          <a:p>
+            <a:pPr indent="0" marL="0">
+              <a:buNone/>
+            </a:pPr>
+            <a:r>
+              <a:rPr lang="en-US" sz="1550" b="1" dirty="0">
+                <a:solidFill>
+                  <a:srgbClr val="1E293B"/>
+                </a:solidFill>
+                <a:latin typeface="Calibri" pitchFamily="34" charset="0"/>
+                <a:ea typeface="Calibri" pitchFamily="34" charset="-122"/>
+                <a:cs typeface="Calibri" pitchFamily="34" charset="-120"/>
+              </a:rPr>
+              <a:t>Resolve the baseline confound</a:t>
+            </a:r>
+            <a:endParaRPr lang="en-US" sz="1550" dirty="0"/>
+          </a:p>
+        </p:txBody>
+      </p:sp>
+      <p:sp>
+        <p:nvSpPr>
+          <p:cNvPr id="9" name="Text 7"/>
+          <p:cNvSpPr/>
+          <p:nvPr/>
+        </p:nvSpPr>
+        <p:spPr>
+          <a:xfrm>
+            <a:off x="5486400" y="2633472"/>
+            <a:ext cx="5852160" cy="594360"/>
+          </a:xfrm>
+          <a:prstGeom prst="rect">
+            <a:avLst/>
+          </a:prstGeom>
+          <a:noFill/>
+          <a:ln/>
+        </p:spPr>
+        <p:txBody>
+          <a:bodyPr wrap="square" lIns="0" tIns="0" rIns="0" bIns="0" rtlCol="0" anchor="ctr"/>
+          <a:lstStyle/>
+          <a:p>
+            <a:pPr indent="0" marL="0">
+              <a:lnSpc>
+                <a:spcPct val="100000"/>
+              </a:lnSpc>
+              <a:buNone/>
+            </a:pPr>
+            <a:r>
+              <a:rPr lang="en-US" sz="1350" dirty="0">
+                <a:solidFill>
+                  <a:srgbClr val="64748B"/>
+                </a:solidFill>
+                <a:latin typeface="Calibri" pitchFamily="34" charset="0"/>
+                <a:ea typeface="Calibri" pitchFamily="34" charset="-122"/>
+                <a:cs typeface="Calibri" pitchFamily="34" charset="-120"/>
+              </a:rPr>
+              <a:t>Restrict 'Baseline' to post-setup trials; regress out raw reflex size. Does the drift survive?</a:t>
+            </a:r>
+            <a:endParaRPr lang="en-US" sz="1350" dirty="0"/>
+          </a:p>
+        </p:txBody>
+      </p:sp>
+      <p:sp>
+        <p:nvSpPr>
+          <p:cNvPr id="10" name="Shape 8"/>
+          <p:cNvSpPr/>
+          <p:nvPr/>
+        </p:nvSpPr>
+        <p:spPr>
+          <a:xfrm>
+            <a:off x="640080" y="3456432"/>
+            <a:ext cx="10881360" cy="841248"/>
+          </a:xfrm>
+          <a:prstGeom prst="roundRect">
+            <a:avLst>
+              <a:gd name="adj" fmla="val 9783"/>
+            </a:avLst>
+          </a:prstGeom>
+          <a:solidFill>
+            <a:srgbClr val="FFFFFF"/>
+          </a:solidFill>
+          <a:ln w="12700">
+            <a:solidFill>
+              <a:srgbClr val="E2E8F0"/>
+            </a:solidFill>
+            <a:prstDash val="solid"/>
+          </a:ln>
+          <a:effectLst>
+            <a:outerShdw sx="100000" sy="100000" kx="0" ky="0" algn="bl" rotWithShape="0" blurRad="114300" dist="38100" dir="5400000">
+              <a:srgbClr val="0F172A">
+                <a:alpha val="14000"/>
+              </a:srgbClr>
+            </a:outerShdw>
+          </a:effectLst>
+        </p:spPr>
+      </p:sp>
+      <p:sp>
+        <p:nvSpPr>
+          <p:cNvPr id="11" name="Shape 9"/>
+          <p:cNvSpPr/>
+          <p:nvPr/>
+        </p:nvSpPr>
+        <p:spPr>
+          <a:xfrm>
+            <a:off x="868680" y="3648456"/>
+            <a:ext cx="457200" cy="457200"/>
+          </a:xfrm>
+          <a:prstGeom prst="ellipse">
+            <a:avLst/>
+          </a:prstGeom>
+          <a:solidFill>
+            <a:srgbClr val="6D28D9"/>
+          </a:solidFill>
+          <a:ln/>
+        </p:spPr>
+      </p:sp>
+      <p:sp>
+        <p:nvSpPr>
+          <p:cNvPr id="12" name="Text 10"/>
+          <p:cNvSpPr/>
+          <p:nvPr/>
+        </p:nvSpPr>
+        <p:spPr>
+          <a:xfrm>
+            <a:off x="868680" y="3648456"/>
+            <a:ext cx="457200" cy="457200"/>
+          </a:xfrm>
+          <a:prstGeom prst="rect">
+            <a:avLst/>
+          </a:prstGeom>
+          <a:noFill/>
+          <a:ln/>
+        </p:spPr>
+        <p:txBody>
+          <a:bodyPr wrap="square" lIns="0" tIns="0" rIns="0" bIns="0" rtlCol="0" anchor="ctr"/>
+          <a:lstStyle/>
+          <a:p>
+            <a:pPr algn="ctr" indent="0" marL="0">
+              <a:buNone/>
+            </a:pPr>
+            <a:r>
+              <a:rPr lang="en-US" sz="1800" b="1" dirty="0">
+                <a:solidFill>
+                  <a:srgbClr val="FFFFFF"/>
+                </a:solidFill>
+                <a:latin typeface="Calibri" pitchFamily="34" charset="0"/>
+                <a:ea typeface="Calibri" pitchFamily="34" charset="-122"/>
+                <a:cs typeface="Calibri" pitchFamily="34" charset="-120"/>
+              </a:rPr>
+              <a:t>2</a:t>
+            </a:r>
+            <a:endParaRPr lang="en-US" sz="1800" dirty="0"/>
+          </a:p>
+        </p:txBody>
+      </p:sp>
+      <p:sp>
+        <p:nvSpPr>
+          <p:cNvPr id="13" name="Text 11"/>
+          <p:cNvSpPr/>
+          <p:nvPr/>
+        </p:nvSpPr>
+        <p:spPr>
+          <a:xfrm>
+            <a:off x="1554480" y="3575304"/>
+            <a:ext cx="3840480" cy="594360"/>
+          </a:xfrm>
+          <a:prstGeom prst="rect">
+            <a:avLst/>
+          </a:prstGeom>
+          <a:noFill/>
+          <a:ln/>
+        </p:spPr>
+        <p:txBody>
+          <a:bodyPr wrap="square" lIns="0" tIns="0" rIns="0" bIns="0" rtlCol="0" anchor="ctr"/>
+          <a:lstStyle/>
+          <a:p>
+            <a:pPr indent="0" marL="0">
+              <a:buNone/>
+            </a:pPr>
+            <a:r>
+              <a:rPr lang="en-US" sz="1550" b="1" dirty="0">
+                <a:solidFill>
+                  <a:srgbClr val="1E293B"/>
+                </a:solidFill>
+                <a:latin typeface="Calibri" pitchFamily="34" charset="0"/>
+                <a:ea typeface="Calibri" pitchFamily="34" charset="-122"/>
+                <a:cs typeface="Calibri" pitchFamily="34" charset="-120"/>
+              </a:rPr>
+              <a:t>Add statistics</a:t>
+            </a:r>
+            <a:endParaRPr lang="en-US" sz="1550" dirty="0"/>
+          </a:p>
+        </p:txBody>
+      </p:sp>
+      <p:sp>
+        <p:nvSpPr>
+          <p:cNvPr id="14" name="Text 12"/>
+          <p:cNvSpPr/>
+          <p:nvPr/>
+        </p:nvSpPr>
+        <p:spPr>
+          <a:xfrm>
+            <a:off x="5486400" y="3575304"/>
+            <a:ext cx="5852160" cy="594360"/>
+          </a:xfrm>
+          <a:prstGeom prst="rect">
+            <a:avLst/>
+          </a:prstGeom>
+          <a:noFill/>
+          <a:ln/>
+        </p:spPr>
+        <p:txBody>
+          <a:bodyPr wrap="square" lIns="0" tIns="0" rIns="0" bIns="0" rtlCol="0" anchor="ctr"/>
+          <a:lstStyle/>
+          <a:p>
+            <a:pPr indent="0" marL="0">
+              <a:lnSpc>
+                <a:spcPct val="100000"/>
+              </a:lnSpc>
+              <a:buNone/>
+            </a:pPr>
+            <a:r>
+              <a:rPr lang="en-US" sz="1350" dirty="0">
+                <a:solidFill>
+                  <a:srgbClr val="64748B"/>
+                </a:solidFill>
+                <a:latin typeface="Calibri" pitchFamily="34" charset="0"/>
+                <a:ea typeface="Calibri" pitchFamily="34" charset="-122"/>
+                <a:cs typeface="Calibri" pitchFamily="34" charset="-120"/>
+              </a:rPr>
+              <a:t>Bootstrap the drift — a within-baseline split should drift ~0. Is 28.5 vs 5.0 real?</a:t>
+            </a:r>
+            <a:endParaRPr lang="en-US" sz="1350" dirty="0"/>
+          </a:p>
+        </p:txBody>
+      </p:sp>
+      <p:sp>
+        <p:nvSpPr>
+          <p:cNvPr id="15" name="Shape 13"/>
+          <p:cNvSpPr/>
+          <p:nvPr/>
+        </p:nvSpPr>
+        <p:spPr>
+          <a:xfrm>
+            <a:off x="640080" y="4398264"/>
+            <a:ext cx="10881360" cy="841248"/>
+          </a:xfrm>
+          <a:prstGeom prst="roundRect">
+            <a:avLst>
+              <a:gd name="adj" fmla="val 9783"/>
+            </a:avLst>
+          </a:prstGeom>
+          <a:solidFill>
+            <a:srgbClr val="FFFFFF"/>
+          </a:solidFill>
+          <a:ln w="12700">
+            <a:solidFill>
+              <a:srgbClr val="E2E8F0"/>
+            </a:solidFill>
+            <a:prstDash val="solid"/>
+          </a:ln>
+          <a:effectLst>
+            <a:outerShdw sx="100000" sy="100000" kx="0" ky="0" algn="bl" rotWithShape="0" blurRad="114300" dist="38100" dir="5400000">
+              <a:srgbClr val="0F172A">
+                <a:alpha val="14000"/>
+              </a:srgbClr>
+            </a:outerShdw>
+          </a:effectLst>
+        </p:spPr>
+      </p:sp>
+      <p:sp>
+        <p:nvSpPr>
+          <p:cNvPr id="16" name="Shape 14"/>
+          <p:cNvSpPr/>
+          <p:nvPr/>
+        </p:nvSpPr>
+        <p:spPr>
+          <a:xfrm>
+            <a:off x="868680" y="4590288"/>
+            <a:ext cx="457200" cy="457200"/>
+          </a:xfrm>
+          <a:prstGeom prst="ellipse">
+            <a:avLst/>
+          </a:prstGeom>
+          <a:solidFill>
+            <a:srgbClr val="0D9488"/>
+          </a:solidFill>
+          <a:ln/>
+        </p:spPr>
+      </p:sp>
+      <p:sp>
+        <p:nvSpPr>
+          <p:cNvPr id="17" name="Text 15"/>
+          <p:cNvSpPr/>
+          <p:nvPr/>
+        </p:nvSpPr>
+        <p:spPr>
+          <a:xfrm>
+            <a:off x="868680" y="4590288"/>
+            <a:ext cx="457200" cy="457200"/>
+          </a:xfrm>
+          <a:prstGeom prst="rect">
+            <a:avLst/>
+          </a:prstGeom>
+          <a:noFill/>
+          <a:ln/>
+        </p:spPr>
+        <p:txBody>
+          <a:bodyPr wrap="square" lIns="0" tIns="0" rIns="0" bIns="0" rtlCol="0" anchor="ctr"/>
+          <a:lstStyle/>
+          <a:p>
+            <a:pPr algn="ctr" indent="0" marL="0">
+              <a:buNone/>
+            </a:pPr>
+            <a:r>
+              <a:rPr lang="en-US" sz="1800" b="1" dirty="0">
+                <a:solidFill>
+                  <a:srgbClr val="FFFFFF"/>
+                </a:solidFill>
+                <a:latin typeface="Calibri" pitchFamily="34" charset="0"/>
+                <a:ea typeface="Calibri" pitchFamily="34" charset="-122"/>
+                <a:cs typeface="Calibri" pitchFamily="34" charset="-120"/>
+              </a:rPr>
+              <a:t>3</a:t>
+            </a:r>
+            <a:endParaRPr lang="en-US" sz="1800" dirty="0"/>
+          </a:p>
+        </p:txBody>
+      </p:sp>
+      <p:sp>
+        <p:nvSpPr>
+          <p:cNvPr id="18" name="Text 16"/>
+          <p:cNvSpPr/>
+          <p:nvPr/>
+        </p:nvSpPr>
+        <p:spPr>
+          <a:xfrm>
+            <a:off x="1554480" y="4517136"/>
+            <a:ext cx="3840480" cy="594360"/>
+          </a:xfrm>
+          <a:prstGeom prst="rect">
+            <a:avLst/>
+          </a:prstGeom>
+          <a:noFill/>
+          <a:ln/>
+        </p:spPr>
+        <p:txBody>
+          <a:bodyPr wrap="square" lIns="0" tIns="0" rIns="0" bIns="0" rtlCol="0" anchor="ctr"/>
+          <a:lstStyle/>
+          <a:p>
+            <a:pPr indent="0" marL="0">
+              <a:buNone/>
+            </a:pPr>
+            <a:r>
+              <a:rPr lang="en-US" sz="1550" b="1" dirty="0">
+                <a:solidFill>
+                  <a:srgbClr val="1E293B"/>
+                </a:solidFill>
+                <a:latin typeface="Calibri" pitchFamily="34" charset="0"/>
+                <a:ea typeface="Calibri" pitchFamily="34" charset="-122"/>
+                <a:cs typeface="Calibri" pitchFamily="34" charset="-120"/>
+              </a:rPr>
+              <a:t>Pool more animals</a:t>
+            </a:r>
+            <a:endParaRPr lang="en-US" sz="1550" dirty="0"/>
+          </a:p>
+        </p:txBody>
+      </p:sp>
+      <p:sp>
+        <p:nvSpPr>
+          <p:cNvPr id="19" name="Text 17"/>
+          <p:cNvSpPr/>
+          <p:nvPr/>
+        </p:nvSpPr>
+        <p:spPr>
+          <a:xfrm>
+            <a:off x="5486400" y="4517136"/>
+            <a:ext cx="5852160" cy="594360"/>
+          </a:xfrm>
+          <a:prstGeom prst="rect">
+            <a:avLst/>
+          </a:prstGeom>
+          <a:noFill/>
+          <a:ln/>
+        </p:spPr>
+        <p:txBody>
+          <a:bodyPr wrap="square" lIns="0" tIns="0" rIns="0" bIns="0" rtlCol="0" anchor="ctr"/>
+          <a:lstStyle/>
+          <a:p>
+            <a:pPr indent="0" marL="0">
+              <a:lnSpc>
+                <a:spcPct val="100000"/>
+              </a:lnSpc>
+              <a:buNone/>
+            </a:pPr>
+            <a:r>
+              <a:rPr lang="en-US" sz="1350" dirty="0">
+                <a:solidFill>
+                  <a:srgbClr val="64748B"/>
+                </a:solidFill>
+                <a:latin typeface="Calibri" pitchFamily="34" charset="0"/>
+                <a:ea typeface="Calibri" pitchFamily="34" charset="-122"/>
+                <a:cs typeface="Calibri" pitchFamily="34" charset="-120"/>
+              </a:rPr>
+              <a:t>Convert 6, 10, 11, 12, 13… one at a time, watching for animal-identity confounds.</a:t>
+            </a:r>
+            <a:endParaRPr lang="en-US" sz="1350" dirty="0"/>
+          </a:p>
+        </p:txBody>
+      </p:sp>
+      <p:sp>
+        <p:nvSpPr>
+          <p:cNvPr id="20" name="Shape 18"/>
+          <p:cNvSpPr/>
+          <p:nvPr/>
+        </p:nvSpPr>
+        <p:spPr>
+          <a:xfrm>
+            <a:off x="640080" y="5340096"/>
+            <a:ext cx="10881360" cy="841248"/>
+          </a:xfrm>
+          <a:prstGeom prst="roundRect">
+            <a:avLst>
+              <a:gd name="adj" fmla="val 9783"/>
+            </a:avLst>
+          </a:prstGeom>
+          <a:solidFill>
+            <a:srgbClr val="FFFFFF"/>
+          </a:solidFill>
+          <a:ln w="12700">
+            <a:solidFill>
+              <a:srgbClr val="E2E8F0"/>
+            </a:solidFill>
+            <a:prstDash val="solid"/>
+          </a:ln>
+          <a:effectLst>
+            <a:outerShdw sx="100000" sy="100000" kx="0" ky="0" algn="bl" rotWithShape="0" blurRad="114300" dist="38100" dir="5400000">
+              <a:srgbClr val="0F172A">
+                <a:alpha val="14000"/>
+              </a:srgbClr>
+            </a:outerShdw>
+          </a:effectLst>
+        </p:spPr>
+      </p:sp>
+      <p:sp>
+        <p:nvSpPr>
           <p:cNvPr id="21" name="Shape 19"/>
           <p:cNvSpPr/>
           <p:nvPr/>
@@ -4466,9 +4901,9 @@
 </p:sld>
 </file>
 
-<file path=ppt/slides/slide14.xml><?xml version="1.0" encoding="utf-8"?>
+<file path=ppt/slides/slide15.xml><?xml version="1.0" encoding="utf-8"?>
 <p:sld xmlns:a="http://schemas.openxmlformats.org/drawingml/2006/main" xmlns:r="http://schemas.openxmlformats.org/officeDocument/2006/relationships" xmlns:p="http://schemas.openxmlformats.org/presentationml/2006/main">
-  <p:cSld name="Slide 14">
+  <p:cSld name="Slide 15">
     <p:bg>
       <p:bgPr>
         <a:solidFill>
@@ -9440,7 +9875,7 @@
                 <a:ea typeface="Calibri" pitchFamily="34" charset="-122"/>
                 <a:cs typeface="Calibri" pitchFamily="34" charset="-120"/>
               </a:rPr>
-              <a:t>RESULT 1</a:t>
+              <a:t>PLAIN ENGLISH — A QUICK CHEAT SHEET</a:t>
             </a:r>
             <a:endParaRPr lang="en-US" sz="1250" dirty="0"/>
           </a:p>
@@ -9479,53 +9914,30 @@
                 <a:ea typeface="Cambria" pitchFamily="34" charset="-122"/>
                 <a:cs typeface="Cambria" pitchFamily="34" charset="-120"/>
               </a:rPr>
-              <a:t>The fingerprint really does carry the reflex</a:t>
+              <a:t>How to read the next three slides</a:t>
             </a:r>
             <a:endParaRPr lang="en-US" sz="3000" dirty="0"/>
           </a:p>
         </p:txBody>
       </p:sp>
-      <p:pic>
-        <p:nvPicPr>
-          <p:cNvPr id="4" name="Image 0" descr="outputs/phase2_loss.png">    </p:cNvPr>
-          <p:cNvPicPr>
-            <a:picLocks noChangeAspect="1"/>
-          </p:cNvPicPr>
-          <p:nvPr/>
-        </p:nvPicPr>
-        <p:blipFill>
-          <a:blip r:embed="rId1"/>
-          <a:srcRect l="0" r="0" t="0" b="0"/>
-          <a:stretch/>
-        </p:blipFill>
-        <p:spPr>
-          <a:xfrm>
-            <a:off x="640080" y="1828800"/>
-            <a:ext cx="5563210" cy="3566160"/>
-          </a:xfrm>
-          <a:prstGeom prst="rect">
-            <a:avLst/>
-          </a:prstGeom>
-        </p:spPr>
-      </p:pic>
-      <p:sp>
-        <p:nvSpPr>
-          <p:cNvPr id="5" name="Shape 2"/>
-          <p:cNvSpPr/>
-          <p:nvPr/>
-        </p:nvSpPr>
-        <p:spPr>
-          <a:xfrm>
-            <a:off x="7040880" y="1920240"/>
-            <a:ext cx="4480560" cy="1874520"/>
+      <p:sp>
+        <p:nvSpPr>
+          <p:cNvPr id="4" name="Shape 2"/>
+          <p:cNvSpPr/>
+          <p:nvPr/>
+        </p:nvSpPr>
+        <p:spPr>
+          <a:xfrm>
+            <a:off x="640080" y="1783080"/>
+            <a:ext cx="5349240" cy="1965960"/>
           </a:xfrm>
           <a:prstGeom prst="roundRect">
             <a:avLst>
-              <a:gd name="adj" fmla="val 4390"/>
+              <a:gd name="adj" fmla="val 4186"/>
             </a:avLst>
           </a:prstGeom>
           <a:solidFill>
-            <a:srgbClr val="F1F5F9"/>
+            <a:srgbClr val="FFFFFF"/>
           </a:solidFill>
           <a:ln w="12700">
             <a:solidFill>
@@ -9544,69 +9956,92 @@
       </p:sp>
       <p:sp>
         <p:nvSpPr>
-          <p:cNvPr id="6" name="Text 3"/>
-          <p:cNvSpPr/>
-          <p:nvPr/>
-        </p:nvSpPr>
-        <p:spPr>
-          <a:xfrm>
-            <a:off x="7040880" y="2084832"/>
-            <a:ext cx="4480560" cy="868680"/>
-          </a:xfrm>
-          <a:prstGeom prst="rect">
-            <a:avLst/>
-          </a:prstGeom>
-          <a:noFill/>
-          <a:ln/>
-        </p:spPr>
-        <p:txBody>
-          <a:bodyPr wrap="square" lIns="0" tIns="0" rIns="0" bIns="0" rtlCol="0" anchor="ctr"/>
-          <a:lstStyle/>
-          <a:p>
-            <a:pPr algn="ctr" indent="0" marL="0">
-              <a:buNone/>
-            </a:pPr>
-            <a:r>
-              <a:rPr lang="en-US" sz="4600" b="1" dirty="0">
-                <a:solidFill>
-                  <a:srgbClr val="0D9488"/>
-                </a:solidFill>
-                <a:latin typeface="Cambria" pitchFamily="34" charset="0"/>
-                <a:ea typeface="Cambria" pitchFamily="34" charset="-122"/>
-                <a:cs typeface="Cambria" pitchFamily="34" charset="-120"/>
-              </a:rPr>
-              <a:t>R² = 0.17</a:t>
-            </a:r>
-            <a:endParaRPr lang="en-US" sz="4600" dirty="0"/>
-          </a:p>
-        </p:txBody>
-      </p:sp>
-      <p:sp>
-        <p:nvSpPr>
-          <p:cNvPr id="7" name="Text 4"/>
-          <p:cNvSpPr/>
-          <p:nvPr/>
-        </p:nvSpPr>
-        <p:spPr>
-          <a:xfrm>
-            <a:off x="7040880" y="2971800"/>
-            <a:ext cx="4480560" cy="640080"/>
-          </a:xfrm>
-          <a:prstGeom prst="rect">
-            <a:avLst/>
-          </a:prstGeom>
-          <a:noFill/>
-          <a:ln/>
-        </p:spPr>
-        <p:txBody>
-          <a:bodyPr wrap="square" lIns="0" tIns="0" rIns="0" bIns="0" rtlCol="0" anchor="ctr"/>
-          <a:lstStyle/>
-          <a:p>
-            <a:pPr algn="ctr" indent="0" marL="0">
-              <a:buNone/>
-            </a:pPr>
-            <a:r>
-              <a:rPr lang="en-US" sz="1350" dirty="0">
+          <p:cNvPr id="5" name="Shape 3"/>
+          <p:cNvSpPr/>
+          <p:nvPr/>
+        </p:nvSpPr>
+        <p:spPr>
+          <a:xfrm>
+            <a:off x="932688" y="2093976"/>
+            <a:ext cx="201168" cy="201168"/>
+          </a:xfrm>
+          <a:prstGeom prst="ellipse">
+            <a:avLst/>
+          </a:prstGeom>
+          <a:solidFill>
+            <a:srgbClr val="6D28D9"/>
+          </a:solidFill>
+          <a:ln/>
+        </p:spPr>
+      </p:sp>
+      <p:sp>
+        <p:nvSpPr>
+          <p:cNvPr id="6" name="Text 4"/>
+          <p:cNvSpPr/>
+          <p:nvPr/>
+        </p:nvSpPr>
+        <p:spPr>
+          <a:xfrm>
+            <a:off x="1261872" y="2020824"/>
+            <a:ext cx="4434840" cy="411480"/>
+          </a:xfrm>
+          <a:prstGeom prst="rect">
+            <a:avLst/>
+          </a:prstGeom>
+          <a:noFill/>
+          <a:ln/>
+        </p:spPr>
+        <p:txBody>
+          <a:bodyPr wrap="square" lIns="0" tIns="0" rIns="0" bIns="0" rtlCol="0" anchor="ctr"/>
+          <a:lstStyle/>
+          <a:p>
+            <a:pPr indent="0" marL="0">
+              <a:buNone/>
+            </a:pPr>
+            <a:r>
+              <a:rPr lang="en-US" sz="1800" b="1" dirty="0">
+                <a:solidFill>
+                  <a:srgbClr val="1E293B"/>
+                </a:solidFill>
+                <a:latin typeface="Calibri" pitchFamily="34" charset="0"/>
+                <a:ea typeface="Calibri" pitchFamily="34" charset="-122"/>
+                <a:cs typeface="Calibri" pitchFamily="34" charset="-120"/>
+              </a:rPr>
+              <a:t>The fingerprint</a:t>
+            </a:r>
+            <a:endParaRPr lang="en-US" sz="1800" dirty="0"/>
+          </a:p>
+        </p:txBody>
+      </p:sp>
+      <p:sp>
+        <p:nvSpPr>
+          <p:cNvPr id="7" name="Text 5"/>
+          <p:cNvSpPr/>
+          <p:nvPr/>
+        </p:nvSpPr>
+        <p:spPr>
+          <a:xfrm>
+            <a:off x="960120" y="2606040"/>
+            <a:ext cx="4709160" cy="1005840"/>
+          </a:xfrm>
+          <a:prstGeom prst="rect">
+            <a:avLst/>
+          </a:prstGeom>
+          <a:noFill/>
+          <a:ln/>
+        </p:spPr>
+        <p:txBody>
+          <a:bodyPr wrap="square" lIns="0" tIns="0" rIns="0" bIns="0" rtlCol="0" anchor="ctr"/>
+          <a:lstStyle/>
+          <a:p>
+            <a:pPr indent="0" marL="0">
+              <a:lnSpc>
+                <a:spcPct val="106000"/>
+              </a:lnSpc>
+              <a:buNone/>
+            </a:pPr>
+            <a:r>
+              <a:rPr lang="en-US" sz="1450" dirty="0">
                 <a:solidFill>
                   <a:srgbClr val="64748B"/>
                 </a:solidFill>
@@ -9614,22 +10049,115 @@
                 <a:ea typeface="Calibri" pitchFamily="34" charset="-122"/>
                 <a:cs typeface="Calibri" pitchFamily="34" charset="-120"/>
               </a:rPr>
-              <a:t>brain fingerprint → H-reflex, frozen encoder</a:t>
-            </a:r>
-            <a:endParaRPr lang="en-US" sz="1350" dirty="0"/>
-          </a:p>
-        </p:txBody>
-      </p:sp>
-      <p:sp>
-        <p:nvSpPr>
-          <p:cNvPr id="8" name="Text 5"/>
-          <p:cNvSpPr/>
-          <p:nvPr/>
-        </p:nvSpPr>
-        <p:spPr>
-          <a:xfrm>
-            <a:off x="7040880" y="3977640"/>
-            <a:ext cx="4480560" cy="1371600"/>
+              <a:t>48 numbers the model invents to summarize each brain trace. Nobody tells it what to look for — it finds its own summary.</a:t>
+            </a:r>
+            <a:endParaRPr lang="en-US" sz="1450" dirty="0"/>
+          </a:p>
+        </p:txBody>
+      </p:sp>
+      <p:sp>
+        <p:nvSpPr>
+          <p:cNvPr id="8" name="Shape 6"/>
+          <p:cNvSpPr/>
+          <p:nvPr/>
+        </p:nvSpPr>
+        <p:spPr>
+          <a:xfrm>
+            <a:off x="6309360" y="1783080"/>
+            <a:ext cx="5349240" cy="1965960"/>
+          </a:xfrm>
+          <a:prstGeom prst="roundRect">
+            <a:avLst>
+              <a:gd name="adj" fmla="val 4186"/>
+            </a:avLst>
+          </a:prstGeom>
+          <a:solidFill>
+            <a:srgbClr val="FFFFFF"/>
+          </a:solidFill>
+          <a:ln w="12700">
+            <a:solidFill>
+              <a:srgbClr val="E2E8F0"/>
+            </a:solidFill>
+            <a:prstDash val="solid"/>
+          </a:ln>
+          <a:effectLst>
+            <a:outerShdw sx="100000" sy="100000" kx="0" ky="0" algn="bl" rotWithShape="0" blurRad="114300" dist="38100" dir="5400000">
+              <a:srgbClr val="0F172A">
+                <a:alpha val="14000"/>
+              </a:srgbClr>
+            </a:outerShdw>
+          </a:effectLst>
+        </p:spPr>
+      </p:sp>
+      <p:sp>
+        <p:nvSpPr>
+          <p:cNvPr id="9" name="Shape 7"/>
+          <p:cNvSpPr/>
+          <p:nvPr/>
+        </p:nvSpPr>
+        <p:spPr>
+          <a:xfrm>
+            <a:off x="6601968" y="2093976"/>
+            <a:ext cx="201168" cy="201168"/>
+          </a:xfrm>
+          <a:prstGeom prst="ellipse">
+            <a:avLst/>
+          </a:prstGeom>
+          <a:solidFill>
+            <a:srgbClr val="0D9488"/>
+          </a:solidFill>
+          <a:ln/>
+        </p:spPr>
+      </p:sp>
+      <p:sp>
+        <p:nvSpPr>
+          <p:cNvPr id="10" name="Text 8"/>
+          <p:cNvSpPr/>
+          <p:nvPr/>
+        </p:nvSpPr>
+        <p:spPr>
+          <a:xfrm>
+            <a:off x="6931152" y="2020824"/>
+            <a:ext cx="4434840" cy="411480"/>
+          </a:xfrm>
+          <a:prstGeom prst="rect">
+            <a:avLst/>
+          </a:prstGeom>
+          <a:noFill/>
+          <a:ln/>
+        </p:spPr>
+        <p:txBody>
+          <a:bodyPr wrap="square" lIns="0" tIns="0" rIns="0" bIns="0" rtlCol="0" anchor="ctr"/>
+          <a:lstStyle/>
+          <a:p>
+            <a:pPr indent="0" marL="0">
+              <a:buNone/>
+            </a:pPr>
+            <a:r>
+              <a:rPr lang="en-US" sz="1800" b="1" dirty="0">
+                <a:solidFill>
+                  <a:srgbClr val="1E293B"/>
+                </a:solidFill>
+                <a:latin typeface="Calibri" pitchFamily="34" charset="0"/>
+                <a:ea typeface="Calibri" pitchFamily="34" charset="-122"/>
+                <a:cs typeface="Calibri" pitchFamily="34" charset="-120"/>
+              </a:rPr>
+              <a:t>R²  (a 0-to-1 score)</a:t>
+            </a:r>
+            <a:endParaRPr lang="en-US" sz="1800" dirty="0"/>
+          </a:p>
+        </p:txBody>
+      </p:sp>
+      <p:sp>
+        <p:nvSpPr>
+          <p:cNvPr id="11" name="Text 9"/>
+          <p:cNvSpPr/>
+          <p:nvPr/>
+        </p:nvSpPr>
+        <p:spPr>
+          <a:xfrm>
+            <a:off x="6629400" y="2606040"/>
+            <a:ext cx="4709160" cy="1005840"/>
           </a:xfrm>
           <a:prstGeom prst="rect">
             <a:avLst/>
@@ -9643,12 +10171,105 @@
           <a:p>
             <a:pPr indent="0" marL="0">
               <a:lnSpc>
-                <a:spcPct val="105000"/>
+                <a:spcPct val="106000"/>
               </a:lnSpc>
               <a:buNone/>
             </a:pPr>
             <a:r>
-              <a:rPr lang="en-US" sz="1450" b="1" dirty="0">
+              <a:rPr lang="en-US" sz="1450" dirty="0">
+                <a:solidFill>
+                  <a:srgbClr val="64748B"/>
+                </a:solidFill>
+                <a:latin typeface="Calibri" pitchFamily="34" charset="0"/>
+                <a:ea typeface="Calibri" pitchFamily="34" charset="-122"/>
+                <a:cs typeface="Calibri" pitchFamily="34" charset="-120"/>
+              </a:rPr>
+              <a:t>How much of the reflex's trial-to-trial change the fingerprint can explain. 0 = nothing, 1 = perfect. We get 0.17 — weak but real, above chance.</a:t>
+            </a:r>
+            <a:endParaRPr lang="en-US" sz="1450" dirty="0"/>
+          </a:p>
+        </p:txBody>
+      </p:sp>
+      <p:sp>
+        <p:nvSpPr>
+          <p:cNvPr id="12" name="Shape 10"/>
+          <p:cNvSpPr/>
+          <p:nvPr/>
+        </p:nvSpPr>
+        <p:spPr>
+          <a:xfrm>
+            <a:off x="640080" y="4069080"/>
+            <a:ext cx="5349240" cy="1965960"/>
+          </a:xfrm>
+          <a:prstGeom prst="roundRect">
+            <a:avLst>
+              <a:gd name="adj" fmla="val 4186"/>
+            </a:avLst>
+          </a:prstGeom>
+          <a:solidFill>
+            <a:srgbClr val="FFFFFF"/>
+          </a:solidFill>
+          <a:ln w="12700">
+            <a:solidFill>
+              <a:srgbClr val="E2E8F0"/>
+            </a:solidFill>
+            <a:prstDash val="solid"/>
+          </a:ln>
+          <a:effectLst>
+            <a:outerShdw sx="100000" sy="100000" kx="0" ky="0" algn="bl" rotWithShape="0" blurRad="114300" dist="38100" dir="5400000">
+              <a:srgbClr val="0F172A">
+                <a:alpha val="14000"/>
+              </a:srgbClr>
+            </a:outerShdw>
+          </a:effectLst>
+        </p:spPr>
+      </p:sp>
+      <p:sp>
+        <p:nvSpPr>
+          <p:cNvPr id="13" name="Shape 11"/>
+          <p:cNvSpPr/>
+          <p:nvPr/>
+        </p:nvSpPr>
+        <p:spPr>
+          <a:xfrm>
+            <a:off x="932688" y="4379976"/>
+            <a:ext cx="201168" cy="201168"/>
+          </a:xfrm>
+          <a:prstGeom prst="ellipse">
+            <a:avLst/>
+          </a:prstGeom>
+          <a:solidFill>
+            <a:srgbClr val="6D28D9"/>
+          </a:solidFill>
+          <a:ln/>
+        </p:spPr>
+      </p:sp>
+      <p:sp>
+        <p:nvSpPr>
+          <p:cNvPr id="14" name="Text 12"/>
+          <p:cNvSpPr/>
+          <p:nvPr/>
+        </p:nvSpPr>
+        <p:spPr>
+          <a:xfrm>
+            <a:off x="1261872" y="4306824"/>
+            <a:ext cx="4434840" cy="411480"/>
+          </a:xfrm>
+          <a:prstGeom prst="rect">
+            <a:avLst/>
+          </a:prstGeom>
+          <a:noFill/>
+          <a:ln/>
+        </p:spPr>
+        <p:txBody>
+          <a:bodyPr wrap="square" lIns="0" tIns="0" rIns="0" bIns="0" rtlCol="0" anchor="ctr"/>
+          <a:lstStyle/>
+          <a:p>
+            <a:pPr indent="0" marL="0">
+              <a:buNone/>
+            </a:pPr>
+            <a:r>
+              <a:rPr lang="en-US" sz="1800" b="1" dirty="0">
                 <a:solidFill>
                   <a:srgbClr val="1E293B"/>
                 </a:solidFill>
@@ -9656,68 +10277,186 @@
                 <a:ea typeface="Calibri" pitchFamily="34" charset="-122"/>
                 <a:cs typeface="Calibri" pitchFamily="34" charset="-120"/>
               </a:rPr>
-              <a:t>Read it honestly. </a:t>
-            </a:r>
+              <a:t>Drift</a:t>
+            </a:r>
+            <a:endParaRPr lang="en-US" sz="1800" dirty="0"/>
+          </a:p>
+        </p:txBody>
+      </p:sp>
+      <p:sp>
+        <p:nvSpPr>
+          <p:cNvPr id="15" name="Text 13"/>
+          <p:cNvSpPr/>
+          <p:nvPr/>
+        </p:nvSpPr>
+        <p:spPr>
+          <a:xfrm>
+            <a:off x="960120" y="4892040"/>
+            <a:ext cx="4709160" cy="1005840"/>
+          </a:xfrm>
+          <a:prstGeom prst="rect">
+            <a:avLst/>
+          </a:prstGeom>
+          <a:noFill/>
+          <a:ln/>
+        </p:spPr>
+        <p:txBody>
+          <a:bodyPr wrap="square" lIns="0" tIns="0" rIns="0" bIns="0" rtlCol="0" anchor="ctr"/>
+          <a:lstStyle/>
+          <a:p>
             <a:pPr indent="0" marL="0">
               <a:lnSpc>
-                <a:spcPct val="105000"/>
+                <a:spcPct val="106000"/>
               </a:lnSpc>
               <a:buNone/>
             </a:pPr>
             <a:r>
               <a:rPr lang="en-US" sz="1450" dirty="0">
                 <a:solidFill>
+                  <a:srgbClr val="64748B"/>
+                </a:solidFill>
+                <a:latin typeface="Calibri" pitchFamily="34" charset="0"/>
+                <a:ea typeface="Calibri" pitchFamily="34" charset="-122"/>
+                <a:cs typeface="Calibri" pitchFamily="34" charset="-120"/>
+              </a:rPr>
+              <a:t>How far the average brain state has moved from where it started at Baseline. A bigger number means the representation changed more.</a:t>
+            </a:r>
+            <a:endParaRPr lang="en-US" sz="1450" dirty="0"/>
+          </a:p>
+        </p:txBody>
+      </p:sp>
+      <p:sp>
+        <p:nvSpPr>
+          <p:cNvPr id="16" name="Shape 14"/>
+          <p:cNvSpPr/>
+          <p:nvPr/>
+        </p:nvSpPr>
+        <p:spPr>
+          <a:xfrm>
+            <a:off x="6309360" y="4069080"/>
+            <a:ext cx="5349240" cy="1965960"/>
+          </a:xfrm>
+          <a:prstGeom prst="roundRect">
+            <a:avLst>
+              <a:gd name="adj" fmla="val 4186"/>
+            </a:avLst>
+          </a:prstGeom>
+          <a:solidFill>
+            <a:srgbClr val="FEF3E2"/>
+          </a:solidFill>
+          <a:ln w="12700">
+            <a:solidFill>
+              <a:srgbClr val="E2E8F0"/>
+            </a:solidFill>
+            <a:prstDash val="solid"/>
+          </a:ln>
+          <a:effectLst>
+            <a:outerShdw sx="100000" sy="100000" kx="0" ky="0" algn="bl" rotWithShape="0" blurRad="114300" dist="38100" dir="5400000">
+              <a:srgbClr val="0F172A">
+                <a:alpha val="14000"/>
+              </a:srgbClr>
+            </a:outerShdw>
+          </a:effectLst>
+        </p:spPr>
+      </p:sp>
+      <p:sp>
+        <p:nvSpPr>
+          <p:cNvPr id="17" name="Shape 15"/>
+          <p:cNvSpPr/>
+          <p:nvPr/>
+        </p:nvSpPr>
+        <p:spPr>
+          <a:xfrm>
+            <a:off x="6601968" y="4379976"/>
+            <a:ext cx="201168" cy="201168"/>
+          </a:xfrm>
+          <a:prstGeom prst="ellipse">
+            <a:avLst/>
+          </a:prstGeom>
+          <a:solidFill>
+            <a:srgbClr val="D97706"/>
+          </a:solidFill>
+          <a:ln/>
+        </p:spPr>
+      </p:sp>
+      <p:sp>
+        <p:nvSpPr>
+          <p:cNvPr id="18" name="Text 16"/>
+          <p:cNvSpPr/>
+          <p:nvPr/>
+        </p:nvSpPr>
+        <p:spPr>
+          <a:xfrm>
+            <a:off x="6931152" y="4306824"/>
+            <a:ext cx="4434840" cy="411480"/>
+          </a:xfrm>
+          <a:prstGeom prst="rect">
+            <a:avLst/>
+          </a:prstGeom>
+          <a:noFill/>
+          <a:ln/>
+        </p:spPr>
+        <p:txBody>
+          <a:bodyPr wrap="square" lIns="0" tIns="0" rIns="0" bIns="0" rtlCol="0" anchor="ctr"/>
+          <a:lstStyle/>
+          <a:p>
+            <a:pPr indent="0" marL="0">
+              <a:buNone/>
+            </a:pPr>
+            <a:r>
+              <a:rPr lang="en-US" sz="1800" b="1" dirty="0">
+                <a:solidFill>
                   <a:srgbClr val="1E293B"/>
                 </a:solidFill>
                 <a:latin typeface="Calibri" pitchFamily="34" charset="0"/>
                 <a:ea typeface="Calibri" pitchFamily="34" charset="-122"/>
                 <a:cs typeface="Calibri" pitchFamily="34" charset="-120"/>
               </a:rPr>
-              <a:t>The cortical fingerprint predicts ~17% of the reflex's variation — with no labels during learning. Modest, but real and well above chance.</a:t>
+              <a:t>The catch</a:t>
+            </a:r>
+            <a:endParaRPr lang="en-US" sz="1800" dirty="0"/>
+          </a:p>
+        </p:txBody>
+      </p:sp>
+      <p:sp>
+        <p:nvSpPr>
+          <p:cNvPr id="19" name="Text 17"/>
+          <p:cNvSpPr/>
+          <p:nvPr/>
+        </p:nvSpPr>
+        <p:spPr>
+          <a:xfrm>
+            <a:off x="6629400" y="4892040"/>
+            <a:ext cx="4709160" cy="1005840"/>
+          </a:xfrm>
+          <a:prstGeom prst="rect">
+            <a:avLst/>
+          </a:prstGeom>
+          <a:noFill/>
+          <a:ln/>
+        </p:spPr>
+        <p:txBody>
+          <a:bodyPr wrap="square" lIns="0" tIns="0" rIns="0" bIns="0" rtlCol="0" anchor="ctr"/>
+          <a:lstStyle/>
+          <a:p>
+            <a:pPr indent="0" marL="0">
+              <a:lnSpc>
+                <a:spcPct val="106000"/>
+              </a:lnSpc>
+              <a:buNone/>
+            </a:pPr>
+            <a:r>
+              <a:rPr lang="en-US" sz="1450" dirty="0">
+                <a:solidFill>
+                  <a:srgbClr val="64748B"/>
+                </a:solidFill>
+                <a:latin typeface="Calibri" pitchFamily="34" charset="0"/>
+                <a:ea typeface="Calibri" pitchFamily="34" charset="-122"/>
+                <a:cs typeface="Calibri" pitchFamily="34" charset="-120"/>
+              </a:rPr>
+              <a:t>Some of that movement might come from the recording setup changing, not from learning. That's the one thing we still have to rule out.</a:t>
             </a:r>
             <a:endParaRPr lang="en-US" sz="1450" dirty="0"/>
-          </a:p>
-        </p:txBody>
-      </p:sp>
-      <p:sp>
-        <p:nvSpPr>
-          <p:cNvPr id="9" name="Text 6"/>
-          <p:cNvSpPr/>
-          <p:nvPr/>
-        </p:nvSpPr>
-        <p:spPr>
-          <a:xfrm>
-            <a:off x="7040880" y="5440680"/>
-            <a:ext cx="4480560" cy="822960"/>
-          </a:xfrm>
-          <a:prstGeom prst="rect">
-            <a:avLst/>
-          </a:prstGeom>
-          <a:noFill/>
-          <a:ln/>
-        </p:spPr>
-        <p:txBody>
-          <a:bodyPr wrap="square" lIns="0" tIns="0" rIns="0" bIns="0" rtlCol="0" anchor="ctr"/>
-          <a:lstStyle/>
-          <a:p>
-            <a:pPr indent="0" marL="0">
-              <a:lnSpc>
-                <a:spcPct val="103000"/>
-              </a:lnSpc>
-              <a:buNone/>
-            </a:pPr>
-            <a:r>
-              <a:rPr lang="en-US" sz="1250" i="1" dirty="0">
-                <a:solidFill>
-                  <a:srgbClr val="D97706"/>
-                </a:solidFill>
-                <a:latin typeface="Calibri" pitchFamily="34" charset="0"/>
-                <a:ea typeface="Calibri" pitchFamily="34" charset="-122"/>
-                <a:cs typeface="Calibri" pitchFamily="34" charset="-120"/>
-              </a:rPr>
-              <a:t>On synthetic data this was 0.90 — only because that data was built to encode the reflex. 0.17 is the real cortex.</a:t>
-            </a:r>
-            <a:endParaRPr lang="en-US" sz="1250" dirty="0"/>
           </a:p>
         </p:txBody>
       </p:sp>

</xml_diff>

<commit_message>
Deck: swap in neuro-accurate figures + add 10-min talk script
Result slides now use the confound-controlled analysis: H/M learning curve
(down-conditioning worked), M-regressed drift (survives the stimulus control),
and an honest R2 breakdown (stimulus 0.20 vs cortex-only 0.04). Corrected the
phase slide and scorecard. Adds slides/PRESENTATION_SCRIPT.md — a per-slide
10-minute talk track with anticipated Q&A.

Co-Authored-By: Claude Opus 4.8 <noreply@anthropic.com>
</commit_message>
<xml_diff>
--- a/slides/HROC_Carp_Update_Animal9.pptx
+++ b/slides/HROC_Carp_Update_Animal9.pptx
@@ -604,7 +604,7 @@
           <a:p>
             <a:r>
               <a:rPr lang="en-US" dirty="0"/>
-              <a:t>Here's the test that makes the fingerprint trustworthy. Freeze the model, ask a tiny predictor to read the H-reflex off the fingerprint. R-squared 0.17 on real cortex. The green line climbing is it getting better at reading the reflex. It's far below the synthetic 0.90 — but that's expected and honest: the synthetic ECoG was built to encode the reflex; real cortex is far noisier. 0.17 with zero labels during learning is a genuine signal.</a:t>
+              <a:t>Start the results with the behaviour, because it's the cleanest thing we have. Left: H/M ratio over time — flat at baseline, then a steady drop to about 0.18. That's textbook successful down-conditioning. Crucial point: we use H/M, not raw H, because the H-reflex depends on stimulus strength — and the right panel shows the stimulus drifted up over the same period. That's why an earlier raw-H plot looked backwards; it was plotting stimulus, not learning. This slide is the fix.</a:t>
             </a:r>
             <a:endParaRPr lang="en-US" dirty="0"/>
           </a:p>
@@ -692,7 +692,7 @@
           <a:p>
             <a:r>
               <a:rPr lang="en-US" dirty="0"/>
-              <a:t>This is the research question in one picture. Each phase's average cortical fingerprint, distance from baseline. It climbs sharply during down-conditioning and returns toward baseline afterward. The brain representation shifts as the cord learns and partly recovers when training stops. On a clean dataset, this figure is the paper. But — next slide — there's a confound to resolve first.</a:t>
+              <a:t>This is the test a reviewer will demand. The worry: if the stimulus drove both the reflex and the cortex, the drift is meaningless. So we regress the M-wave out of the brain fingerprint and recompute. The grey and purple lines sit right on top of each other — removing the stimulus barely changes the drift. So the cortical change is real, not a stimulus artifact. Honest caveat: the drift is largest at conditioning onset and then eases, so the cortex is reacting to the task rather than tracking the reflex size step for step.</a:t>
             </a:r>
             <a:endParaRPr lang="en-US" dirty="0"/>
           </a:p>
@@ -780,7 +780,7 @@
           <a:p>
             <a:r>
               <a:rPr lang="en-US" dirty="0"/>
-              <a:t>I want to be upfront. The H-reflex is HIGHER during down-conditioning, which is backwards — down-conditioning should shrink it. The likely reason: the 'Baseline' block is really the setup/characterization period, where the stimulus intensity is still being tuned (the log is full of TARG adjustments). So the cortical drift might partly reflect overall session state rather than the learning. This is the single most important thing to nail down before we call it a cortical correlate of conditioning — and it's exactly where I need your input.</a:t>
+              <a:t>The prediction result, done honestly. We ask how much of the reflex each thing explains. The stimulus alone explains 0.20 — that's the confound, and it's the biggest piece. The cortex on its own is only 0.05. And when we remove the stimulus, the cortex's unique contribution is 0.04 — small, but it survives the control, so it's genuinely there. Important honesty point: the 0.17 I showed earlier was inflated because the cortical window contains a stimulus-evoked response; once you control for the stimulus, the real cortex-to-reflex link is modest.</a:t>
             </a:r>
             <a:endParaRPr lang="en-US" dirty="0"/>
           </a:p>
@@ -2423,7 +2423,7 @@
                 <a:ea typeface="Calibri" pitchFamily="34" charset="-122"/>
                 <a:cs typeface="Calibri" pitchFamily="34" charset="-120"/>
               </a:rPr>
-              <a:t>RESULT 1</a:t>
+              <a:t>RESULT 1 · THE BEHAVIOUR IS REAL</a:t>
             </a:r>
             <a:endParaRPr lang="en-US" sz="1250" dirty="0"/>
           </a:p>
@@ -2462,7 +2462,7 @@
                 <a:ea typeface="Cambria" pitchFamily="34" charset="-122"/>
                 <a:cs typeface="Cambria" pitchFamily="34" charset="-120"/>
               </a:rPr>
-              <a:t>The fingerprint really does carry the reflex</a:t>
+              <a:t>Down-conditioning worked — the textbook curve</a:t>
             </a:r>
             <a:endParaRPr lang="en-US" sz="3000" dirty="0"/>
           </a:p>
@@ -2470,7 +2470,7 @@
       </p:sp>
       <p:pic>
         <p:nvPicPr>
-          <p:cNvPr id="4" name="Image 0" descr="outputs/phase2_loss.png">    </p:cNvPr>
+          <p:cNvPr id="4" name="Image 0" descr="outputs/confound/learning_curve.png">    </p:cNvPr>
           <p:cNvPicPr>
             <a:picLocks noChangeAspect="1"/>
           </p:cNvPicPr>
@@ -2483,8 +2483,8 @@
         </p:blipFill>
         <p:spPr>
           <a:xfrm>
-            <a:off x="640080" y="1828800"/>
-            <a:ext cx="5563210" cy="3566160"/>
+            <a:off x="594360" y="1828800"/>
+            <a:ext cx="7315200" cy="2594043"/>
           </a:xfrm>
           <a:prstGeom prst="rect">
             <a:avLst/>
@@ -2499,16 +2499,16 @@
         </p:nvSpPr>
         <p:spPr>
           <a:xfrm>
-            <a:off x="7040880" y="1920240"/>
-            <a:ext cx="4480560" cy="1874520"/>
+            <a:off x="8138160" y="1920240"/>
+            <a:ext cx="3429000" cy="3794760"/>
           </a:xfrm>
           <a:prstGeom prst="roundRect">
             <a:avLst>
-              <a:gd name="adj" fmla="val 4390"/>
+              <a:gd name="adj" fmla="val 2400"/>
             </a:avLst>
           </a:prstGeom>
           <a:solidFill>
-            <a:srgbClr val="F1F5F9"/>
+            <a:srgbClr val="F5F3FF"/>
           </a:solidFill>
           <a:ln w="12700">
             <a:solidFill>
@@ -2533,34 +2533,34 @@
         </p:nvSpPr>
         <p:spPr>
           <a:xfrm>
-            <a:off x="7040880" y="2084832"/>
-            <a:ext cx="4480560" cy="868680"/>
-          </a:xfrm>
-          <a:prstGeom prst="rect">
-            <a:avLst/>
-          </a:prstGeom>
-          <a:noFill/>
-          <a:ln/>
-        </p:spPr>
-        <p:txBody>
-          <a:bodyPr wrap="square" lIns="0" tIns="0" rIns="0" bIns="0" rtlCol="0" anchor="ctr"/>
-          <a:lstStyle/>
-          <a:p>
-            <a:pPr algn="ctr" indent="0" marL="0">
-              <a:buNone/>
-            </a:pPr>
-            <a:r>
-              <a:rPr lang="en-US" sz="4600" b="1" dirty="0">
-                <a:solidFill>
-                  <a:srgbClr val="0D9488"/>
-                </a:solidFill>
-                <a:latin typeface="Cambria" pitchFamily="34" charset="0"/>
-                <a:ea typeface="Cambria" pitchFamily="34" charset="-122"/>
-                <a:cs typeface="Cambria" pitchFamily="34" charset="-120"/>
-              </a:rPr>
-              <a:t>R² = 0.17</a:t>
-            </a:r>
-            <a:endParaRPr lang="en-US" sz="4600" dirty="0"/>
+            <a:off x="8366760" y="2148840"/>
+            <a:ext cx="3017520" cy="320040"/>
+          </a:xfrm>
+          <a:prstGeom prst="rect">
+            <a:avLst/>
+          </a:prstGeom>
+          <a:noFill/>
+          <a:ln/>
+        </p:spPr>
+        <p:txBody>
+          <a:bodyPr wrap="square" lIns="0" tIns="0" rIns="0" bIns="0" rtlCol="0" anchor="ctr"/>
+          <a:lstStyle/>
+          <a:p>
+            <a:pPr indent="0" marL="0">
+              <a:buNone/>
+            </a:pPr>
+            <a:r>
+              <a:rPr lang="en-US" sz="1400" b="1" dirty="0">
+                <a:solidFill>
+                  <a:srgbClr val="6D28D9"/>
+                </a:solidFill>
+                <a:latin typeface="Calibri" pitchFamily="34" charset="0"/>
+                <a:ea typeface="Calibri" pitchFamily="34" charset="-122"/>
+                <a:cs typeface="Calibri" pitchFamily="34" charset="-120"/>
+              </a:rPr>
+              <a:t>Why H/M, not raw H</a:t>
+            </a:r>
+            <a:endParaRPr lang="en-US" sz="1400" dirty="0"/>
           </a:p>
         </p:txBody>
       </p:sp>
@@ -2572,47 +2572,8 @@
         </p:nvSpPr>
         <p:spPr>
           <a:xfrm>
-            <a:off x="7040880" y="2971800"/>
-            <a:ext cx="4480560" cy="640080"/>
-          </a:xfrm>
-          <a:prstGeom prst="rect">
-            <a:avLst/>
-          </a:prstGeom>
-          <a:noFill/>
-          <a:ln/>
-        </p:spPr>
-        <p:txBody>
-          <a:bodyPr wrap="square" lIns="0" tIns="0" rIns="0" bIns="0" rtlCol="0" anchor="ctr"/>
-          <a:lstStyle/>
-          <a:p>
-            <a:pPr algn="ctr" indent="0" marL="0">
-              <a:buNone/>
-            </a:pPr>
-            <a:r>
-              <a:rPr lang="en-US" sz="1350" dirty="0">
-                <a:solidFill>
-                  <a:srgbClr val="64748B"/>
-                </a:solidFill>
-                <a:latin typeface="Calibri" pitchFamily="34" charset="0"/>
-                <a:ea typeface="Calibri" pitchFamily="34" charset="-122"/>
-                <a:cs typeface="Calibri" pitchFamily="34" charset="-120"/>
-              </a:rPr>
-              <a:t>brain fingerprint → H-reflex, frozen encoder</a:t>
-            </a:r>
-            <a:endParaRPr lang="en-US" sz="1350" dirty="0"/>
-          </a:p>
-        </p:txBody>
-      </p:sp>
-      <p:sp>
-        <p:nvSpPr>
-          <p:cNvPr id="8" name="Text 5"/>
-          <p:cNvSpPr/>
-          <p:nvPr/>
-        </p:nvSpPr>
-        <p:spPr>
-          <a:xfrm>
-            <a:off x="7040880" y="3977640"/>
-            <a:ext cx="4480560" cy="1371600"/>
+            <a:off x="8366760" y="2560320"/>
+            <a:ext cx="3063240" cy="1463040"/>
           </a:xfrm>
           <a:prstGeom prst="rect">
             <a:avLst/>
@@ -2631,7 +2592,7 @@
               <a:buNone/>
             </a:pPr>
             <a:r>
-              <a:rPr lang="en-US" sz="1450" b="1" dirty="0">
+              <a:rPr lang="en-US" sz="1350" dirty="0">
                 <a:solidFill>
                   <a:srgbClr val="1E293B"/>
                 </a:solidFill>
@@ -2639,8 +2600,33 @@
                 <a:ea typeface="Calibri" pitchFamily="34" charset="-122"/>
                 <a:cs typeface="Calibri" pitchFamily="34" charset="-120"/>
               </a:rPr>
-              <a:t>Read it honestly. </a:t>
-            </a:r>
+              <a:t>The reflex (H) depends on how hard you stimulate. So we divide by the M-wave — the direct-muscle response in the same trace — exactly as the Wolpaw lab does.</a:t>
+            </a:r>
+            <a:endParaRPr lang="en-US" sz="1350" dirty="0"/>
+          </a:p>
+        </p:txBody>
+      </p:sp>
+      <p:sp>
+        <p:nvSpPr>
+          <p:cNvPr id="8" name="Text 5"/>
+          <p:cNvSpPr/>
+          <p:nvPr/>
+        </p:nvSpPr>
+        <p:spPr>
+          <a:xfrm>
+            <a:off x="8366760" y="4114800"/>
+            <a:ext cx="3063240" cy="1554480"/>
+          </a:xfrm>
+          <a:prstGeom prst="rect">
+            <a:avLst/>
+          </a:prstGeom>
+          <a:noFill/>
+          <a:ln/>
+        </p:spPr>
+        <p:txBody>
+          <a:bodyPr wrap="square" lIns="0" tIns="0" rIns="0" bIns="0" rtlCol="0" anchor="ctr"/>
+          <a:lstStyle/>
+          <a:p>
             <a:pPr indent="0" marL="0">
               <a:lnSpc>
                 <a:spcPct val="105000"/>
@@ -2648,7 +2634,7 @@
               <a:buNone/>
             </a:pPr>
             <a:r>
-              <a:rPr lang="en-US" sz="1450" dirty="0">
+              <a:rPr lang="en-US" sz="1350" b="1" dirty="0">
                 <a:solidFill>
                   <a:srgbClr val="1E293B"/>
                 </a:solidFill>
@@ -2656,51 +2642,26 @@
                 <a:ea typeface="Calibri" pitchFamily="34" charset="-122"/>
                 <a:cs typeface="Calibri" pitchFamily="34" charset="-120"/>
               </a:rPr>
-              <a:t>The cortical fingerprint predicts ~17% of the reflex's variation — with no labels during learning. Modest, but real and well above chance.</a:t>
-            </a:r>
-            <a:endParaRPr lang="en-US" sz="1450" dirty="0"/>
-          </a:p>
-        </p:txBody>
-      </p:sp>
-      <p:sp>
-        <p:nvSpPr>
-          <p:cNvPr id="9" name="Text 6"/>
-          <p:cNvSpPr/>
-          <p:nvPr/>
-        </p:nvSpPr>
-        <p:spPr>
-          <a:xfrm>
-            <a:off x="7040880" y="5440680"/>
-            <a:ext cx="4480560" cy="822960"/>
-          </a:xfrm>
-          <a:prstGeom prst="rect">
-            <a:avLst/>
-          </a:prstGeom>
-          <a:noFill/>
-          <a:ln/>
-        </p:spPr>
-        <p:txBody>
-          <a:bodyPr wrap="square" lIns="0" tIns="0" rIns="0" bIns="0" rtlCol="0" anchor="ctr"/>
-          <a:lstStyle/>
-          <a:p>
+              <a:t>H/M falls 1.17 → 0.59</a:t>
+            </a:r>
             <a:pPr indent="0" marL="0">
               <a:lnSpc>
-                <a:spcPct val="103000"/>
+                <a:spcPct val="105000"/>
               </a:lnSpc>
               <a:buNone/>
             </a:pPr>
             <a:r>
-              <a:rPr lang="en-US" sz="1250" i="1" dirty="0">
-                <a:solidFill>
-                  <a:srgbClr val="D97706"/>
-                </a:solidFill>
-                <a:latin typeface="Calibri" pitchFamily="34" charset="0"/>
-                <a:ea typeface="Calibri" pitchFamily="34" charset="-122"/>
-                <a:cs typeface="Calibri" pitchFamily="34" charset="-120"/>
-              </a:rPr>
-              <a:t>On synthetic data this was 0.90 — only because that data was built to encode the reflex. 0.17 is the real cortex.</a:t>
-            </a:r>
-            <a:endParaRPr lang="en-US" sz="1250" dirty="0"/>
+              <a:rPr lang="en-US" sz="1350" dirty="0">
+                <a:solidFill>
+                  <a:srgbClr val="1E293B"/>
+                </a:solidFill>
+                <a:latin typeface="Calibri" pitchFamily="34" charset="0"/>
+                <a:ea typeface="Calibri" pitchFamily="34" charset="-122"/>
+                <a:cs typeface="Calibri" pitchFamily="34" charset="-120"/>
+              </a:rPr>
+              <a:t> (median down to 0.18). Right panel: the stimulus drifted UP over the same weeks — which is exactly why raw H is invalid.</a:t>
+            </a:r>
+            <a:endParaRPr lang="en-US" sz="1350" dirty="0"/>
           </a:p>
         </p:txBody>
       </p:sp>
@@ -2769,7 +2730,7 @@
                 <a:ea typeface="Calibri" pitchFamily="34" charset="-122"/>
                 <a:cs typeface="Calibri" pitchFamily="34" charset="-120"/>
               </a:rPr>
-              <a:t>RESULT 2 · THE HEADLINE</a:t>
+              <a:t>RESULT 2 · THE TEST THAT SETTLES IT</a:t>
             </a:r>
             <a:endParaRPr lang="en-US" sz="1250" dirty="0"/>
           </a:p>
@@ -2808,7 +2769,7 @@
                 <a:ea typeface="Cambria" pitchFamily="34" charset="-122"/>
                 <a:cs typeface="Cambria" pitchFamily="34" charset="-120"/>
               </a:rPr>
-              <a:t>The cortical fingerprint drifts as the cord learns</a:t>
+              <a:t>Does the cortical drift survive the stimulus?</a:t>
             </a:r>
             <a:endParaRPr lang="en-US" sz="3000" dirty="0"/>
           </a:p>
@@ -2816,7 +2777,7 @@
       </p:sp>
       <p:pic>
         <p:nvPicPr>
-          <p:cNvPr id="4" name="Image 0" descr="outputs/centroid_drift.png">    </p:cNvPr>
+          <p:cNvPr id="4" name="Image 0" descr="outputs/confound/drift_confound_control.png">    </p:cNvPr>
           <p:cNvPicPr>
             <a:picLocks noChangeAspect="1"/>
           </p:cNvPicPr>
@@ -2829,8 +2790,8 @@
         </p:blipFill>
         <p:spPr>
           <a:xfrm>
-            <a:off x="640080" y="1783080"/>
-            <a:ext cx="5998464" cy="3749040"/>
+            <a:off x="594360" y="1783080"/>
+            <a:ext cx="6110935" cy="3749040"/>
           </a:xfrm>
           <a:prstGeom prst="rect">
             <a:avLst/>
@@ -2845,12 +2806,12 @@
         </p:nvSpPr>
         <p:spPr>
           <a:xfrm>
-            <a:off x="7680960" y="1920240"/>
-            <a:ext cx="3840480" cy="3931920"/>
+            <a:off x="7635240" y="1920240"/>
+            <a:ext cx="3931920" cy="3931920"/>
           </a:xfrm>
           <a:prstGeom prst="roundRect">
             <a:avLst>
-              <a:gd name="adj" fmla="val 2143"/>
+              <a:gd name="adj" fmla="val 2093"/>
             </a:avLst>
           </a:prstGeom>
           <a:solidFill>
@@ -2879,8 +2840,8 @@
         </p:nvSpPr>
         <p:spPr>
           <a:xfrm>
-            <a:off x="7909560" y="2148840"/>
-            <a:ext cx="3383280" cy="320040"/>
+            <a:off x="7863840" y="2148840"/>
+            <a:ext cx="3474720" cy="320040"/>
           </a:xfrm>
           <a:prstGeom prst="rect">
             <a:avLst/>
@@ -2904,7 +2865,7 @@
                 <a:ea typeface="Calibri" pitchFamily="34" charset="-122"/>
                 <a:cs typeface="Calibri" pitchFamily="34" charset="-120"/>
               </a:rPr>
-              <a:t>What you're seeing</a:t>
+              <a:t>The critical control</a:t>
             </a:r>
             <a:endParaRPr lang="en-US" sz="1400" dirty="0"/>
           </a:p>
@@ -2918,8 +2879,8 @@
         </p:nvSpPr>
         <p:spPr>
           <a:xfrm>
-            <a:off x="7909560" y="2560320"/>
-            <a:ext cx="3429000" cy="914400"/>
+            <a:off x="7863840" y="2560320"/>
+            <a:ext cx="3520440" cy="1005840"/>
           </a:xfrm>
           <a:prstGeom prst="rect">
             <a:avLst/>
@@ -2938,7 +2899,7 @@
               <a:buNone/>
             </a:pPr>
             <a:r>
-              <a:rPr lang="en-US" sz="1450" dirty="0">
+              <a:rPr lang="en-US" sz="1400" dirty="0">
                 <a:solidFill>
                   <a:srgbClr val="1E293B"/>
                 </a:solidFill>
@@ -2946,9 +2907,9 @@
                 <a:ea typeface="Calibri" pitchFamily="34" charset="-122"/>
                 <a:cs typeface="Calibri" pitchFamily="34" charset="-120"/>
               </a:rPr>
-              <a:t>Each point = how far that phase's average brain fingerprint sits from Baseline.</a:t>
-            </a:r>
-            <a:endParaRPr lang="en-US" sz="1450" dirty="0"/>
+              <a:t>We mathematically remove the M-wave (stimulus) from the brain fingerprint, then re-measure the drift.</a:t>
+            </a:r>
+            <a:endParaRPr lang="en-US" sz="1400" dirty="0"/>
           </a:p>
         </p:txBody>
       </p:sp>
@@ -2960,50 +2921,8 @@
         </p:nvSpPr>
         <p:spPr>
           <a:xfrm>
-            <a:off x="7909560" y="3611880"/>
-            <a:ext cx="3429000" cy="1280160"/>
-          </a:xfrm>
-          <a:prstGeom prst="rect">
-            <a:avLst/>
-          </a:prstGeom>
-          <a:noFill/>
-          <a:ln/>
-        </p:spPr>
-        <p:txBody>
-          <a:bodyPr wrap="square" lIns="0" tIns="0" rIns="0" bIns="0" rtlCol="0" anchor="ctr"/>
-          <a:lstStyle/>
-          <a:p>
-            <a:pPr indent="0" marL="0">
-              <a:lnSpc>
-                <a:spcPct val="108000"/>
-              </a:lnSpc>
-              <a:buNone/>
-            </a:pPr>
-            <a:r>
-              <a:rPr lang="en-US" sz="1500" b="1" dirty="0">
-                <a:solidFill>
-                  <a:srgbClr val="1E293B"/>
-                </a:solidFill>
-                <a:latin typeface="Calibri" pitchFamily="34" charset="0"/>
-                <a:ea typeface="Calibri" pitchFamily="34" charset="-122"/>
-                <a:cs typeface="Calibri" pitchFamily="34" charset="-120"/>
-              </a:rPr>
-              <a:t>It jumps to 28.5 during down-conditioning, then falls back to 5.0 once conditioning stops.</a:t>
-            </a:r>
-            <a:endParaRPr lang="en-US" sz="1500" dirty="0"/>
-          </a:p>
-        </p:txBody>
-      </p:sp>
-      <p:sp>
-        <p:nvSpPr>
-          <p:cNvPr id="9" name="Text 6"/>
-          <p:cNvSpPr/>
-          <p:nvPr/>
-        </p:nvSpPr>
-        <p:spPr>
-          <a:xfrm>
-            <a:off x="7909560" y="4892040"/>
-            <a:ext cx="3429000" cy="914400"/>
+            <a:off x="7863840" y="3657600"/>
+            <a:ext cx="3520440" cy="1097280"/>
           </a:xfrm>
           <a:prstGeom prst="rect">
             <a:avLst/>
@@ -3022,17 +2941,76 @@
               <a:buNone/>
             </a:pPr>
             <a:r>
-              <a:rPr lang="en-US" sz="1300" i="1" dirty="0">
-                <a:solidFill>
-                  <a:srgbClr val="6D28D9"/>
-                </a:solidFill>
-                <a:latin typeface="Calibri" pitchFamily="34" charset="0"/>
-                <a:ea typeface="Calibri" pitchFamily="34" charset="-122"/>
-                <a:cs typeface="Calibri" pitchFamily="34" charset="-120"/>
-              </a:rPr>
-              <a:t>The representation moves while the cord is learning — and partly recovers after. That's the effect we came to find.</a:t>
-            </a:r>
-            <a:endParaRPr lang="en-US" sz="1300" dirty="0"/>
+              <a:rPr lang="en-US" sz="1400" b="1" dirty="0">
+                <a:solidFill>
+                  <a:srgbClr val="1E293B"/>
+                </a:solidFill>
+                <a:latin typeface="Calibri" pitchFamily="34" charset="0"/>
+                <a:ea typeface="Calibri" pitchFamily="34" charset="-122"/>
+                <a:cs typeface="Calibri" pitchFamily="34" charset="-120"/>
+              </a:rPr>
+              <a:t>The two lines barely move apart. </a:t>
+            </a:r>
+            <a:pPr indent="0" marL="0">
+              <a:lnSpc>
+                <a:spcPct val="105000"/>
+              </a:lnSpc>
+              <a:buNone/>
+            </a:pPr>
+            <a:r>
+              <a:rPr lang="en-US" sz="1400" dirty="0">
+                <a:solidFill>
+                  <a:srgbClr val="1E293B"/>
+                </a:solidFill>
+                <a:latin typeface="Calibri" pitchFamily="34" charset="0"/>
+                <a:ea typeface="Calibri" pitchFamily="34" charset="-122"/>
+                <a:cs typeface="Calibri" pitchFamily="34" charset="-120"/>
+              </a:rPr>
+              <a:t>The cortical drift is NOT a stimulus artifact — it's real.</a:t>
+            </a:r>
+            <a:endParaRPr lang="en-US" sz="1400" dirty="0"/>
+          </a:p>
+        </p:txBody>
+      </p:sp>
+      <p:sp>
+        <p:nvSpPr>
+          <p:cNvPr id="9" name="Text 6"/>
+          <p:cNvSpPr/>
+          <p:nvPr/>
+        </p:nvSpPr>
+        <p:spPr>
+          <a:xfrm>
+            <a:off x="7863840" y="4754880"/>
+            <a:ext cx="3520440" cy="1005840"/>
+          </a:xfrm>
+          <a:prstGeom prst="rect">
+            <a:avLst/>
+          </a:prstGeom>
+          <a:noFill/>
+          <a:ln/>
+        </p:spPr>
+        <p:txBody>
+          <a:bodyPr wrap="square" lIns="0" tIns="0" rIns="0" bIns="0" rtlCol="0" anchor="ctr"/>
+          <a:lstStyle/>
+          <a:p>
+            <a:pPr indent="0" marL="0">
+              <a:lnSpc>
+                <a:spcPct val="103000"/>
+              </a:lnSpc>
+              <a:buNone/>
+            </a:pPr>
+            <a:r>
+              <a:rPr lang="en-US" sz="1200" i="1" dirty="0">
+                <a:solidFill>
+                  <a:srgbClr val="D97706"/>
+                </a:solidFill>
+                <a:latin typeface="Calibri" pitchFamily="34" charset="0"/>
+                <a:ea typeface="Calibri" pitchFamily="34" charset="-122"/>
+                <a:cs typeface="Calibri" pitchFamily="34" charset="-120"/>
+              </a:rPr>
+              <a:t>Caveat: the shift is biggest at conditioning onset, not steadily growing — cortex reacts to the new task, doesn't simply mirror reflex size.</a:t>
+            </a:r>
+            <a:endParaRPr lang="en-US" sz="1200" dirty="0"/>
           </a:p>
         </p:txBody>
       </p:sp>
@@ -3095,13 +3073,13 @@
             <a:r>
               <a:rPr lang="en-US" sz="1250" b="1" spc="300" kern="0" dirty="0">
                 <a:solidFill>
-                  <a:srgbClr val="D97706"/>
-                </a:solidFill>
-                <a:latin typeface="Calibri" pitchFamily="34" charset="0"/>
-                <a:ea typeface="Calibri" pitchFamily="34" charset="-122"/>
-                <a:cs typeface="Calibri" pitchFamily="34" charset="-120"/>
-              </a:rPr>
-              <a:t>THE HONEST CAVEAT — READ THIS</a:t>
+                  <a:srgbClr val="0D9488"/>
+                </a:solidFill>
+                <a:latin typeface="Calibri" pitchFamily="34" charset="0"/>
+                <a:ea typeface="Calibri" pitchFamily="34" charset="-122"/>
+                <a:cs typeface="Calibri" pitchFamily="34" charset="-120"/>
+              </a:rPr>
+              <a:t>RESULT 3 · READING THE REFLEX FROM CORTEX</a:t>
             </a:r>
             <a:endParaRPr lang="en-US" sz="1250" dirty="0"/>
           </a:p>
@@ -3140,53 +3118,72 @@
                 <a:ea typeface="Cambria" pitchFamily="34" charset="-122"/>
                 <a:cs typeface="Cambria" pitchFamily="34" charset="-120"/>
               </a:rPr>
-              <a:t>Is the drift learning, or just session state?</a:t>
+              <a:t>Can the brain predict the reflex? A little — honestly</a:t>
             </a:r>
             <a:endParaRPr lang="en-US" sz="3000" dirty="0"/>
           </a:p>
         </p:txBody>
       </p:sp>
-      <p:pic>
-        <p:nvPicPr>
-          <p:cNvPr id="4" name="Image 0" descr="outputs/hreflex_by_phase.png">    </p:cNvPr>
-          <p:cNvPicPr>
-            <a:picLocks noChangeAspect="1"/>
-          </p:cNvPicPr>
-          <p:nvPr/>
-        </p:nvPicPr>
-        <p:blipFill>
-          <a:blip r:embed="rId1"/>
-          <a:srcRect l="0" r="0" t="0" b="0"/>
-          <a:stretch/>
-        </p:blipFill>
-        <p:spPr>
-          <a:xfrm>
-            <a:off x="640080" y="1828800"/>
-            <a:ext cx="5705856" cy="3566160"/>
-          </a:xfrm>
-          <a:prstGeom prst="rect">
-            <a:avLst/>
-          </a:prstGeom>
-        </p:spPr>
-      </p:pic>
-      <p:sp>
-        <p:nvSpPr>
-          <p:cNvPr id="5" name="Shape 2"/>
-          <p:cNvSpPr/>
-          <p:nvPr/>
-        </p:nvSpPr>
-        <p:spPr>
-          <a:xfrm>
-            <a:off x="6858000" y="1920240"/>
-            <a:ext cx="4663440" cy="3977640"/>
+      <p:sp>
+        <p:nvSpPr>
+          <p:cNvPr id="4" name="Text 2"/>
+          <p:cNvSpPr/>
+          <p:nvPr/>
+        </p:nvSpPr>
+        <p:spPr>
+          <a:xfrm>
+            <a:off x="640080" y="1600200"/>
+            <a:ext cx="10881360" cy="548640"/>
+          </a:xfrm>
+          <a:prstGeom prst="rect">
+            <a:avLst/>
+          </a:prstGeom>
+          <a:noFill/>
+          <a:ln/>
+        </p:spPr>
+        <p:txBody>
+          <a:bodyPr wrap="square" lIns="0" tIns="0" rIns="0" bIns="0" rtlCol="0" anchor="ctr"/>
+          <a:lstStyle/>
+          <a:p>
+            <a:pPr indent="0" marL="0">
+              <a:lnSpc>
+                <a:spcPct val="103000"/>
+              </a:lnSpc>
+              <a:buNone/>
+            </a:pPr>
+            <a:r>
+              <a:rPr lang="en-US" sz="1550" dirty="0">
+                <a:solidFill>
+                  <a:srgbClr val="1E293B"/>
+                </a:solidFill>
+                <a:latin typeface="Calibri" pitchFamily="34" charset="0"/>
+                <a:ea typeface="Calibri" pitchFamily="34" charset="-122"/>
+                <a:cs typeface="Calibri" pitchFamily="34" charset="-120"/>
+              </a:rPr>
+              <a:t>We test how much of the reflex each source explains, using the same M-wave control. Three numbers, side by side:</a:t>
+            </a:r>
+            <a:endParaRPr lang="en-US" sz="1550" dirty="0"/>
+          </a:p>
+        </p:txBody>
+      </p:sp>
+      <p:sp>
+        <p:nvSpPr>
+          <p:cNvPr id="5" name="Shape 3"/>
+          <p:cNvSpPr/>
+          <p:nvPr/>
+        </p:nvSpPr>
+        <p:spPr>
+          <a:xfrm>
+            <a:off x="640080" y="2331720"/>
+            <a:ext cx="3538728" cy="3383280"/>
           </a:xfrm>
           <a:prstGeom prst="roundRect">
             <a:avLst>
-              <a:gd name="adj" fmla="val 2069"/>
+              <a:gd name="adj" fmla="val 2432"/>
             </a:avLst>
           </a:prstGeom>
           <a:solidFill>
-            <a:srgbClr val="FEF3E2"/>
+            <a:srgbClr val="FFFFFF"/>
           </a:solidFill>
           <a:ln w="12700">
             <a:solidFill>
@@ -3205,72 +3202,249 @@
       </p:sp>
       <p:sp>
         <p:nvSpPr>
-          <p:cNvPr id="6" name="Text 3"/>
-          <p:cNvSpPr/>
-          <p:nvPr/>
-        </p:nvSpPr>
-        <p:spPr>
-          <a:xfrm>
-            <a:off x="7086600" y="2148840"/>
-            <a:ext cx="4206240" cy="320040"/>
-          </a:xfrm>
-          <a:prstGeom prst="rect">
-            <a:avLst/>
-          </a:prstGeom>
-          <a:noFill/>
-          <a:ln/>
-        </p:spPr>
-        <p:txBody>
-          <a:bodyPr wrap="square" lIns="0" tIns="0" rIns="0" bIns="0" rtlCol="0" anchor="ctr"/>
-          <a:lstStyle/>
-          <a:p>
-            <a:pPr indent="0" marL="0">
-              <a:buNone/>
-            </a:pPr>
-            <a:r>
-              <a:rPr lang="en-US" sz="1400" b="1" dirty="0">
+          <p:cNvPr id="6" name="Text 4"/>
+          <p:cNvSpPr/>
+          <p:nvPr/>
+        </p:nvSpPr>
+        <p:spPr>
+          <a:xfrm>
+            <a:off x="640080" y="2651760"/>
+            <a:ext cx="3538728" cy="914400"/>
+          </a:xfrm>
+          <a:prstGeom prst="rect">
+            <a:avLst/>
+          </a:prstGeom>
+          <a:noFill/>
+          <a:ln/>
+        </p:spPr>
+        <p:txBody>
+          <a:bodyPr wrap="square" lIns="0" tIns="0" rIns="0" bIns="0" rtlCol="0" anchor="ctr"/>
+          <a:lstStyle/>
+          <a:p>
+            <a:pPr algn="ctr" indent="0" marL="0">
+              <a:buNone/>
+            </a:pPr>
+            <a:r>
+              <a:rPr lang="en-US" sz="5200" b="1" dirty="0">
                 <a:solidFill>
                   <a:srgbClr val="D97706"/>
                 </a:solidFill>
-                <a:latin typeface="Calibri" pitchFamily="34" charset="0"/>
-                <a:ea typeface="Calibri" pitchFamily="34" charset="-122"/>
-                <a:cs typeface="Calibri" pitchFamily="34" charset="-120"/>
-              </a:rPr>
-              <a:t>The problem</a:t>
-            </a:r>
-            <a:endParaRPr lang="en-US" sz="1400" dirty="0"/>
-          </a:p>
-        </p:txBody>
-      </p:sp>
-      <p:sp>
-        <p:nvSpPr>
-          <p:cNvPr id="7" name="Text 4"/>
-          <p:cNvSpPr/>
-          <p:nvPr/>
-        </p:nvSpPr>
-        <p:spPr>
-          <a:xfrm>
-            <a:off x="7086600" y="2542032"/>
-            <a:ext cx="4251960" cy="1051560"/>
-          </a:xfrm>
-          <a:prstGeom prst="rect">
-            <a:avLst/>
-          </a:prstGeom>
-          <a:noFill/>
-          <a:ln/>
-        </p:spPr>
-        <p:txBody>
-          <a:bodyPr wrap="square" lIns="0" tIns="0" rIns="0" bIns="0" rtlCol="0" anchor="ctr"/>
-          <a:lstStyle/>
-          <a:p>
-            <a:pPr indent="0" marL="0">
+                <a:latin typeface="Cambria" pitchFamily="34" charset="0"/>
+                <a:ea typeface="Cambria" pitchFamily="34" charset="-122"/>
+                <a:cs typeface="Cambria" pitchFamily="34" charset="-120"/>
+              </a:rPr>
+              <a:t>0.20</a:t>
+            </a:r>
+            <a:endParaRPr lang="en-US" sz="5200" dirty="0"/>
+          </a:p>
+        </p:txBody>
+      </p:sp>
+      <p:sp>
+        <p:nvSpPr>
+          <p:cNvPr id="7" name="Text 5"/>
+          <p:cNvSpPr/>
+          <p:nvPr/>
+        </p:nvSpPr>
+        <p:spPr>
+          <a:xfrm>
+            <a:off x="822960" y="3611880"/>
+            <a:ext cx="3172968" cy="777240"/>
+          </a:xfrm>
+          <a:prstGeom prst="rect">
+            <a:avLst/>
+          </a:prstGeom>
+          <a:noFill/>
+          <a:ln/>
+        </p:spPr>
+        <p:txBody>
+          <a:bodyPr wrap="square" lIns="0" tIns="0" rIns="0" bIns="0" rtlCol="0" anchor="ctr"/>
+          <a:lstStyle/>
+          <a:p>
+            <a:pPr algn="ctr" indent="0" marL="0">
+              <a:lnSpc>
+                <a:spcPct val="100000"/>
+              </a:lnSpc>
+              <a:buNone/>
+            </a:pPr>
+            <a:r>
+              <a:rPr lang="en-US" sz="1450" b="1" dirty="0">
+                <a:solidFill>
+                  <a:srgbClr val="1E293B"/>
+                </a:solidFill>
+                <a:latin typeface="Calibri" pitchFamily="34" charset="0"/>
+                <a:ea typeface="Calibri" pitchFamily="34" charset="-122"/>
+                <a:cs typeface="Calibri" pitchFamily="34" charset="-120"/>
+              </a:rPr>
+              <a:t>Stimulus alone</a:t>
+            </a:r>
+            <a:endParaRPr lang="en-US" sz="1450" dirty="0"/>
+          </a:p>
+          <a:p>
+            <a:pPr algn="ctr" indent="0" marL="0">
+              <a:lnSpc>
+                <a:spcPct val="100000"/>
+              </a:lnSpc>
+              <a:buNone/>
+            </a:pPr>
+            <a:r>
+              <a:rPr lang="en-US" sz="1450" b="1" dirty="0">
+                <a:solidFill>
+                  <a:srgbClr val="1E293B"/>
+                </a:solidFill>
+                <a:latin typeface="Calibri" pitchFamily="34" charset="0"/>
+                <a:ea typeface="Calibri" pitchFamily="34" charset="-122"/>
+                <a:cs typeface="Calibri" pitchFamily="34" charset="-120"/>
+              </a:rPr>
+              <a:t>(M-wave → reflex)</a:t>
+            </a:r>
+            <a:endParaRPr lang="en-US" sz="1450" dirty="0"/>
+          </a:p>
+        </p:txBody>
+      </p:sp>
+      <p:sp>
+        <p:nvSpPr>
+          <p:cNvPr id="8" name="Text 6"/>
+          <p:cNvSpPr/>
+          <p:nvPr/>
+        </p:nvSpPr>
+        <p:spPr>
+          <a:xfrm>
+            <a:off x="868680" y="4526280"/>
+            <a:ext cx="3081528" cy="1005840"/>
+          </a:xfrm>
+          <a:prstGeom prst="rect">
+            <a:avLst/>
+          </a:prstGeom>
+          <a:noFill/>
+          <a:ln/>
+        </p:spPr>
+        <p:txBody>
+          <a:bodyPr wrap="square" lIns="0" tIns="0" rIns="0" bIns="0" rtlCol="0" anchor="ctr"/>
+          <a:lstStyle/>
+          <a:p>
+            <a:pPr algn="ctr" indent="0" marL="0">
               <a:lnSpc>
                 <a:spcPct val="105000"/>
               </a:lnSpc>
               <a:buNone/>
             </a:pPr>
             <a:r>
-              <a:rPr lang="en-US" sz="1450" dirty="0">
+              <a:rPr lang="en-US" sz="1300" dirty="0">
+                <a:solidFill>
+                  <a:srgbClr val="64748B"/>
+                </a:solidFill>
+                <a:latin typeface="Calibri" pitchFamily="34" charset="0"/>
+                <a:ea typeface="Calibri" pitchFamily="34" charset="-122"/>
+                <a:cs typeface="Calibri" pitchFamily="34" charset="-120"/>
+              </a:rPr>
+              <a:t>The stimulus explains most of it. This is the confound.</a:t>
+            </a:r>
+            <a:endParaRPr lang="en-US" sz="1300" dirty="0"/>
+          </a:p>
+        </p:txBody>
+      </p:sp>
+      <p:sp>
+        <p:nvSpPr>
+          <p:cNvPr id="9" name="Shape 7"/>
+          <p:cNvSpPr/>
+          <p:nvPr/>
+        </p:nvSpPr>
+        <p:spPr>
+          <a:xfrm>
+            <a:off x="4370832" y="2331720"/>
+            <a:ext cx="3538728" cy="3383280"/>
+          </a:xfrm>
+          <a:prstGeom prst="roundRect">
+            <a:avLst>
+              <a:gd name="adj" fmla="val 2432"/>
+            </a:avLst>
+          </a:prstGeom>
+          <a:solidFill>
+            <a:srgbClr val="FFFFFF"/>
+          </a:solidFill>
+          <a:ln w="12700">
+            <a:solidFill>
+              <a:srgbClr val="E2E8F0"/>
+            </a:solidFill>
+            <a:prstDash val="solid"/>
+          </a:ln>
+          <a:effectLst>
+            <a:outerShdw sx="100000" sy="100000" kx="0" ky="0" algn="bl" rotWithShape="0" blurRad="114300" dist="38100" dir="5400000">
+              <a:srgbClr val="0F172A">
+                <a:alpha val="14000"/>
+              </a:srgbClr>
+            </a:outerShdw>
+          </a:effectLst>
+        </p:spPr>
+      </p:sp>
+      <p:sp>
+        <p:nvSpPr>
+          <p:cNvPr id="10" name="Text 8"/>
+          <p:cNvSpPr/>
+          <p:nvPr/>
+        </p:nvSpPr>
+        <p:spPr>
+          <a:xfrm>
+            <a:off x="4370832" y="2651760"/>
+            <a:ext cx="3538728" cy="914400"/>
+          </a:xfrm>
+          <a:prstGeom prst="rect">
+            <a:avLst/>
+          </a:prstGeom>
+          <a:noFill/>
+          <a:ln/>
+        </p:spPr>
+        <p:txBody>
+          <a:bodyPr wrap="square" lIns="0" tIns="0" rIns="0" bIns="0" rtlCol="0" anchor="ctr"/>
+          <a:lstStyle/>
+          <a:p>
+            <a:pPr algn="ctr" indent="0" marL="0">
+              <a:buNone/>
+            </a:pPr>
+            <a:r>
+              <a:rPr lang="en-US" sz="5200" b="1" dirty="0">
+                <a:solidFill>
+                  <a:srgbClr val="64748B"/>
+                </a:solidFill>
+                <a:latin typeface="Cambria" pitchFamily="34" charset="0"/>
+                <a:ea typeface="Cambria" pitchFamily="34" charset="-122"/>
+                <a:cs typeface="Cambria" pitchFamily="34" charset="-120"/>
+              </a:rPr>
+              <a:t>0.05</a:t>
+            </a:r>
+            <a:endParaRPr lang="en-US" sz="5200" dirty="0"/>
+          </a:p>
+        </p:txBody>
+      </p:sp>
+      <p:sp>
+        <p:nvSpPr>
+          <p:cNvPr id="11" name="Text 9"/>
+          <p:cNvSpPr/>
+          <p:nvPr/>
+        </p:nvSpPr>
+        <p:spPr>
+          <a:xfrm>
+            <a:off x="4553712" y="3611880"/>
+            <a:ext cx="3172968" cy="777240"/>
+          </a:xfrm>
+          <a:prstGeom prst="rect">
+            <a:avLst/>
+          </a:prstGeom>
+          <a:noFill/>
+          <a:ln/>
+        </p:spPr>
+        <p:txBody>
+          <a:bodyPr wrap="square" lIns="0" tIns="0" rIns="0" bIns="0" rtlCol="0" anchor="ctr"/>
+          <a:lstStyle/>
+          <a:p>
+            <a:pPr algn="ctr" indent="0" marL="0">
+              <a:lnSpc>
+                <a:spcPct val="100000"/>
+              </a:lnSpc>
+              <a:buNone/>
+            </a:pPr>
+            <a:r>
+              <a:rPr lang="en-US" sz="1450" b="1" dirty="0">
                 <a:solidFill>
                   <a:srgbClr val="1E293B"/>
                 </a:solidFill>
@@ -3278,38 +3452,19 @@
                 <a:ea typeface="Calibri" pitchFamily="34" charset="-122"/>
                 <a:cs typeface="Calibri" pitchFamily="34" charset="-120"/>
               </a:rPr>
-              <a:t>Down-conditioning should make the H-reflex SMALLER. But in the data it's larger during down-conditioning than at Baseline.</a:t>
+              <a:t>Cortex, raw</a:t>
             </a:r>
             <a:endParaRPr lang="en-US" sz="1450" dirty="0"/>
           </a:p>
-        </p:txBody>
-      </p:sp>
-      <p:sp>
-        <p:nvSpPr>
-          <p:cNvPr id="8" name="Text 5"/>
-          <p:cNvSpPr/>
-          <p:nvPr/>
-        </p:nvSpPr>
-        <p:spPr>
-          <a:xfrm>
-            <a:off x="7086600" y="3611880"/>
-            <a:ext cx="4206240" cy="320040"/>
-          </a:xfrm>
-          <a:prstGeom prst="rect">
-            <a:avLst/>
-          </a:prstGeom>
-          <a:noFill/>
-          <a:ln/>
-        </p:spPr>
-        <p:txBody>
-          <a:bodyPr wrap="square" lIns="0" tIns="0" rIns="0" bIns="0" rtlCol="0" anchor="ctr"/>
-          <a:lstStyle/>
-          <a:p>
-            <a:pPr indent="0" marL="0">
-              <a:buNone/>
-            </a:pPr>
-            <a:r>
-              <a:rPr lang="en-US" sz="1400" b="1" dirty="0">
+          <a:p>
+            <a:pPr algn="ctr" indent="0" marL="0">
+              <a:lnSpc>
+                <a:spcPct val="100000"/>
+              </a:lnSpc>
+              <a:buNone/>
+            </a:pPr>
+            <a:r>
+              <a:rPr lang="en-US" sz="1450" b="1" dirty="0">
                 <a:solidFill>
                   <a:srgbClr val="1E293B"/>
                 </a:solidFill>
@@ -3317,41 +3472,156 @@
                 <a:ea typeface="Calibri" pitchFamily="34" charset="-122"/>
                 <a:cs typeface="Calibri" pitchFamily="34" charset="-120"/>
               </a:rPr>
-              <a:t>Most likely why:</a:t>
-            </a:r>
-            <a:endParaRPr lang="en-US" sz="1400" dirty="0"/>
-          </a:p>
-        </p:txBody>
-      </p:sp>
-      <p:sp>
-        <p:nvSpPr>
-          <p:cNvPr id="9" name="Text 6"/>
-          <p:cNvSpPr/>
-          <p:nvPr/>
-        </p:nvSpPr>
-        <p:spPr>
-          <a:xfrm>
-            <a:off x="7086600" y="3977640"/>
-            <a:ext cx="4251960" cy="1051560"/>
-          </a:xfrm>
-          <a:prstGeom prst="rect">
-            <a:avLst/>
-          </a:prstGeom>
-          <a:noFill/>
-          <a:ln/>
-        </p:spPr>
-        <p:txBody>
-          <a:bodyPr wrap="square" lIns="0" tIns="0" rIns="0" bIns="0" rtlCol="0" anchor="ctr"/>
-          <a:lstStyle/>
-          <a:p>
-            <a:pPr indent="0" marL="0">
+              <a:t>(fingerprint → reflex)</a:t>
+            </a:r>
+            <a:endParaRPr lang="en-US" sz="1450" dirty="0"/>
+          </a:p>
+        </p:txBody>
+      </p:sp>
+      <p:sp>
+        <p:nvSpPr>
+          <p:cNvPr id="12" name="Text 10"/>
+          <p:cNvSpPr/>
+          <p:nvPr/>
+        </p:nvSpPr>
+        <p:spPr>
+          <a:xfrm>
+            <a:off x="4599432" y="4526280"/>
+            <a:ext cx="3081528" cy="1005840"/>
+          </a:xfrm>
+          <a:prstGeom prst="rect">
+            <a:avLst/>
+          </a:prstGeom>
+          <a:noFill/>
+          <a:ln/>
+        </p:spPr>
+        <p:txBody>
+          <a:bodyPr wrap="square" lIns="0" tIns="0" rIns="0" bIns="0" rtlCol="0" anchor="ctr"/>
+          <a:lstStyle/>
+          <a:p>
+            <a:pPr algn="ctr" indent="0" marL="0">
               <a:lnSpc>
                 <a:spcPct val="105000"/>
               </a:lnSpc>
               <a:buNone/>
             </a:pPr>
             <a:r>
-              <a:rPr lang="en-US" sz="1400" dirty="0">
+              <a:rPr lang="en-US" sz="1300" dirty="0">
+                <a:solidFill>
+                  <a:srgbClr val="64748B"/>
+                </a:solidFill>
+                <a:latin typeface="Calibri" pitchFamily="34" charset="0"/>
+                <a:ea typeface="Calibri" pitchFamily="34" charset="-122"/>
+                <a:cs typeface="Calibri" pitchFamily="34" charset="-120"/>
+              </a:rPr>
+              <a:t>A weak link on its own.</a:t>
+            </a:r>
+            <a:endParaRPr lang="en-US" sz="1300" dirty="0"/>
+          </a:p>
+        </p:txBody>
+      </p:sp>
+      <p:sp>
+        <p:nvSpPr>
+          <p:cNvPr id="13" name="Shape 11"/>
+          <p:cNvSpPr/>
+          <p:nvPr/>
+        </p:nvSpPr>
+        <p:spPr>
+          <a:xfrm>
+            <a:off x="8101584" y="2331720"/>
+            <a:ext cx="3538728" cy="3383280"/>
+          </a:xfrm>
+          <a:prstGeom prst="roundRect">
+            <a:avLst>
+              <a:gd name="adj" fmla="val 2432"/>
+            </a:avLst>
+          </a:prstGeom>
+          <a:solidFill>
+            <a:srgbClr val="FFFFFF"/>
+          </a:solidFill>
+          <a:ln w="12700">
+            <a:solidFill>
+              <a:srgbClr val="E2E8F0"/>
+            </a:solidFill>
+            <a:prstDash val="solid"/>
+          </a:ln>
+          <a:effectLst>
+            <a:outerShdw sx="100000" sy="100000" kx="0" ky="0" algn="bl" rotWithShape="0" blurRad="114300" dist="38100" dir="5400000">
+              <a:srgbClr val="0F172A">
+                <a:alpha val="14000"/>
+              </a:srgbClr>
+            </a:outerShdw>
+          </a:effectLst>
+        </p:spPr>
+      </p:sp>
+      <p:sp>
+        <p:nvSpPr>
+          <p:cNvPr id="14" name="Text 12"/>
+          <p:cNvSpPr/>
+          <p:nvPr/>
+        </p:nvSpPr>
+        <p:spPr>
+          <a:xfrm>
+            <a:off x="8101584" y="2651760"/>
+            <a:ext cx="3538728" cy="914400"/>
+          </a:xfrm>
+          <a:prstGeom prst="rect">
+            <a:avLst/>
+          </a:prstGeom>
+          <a:noFill/>
+          <a:ln/>
+        </p:spPr>
+        <p:txBody>
+          <a:bodyPr wrap="square" lIns="0" tIns="0" rIns="0" bIns="0" rtlCol="0" anchor="ctr"/>
+          <a:lstStyle/>
+          <a:p>
+            <a:pPr algn="ctr" indent="0" marL="0">
+              <a:buNone/>
+            </a:pPr>
+            <a:r>
+              <a:rPr lang="en-US" sz="5200" b="1" dirty="0">
+                <a:solidFill>
+                  <a:srgbClr val="6D28D9"/>
+                </a:solidFill>
+                <a:latin typeface="Cambria" pitchFamily="34" charset="0"/>
+                <a:ea typeface="Cambria" pitchFamily="34" charset="-122"/>
+                <a:cs typeface="Cambria" pitchFamily="34" charset="-120"/>
+              </a:rPr>
+              <a:t>0.04</a:t>
+            </a:r>
+            <a:endParaRPr lang="en-US" sz="5200" dirty="0"/>
+          </a:p>
+        </p:txBody>
+      </p:sp>
+      <p:sp>
+        <p:nvSpPr>
+          <p:cNvPr id="15" name="Text 13"/>
+          <p:cNvSpPr/>
+          <p:nvPr/>
+        </p:nvSpPr>
+        <p:spPr>
+          <a:xfrm>
+            <a:off x="8284464" y="3611880"/>
+            <a:ext cx="3172968" cy="777240"/>
+          </a:xfrm>
+          <a:prstGeom prst="rect">
+            <a:avLst/>
+          </a:prstGeom>
+          <a:noFill/>
+          <a:ln/>
+        </p:spPr>
+        <p:txBody>
+          <a:bodyPr wrap="square" lIns="0" tIns="0" rIns="0" bIns="0" rtlCol="0" anchor="ctr"/>
+          <a:lstStyle/>
+          <a:p>
+            <a:pPr algn="ctr" indent="0" marL="0">
+              <a:lnSpc>
+                <a:spcPct val="100000"/>
+              </a:lnSpc>
+              <a:buNone/>
+            </a:pPr>
+            <a:r>
+              <a:rPr lang="en-US" sz="1450" b="1" dirty="0">
                 <a:solidFill>
                   <a:srgbClr val="1E293B"/>
                 </a:solidFill>
@@ -3359,41 +3629,80 @@
                 <a:ea typeface="Calibri" pitchFamily="34" charset="-122"/>
                 <a:cs typeface="Calibri" pitchFamily="34" charset="-120"/>
               </a:rPr>
-              <a:t>our 'Baseline' is really the setup period — the log shows the stimulus being constantly re-tuned, so responses there are smaller and inconsistent.</a:t>
-            </a:r>
-            <a:endParaRPr lang="en-US" sz="1400" dirty="0"/>
-          </a:p>
-        </p:txBody>
-      </p:sp>
-      <p:sp>
-        <p:nvSpPr>
-          <p:cNvPr id="10" name="Text 7"/>
-          <p:cNvSpPr/>
-          <p:nvPr/>
-        </p:nvSpPr>
-        <p:spPr>
-          <a:xfrm>
-            <a:off x="7086600" y="5029200"/>
-            <a:ext cx="4251960" cy="822960"/>
-          </a:xfrm>
-          <a:prstGeom prst="rect">
-            <a:avLst/>
-          </a:prstGeom>
-          <a:noFill/>
-          <a:ln/>
-        </p:spPr>
-        <p:txBody>
-          <a:bodyPr wrap="square" lIns="0" tIns="0" rIns="0" bIns="0" rtlCol="0" anchor="ctr"/>
-          <a:lstStyle/>
-          <a:p>
-            <a:pPr indent="0" marL="0">
+              <a:t>Cortex, stimulus removed</a:t>
+            </a:r>
+            <a:endParaRPr lang="en-US" sz="1450" dirty="0"/>
+          </a:p>
+        </p:txBody>
+      </p:sp>
+      <p:sp>
+        <p:nvSpPr>
+          <p:cNvPr id="16" name="Text 14"/>
+          <p:cNvSpPr/>
+          <p:nvPr/>
+        </p:nvSpPr>
+        <p:spPr>
+          <a:xfrm>
+            <a:off x="8330184" y="4526280"/>
+            <a:ext cx="3081528" cy="1005840"/>
+          </a:xfrm>
+          <a:prstGeom prst="rect">
+            <a:avLst/>
+          </a:prstGeom>
+          <a:noFill/>
+          <a:ln/>
+        </p:spPr>
+        <p:txBody>
+          <a:bodyPr wrap="square" lIns="0" tIns="0" rIns="0" bIns="0" rtlCol="0" anchor="ctr"/>
+          <a:lstStyle/>
+          <a:p>
+            <a:pPr algn="ctr" indent="0" marL="0">
               <a:lnSpc>
-                <a:spcPct val="103000"/>
+                <a:spcPct val="105000"/>
               </a:lnSpc>
               <a:buNone/>
             </a:pPr>
             <a:r>
-              <a:rPr lang="en-US" sz="1250" b="1" i="1" dirty="0">
+              <a:rPr lang="en-US" sz="1300" dirty="0">
+                <a:solidFill>
+                  <a:srgbClr val="64748B"/>
+                </a:solidFill>
+                <a:latin typeface="Calibri" pitchFamily="34" charset="0"/>
+                <a:ea typeface="Calibri" pitchFamily="34" charset="-122"/>
+                <a:cs typeface="Calibri" pitchFamily="34" charset="-120"/>
+              </a:rPr>
+              <a:t>Survives the control — small but genuinely there.</a:t>
+            </a:r>
+            <a:endParaRPr lang="en-US" sz="1300" dirty="0"/>
+          </a:p>
+        </p:txBody>
+      </p:sp>
+      <p:sp>
+        <p:nvSpPr>
+          <p:cNvPr id="17" name="Text 15"/>
+          <p:cNvSpPr/>
+          <p:nvPr/>
+        </p:nvSpPr>
+        <p:spPr>
+          <a:xfrm>
+            <a:off x="640080" y="5989320"/>
+            <a:ext cx="10881360" cy="457200"/>
+          </a:xfrm>
+          <a:prstGeom prst="rect">
+            <a:avLst/>
+          </a:prstGeom>
+          <a:noFill/>
+          <a:ln/>
+        </p:spPr>
+        <p:txBody>
+          <a:bodyPr wrap="square" lIns="0" tIns="0" rIns="0" bIns="0" rtlCol="0" anchor="ctr"/>
+          <a:lstStyle/>
+          <a:p>
+            <a:pPr indent="0" marL="0">
+              <a:buNone/>
+            </a:pPr>
+            <a:r>
+              <a:rPr lang="en-US" sz="1300" i="1" dirty="0">
                 <a:solidFill>
                   <a:srgbClr val="D97706"/>
                 </a:solidFill>
@@ -3401,9 +3710,9 @@
                 <a:ea typeface="Calibri" pitchFamily="34" charset="-122"/>
                 <a:cs typeface="Calibri" pitchFamily="34" charset="-120"/>
               </a:rPr>
-              <a:t>So part of the cortical drift may track session state (fixed-stimulus, active recording) rather than learning itself. #1 thing to resolve.</a:t>
-            </a:r>
-            <a:endParaRPr lang="en-US" sz="1250" dirty="0"/>
+              <a:t>The earlier R²≈0.17 was inflated — it rode on shared stimulus variance. The honest cortex-only contribution is ~0.04.</a:t>
+            </a:r>
+            <a:endParaRPr lang="en-US" sz="1300" dirty="0"/>
           </a:p>
         </p:txBody>
       </p:sp>
@@ -3645,7 +3954,7 @@
                 <a:ea typeface="Calibri" pitchFamily="34" charset="-122"/>
                 <a:cs typeface="Calibri" pitchFamily="34" charset="-120"/>
               </a:rPr>
-              <a:t>Infrastructure</a:t>
+              <a:t>Infrastructure + behaviour</a:t>
             </a:r>
             <a:endParaRPr lang="en-US" sz="1800" dirty="0"/>
           </a:p>
@@ -3687,7 +3996,7 @@
                 <a:ea typeface="Calibri" pitchFamily="34" charset="-122"/>
                 <a:cs typeface="Calibri" pitchFamily="34" charset="-120"/>
               </a:rPr>
-              <a:t>Real data flows end to end — decode, phase labels, training, analysis. Reproducible, on a laptop. This was the hard part and it's done.</a:t>
+              <a:t>Real data end to end, and the behaviour is textbook: down-conditioning worked (H/M fell to ~0.18). Reproducible on a laptop.</a:t>
             </a:r>
             <a:endParaRPr lang="en-US" sz="1400" dirty="0"/>
           </a:p>
@@ -3782,7 +4091,7 @@
                 <a:ea typeface="Calibri" pitchFamily="34" charset="-122"/>
                 <a:cs typeface="Calibri" pitchFamily="34" charset="-120"/>
               </a:rPr>
-              <a:t>PROMISING</a:t>
+              <a:t>REAL BUT MODEST</a:t>
             </a:r>
             <a:endParaRPr lang="en-US" sz="1300" dirty="0"/>
           </a:p>
@@ -3821,7 +4130,7 @@
                 <a:ea typeface="Calibri" pitchFamily="34" charset="-122"/>
                 <a:cs typeface="Calibri" pitchFamily="34" charset="-120"/>
               </a:rPr>
-              <a:t>First real signal</a:t>
+              <a:t>Cortical effect</a:t>
             </a:r>
             <a:endParaRPr lang="en-US" sz="1800" dirty="0"/>
           </a:p>
@@ -3863,7 +4172,7 @@
                 <a:ea typeface="Calibri" pitchFamily="34" charset="-122"/>
                 <a:cs typeface="Calibri" pitchFamily="34" charset="-120"/>
               </a:rPr>
-              <a:t>The fingerprint predicts the reflex above chance (R²=0.17) and the representation clearly moves during conditioning.</a:t>
+              <a:t>The cortical drift survives removing the stimulus — not an artifact. But the cortex→reflex link is small (~0.04) and onset-driven.</a:t>
             </a:r>
             <a:endParaRPr lang="en-US" sz="1400" dirty="0"/>
           </a:p>
@@ -4039,7 +4348,7 @@
                 <a:ea typeface="Calibri" pitchFamily="34" charset="-122"/>
                 <a:cs typeface="Calibri" pitchFamily="34" charset="-120"/>
               </a:rPr>
-              <a:t>Needs the baseline confound resolved, proper statistics, and more animals. Today is a strong foundation, not a result.</a:t>
+              <a:t>Needs more animals, up-conditioning controls, and statistics on the drift. One animal, one direction — a strong foundation, not a result.</a:t>
             </a:r>
             <a:endParaRPr lang="en-US" sz="1400" dirty="0"/>
           </a:p>
@@ -8468,7 +8777,7 @@
                 <a:ea typeface="Calibri" pitchFamily="34" charset="-122"/>
                 <a:cs typeface="Calibri" pitchFamily="34" charset="-120"/>
               </a:rPr>
-              <a:t>Setup + characterize the reflex</a:t>
+              <a:t>Before conditioning onset</a:t>
             </a:r>
             <a:endParaRPr lang="en-US" sz="1250" dirty="0"/>
           </a:p>
@@ -8541,7 +8850,7 @@
                 <a:ea typeface="Calibri" pitchFamily="34" charset="-122"/>
                 <a:cs typeface="Calibri" pitchFamily="34" charset="-120"/>
               </a:rPr>
-              <a:t>Down-conditioning</a:t>
+              <a:t>Down-cond early</a:t>
             </a:r>
             <a:endParaRPr lang="en-US" sz="1600" dirty="0"/>
           </a:p>
@@ -8580,7 +8889,7 @@
                 <a:ea typeface="Cambria" pitchFamily="34" charset="-122"/>
                 <a:cs typeface="Cambria" pitchFamily="34" charset="-120"/>
               </a:rPr>
-              <a:t>55,397</a:t>
+              <a:t>71,743</a:t>
             </a:r>
             <a:endParaRPr lang="en-US" sz="3400" dirty="0"/>
           </a:p>
@@ -8619,7 +8928,7 @@
                 <a:ea typeface="Calibri" pitchFamily="34" charset="-122"/>
                 <a:cs typeface="Calibri" pitchFamily="34" charset="-120"/>
               </a:rPr>
-              <a:t>Cord trained to shrink the reflex</a:t>
+              <a:t>Conditioning underway</a:t>
             </a:r>
             <a:endParaRPr lang="en-US" sz="1250" dirty="0"/>
           </a:p>
@@ -8692,7 +9001,7 @@
                 <a:ea typeface="Calibri" pitchFamily="34" charset="-122"/>
                 <a:cs typeface="Calibri" pitchFamily="34" charset="-120"/>
               </a:rPr>
-              <a:t>Post</a:t>
+              <a:t>Down-cond late</a:t>
             </a:r>
             <a:endParaRPr lang="en-US" sz="1600" dirty="0"/>
           </a:p>
@@ -8731,7 +9040,7 @@
                 <a:ea typeface="Cambria" pitchFamily="34" charset="-122"/>
                 <a:cs typeface="Cambria" pitchFamily="34" charset="-120"/>
               </a:rPr>
-              <a:t>78,854</a:t>
+              <a:t>62,508</a:t>
             </a:r>
             <a:endParaRPr lang="en-US" sz="3400" dirty="0"/>
           </a:p>
@@ -8770,7 +9079,7 @@
                 <a:ea typeface="Calibri" pitchFamily="34" charset="-122"/>
                 <a:cs typeface="Calibri" pitchFamily="34" charset="-120"/>
               </a:rPr>
-              <a:t>After conditioning stopped</a:t>
+              <a:t>Effect fully developed</a:t>
             </a:r>
             <a:endParaRPr lang="en-US" sz="1250" dirty="0"/>
           </a:p>
@@ -8838,7 +9147,7 @@
               <a:buNone/>
             </a:pPr>
             <a:r>
-              <a:rPr lang="en-US" sz="1450" b="1" dirty="0">
+              <a:rPr lang="en-US" sz="1400" b="1" dirty="0">
                 <a:solidFill>
                   <a:srgbClr val="6D28D9"/>
                 </a:solidFill>
@@ -8846,7 +9155,7 @@
                 <a:ea typeface="Calibri" pitchFamily="34" charset="-122"/>
                 <a:cs typeface="Calibri" pitchFamily="34" charset="-120"/>
               </a:rPr>
-              <a:t>Key detail:  </a:t>
+              <a:t>Corrected boundaries:  </a:t>
             </a:r>
             <a:pPr indent="0" marL="0">
               <a:lnSpc>
@@ -8855,7 +9164,7 @@
               <a:buNone/>
             </a:pPr>
             <a:r>
-              <a:rPr lang="en-US" sz="1450" dirty="0">
+              <a:rPr lang="en-US" sz="1400" dirty="0">
                 <a:solidFill>
                   <a:srgbClr val="1E293B"/>
                 </a:solidFill>
@@ -8863,9 +9172,9 @@
                 <a:ea typeface="Calibri" pitchFamily="34" charset="-122"/>
                 <a:cs typeface="Calibri" pitchFamily="34" charset="-120"/>
               </a:rPr>
-              <a:t>Animal 9 ran Baseline → Down-conditioning → Post — NOT the full 6-phase protocol. We verified the phase boundaries against the authoritative database schema, so these labels are trustworthy.</a:t>
-            </a:r>
-            <a:endParaRPr lang="en-US" sz="1450" dirty="0"/>
+              <a:t>the log's “stopped conditioning” note is misleading — the reflex keeps dropping long after it, so conditioning actually continued. We anchor the boundary on the documented conditioning ONSET and split early/late by time.</a:t>
+            </a:r>
+            <a:endParaRPr lang="en-US" sz="1400" dirty="0"/>
           </a:p>
         </p:txBody>
       </p:sp>
@@ -10184,7 +10493,7 @@
                 <a:ea typeface="Calibri" pitchFamily="34" charset="-122"/>
                 <a:cs typeface="Calibri" pitchFamily="34" charset="-120"/>
               </a:rPr>
-              <a:t>How much of the reflex's trial-to-trial change the fingerprint can explain. 0 = nothing, 1 = perfect. We get 0.17 — weak but real, above chance.</a:t>
+              <a:t>How much of the reflex the fingerprint can explain. 0 = nothing, 1 = perfect. After controlling for the stimulus it's ~0.04 — small but real.</a:t>
             </a:r>
             <a:endParaRPr lang="en-US" sz="1450" dirty="0"/>
           </a:p>
@@ -10412,7 +10721,7 @@
                 <a:ea typeface="Calibri" pitchFamily="34" charset="-122"/>
                 <a:cs typeface="Calibri" pitchFamily="34" charset="-120"/>
               </a:rPr>
-              <a:t>The catch</a:t>
+              <a:t>The M-wave control</a:t>
             </a:r>
             <a:endParaRPr lang="en-US" sz="1800" dirty="0"/>
           </a:p>
@@ -10454,7 +10763,7 @@
                 <a:ea typeface="Calibri" pitchFamily="34" charset="-122"/>
                 <a:cs typeface="Calibri" pitchFamily="34" charset="-120"/>
               </a:rPr>
-              <a:t>Some of that movement might come from the recording setup changing, not from learning. That's the one thing we still have to rule out.</a:t>
+              <a:t>The reflex depends on stimulus strength. We divide by (or remove) the M-wave everywhere, so we measure learning, not stimulus.</a:t>
             </a:r>
             <a:endParaRPr lang="en-US" sz="1450" dirty="0"/>
           </a:p>

</xml_diff>